<commit_message>
chore: otomatik kayit 2026-07-16 15:01
</commit_message>
<xml_diff>
--- a/presentations/Agentra_Tech_Takim_Tanitim_Sunum.pptx
+++ b/presentations/Agentra_Tech_Takim_Tanitim_Sunum.pptx
@@ -3866,8 +3866,8 @@
         </p:nvSpPr>
         <p:spPr>
           <a:xfrm>
-            <a:off x="859536" y="2962656"/>
-            <a:ext cx="3017520" cy="54864"/>
+            <a:off x="841248" y="2980944"/>
+            <a:ext cx="4526280" cy="54864"/>
           </a:xfrm>
           <a:prstGeom prst="rect">
             <a:avLst/>
@@ -4276,7 +4276,7 @@
         </p:nvSpPr>
         <p:spPr>
           <a:xfrm>
-            <a:off x="530352" y="621792"/>
+            <a:off x="566928" y="621792"/>
             <a:ext cx="11155680" cy="676656"/>
           </a:xfrm>
           <a:prstGeom prst="rect">
@@ -4318,8 +4318,8 @@
         </p:nvSpPr>
         <p:spPr>
           <a:xfrm>
-            <a:off x="585216" y="1353312"/>
-            <a:ext cx="960120" cy="64008"/>
+            <a:off x="576072" y="1371600"/>
+            <a:ext cx="4046220" cy="45720"/>
           </a:xfrm>
           <a:prstGeom prst="rect">
             <a:avLst/>
@@ -6945,7 +6945,7 @@
                 </a:solidFill>
                 <a:latin typeface="Segoe UI Semibold"/>
               </a:rPr>
-              <a:t>BIR BAKIŞTA</a:t>
+              <a:t>TAKIMIMIZ</a:t>
             </a:r>
           </a:p>
         </p:txBody>
@@ -6958,7 +6958,7 @@
         </p:nvSpPr>
         <p:spPr>
           <a:xfrm>
-            <a:off x="530352" y="621792"/>
+            <a:off x="566928" y="621792"/>
             <a:ext cx="11155680" cy="676656"/>
           </a:xfrm>
           <a:prstGeom prst="rect">
@@ -6987,7 +6987,7 @@
                 </a:solidFill>
                 <a:latin typeface="Segoe UI Semibold"/>
               </a:rPr>
-              <a:t>Takım Künyemiz</a:t>
+              <a:t>Kısaca Biz</a:t>
             </a:r>
           </a:p>
         </p:txBody>
@@ -7000,8 +7000,8 @@
         </p:nvSpPr>
         <p:spPr>
           <a:xfrm>
-            <a:off x="585216" y="1353312"/>
-            <a:ext cx="960120" cy="64008"/>
+            <a:off x="576072" y="1371600"/>
+            <a:ext cx="1769364" cy="45720"/>
           </a:xfrm>
           <a:prstGeom prst="rect">
             <a:avLst/>
@@ -8057,6 +8057,15 @@
               </a:spcAft>
             </a:pPr>
             <a:r>
+              <a:rPr sz="1550" b="0">
+                <a:solidFill>
+                  <a:srgbClr val="1A2233"/>
+                </a:solidFill>
+                <a:latin typeface="Segoe UI"/>
+              </a:rPr>
+              <a:t>Biz </a:t>
+            </a:r>
+            <a:r>
               <a:rPr sz="1600" b="1">
                 <a:solidFill>
                   <a:srgbClr val="1A2233"/>
@@ -8072,7 +8081,7 @@
                 </a:solidFill>
                 <a:latin typeface="Segoe UI"/>
               </a:rPr>
-              <a:t> — TEKNOFEST 2026 Yapay Zeka Dil Ajanları Yarışması 1. Senaryo için kurulmuş, </a:t>
+              <a:t>; TEKNOFEST 2026 için bir araya gelen, </a:t>
             </a:r>
             <a:r>
               <a:rPr sz="1550" b="1">
@@ -8081,7 +8090,7 @@
                 </a:solidFill>
                 <a:latin typeface="Segoe UI Semibold"/>
               </a:rPr>
-              <a:t>Türkçe dil teknolojileri ve akıllı ajan sistemlerine</a:t>
+              <a:t>Türkçe dil teknolojileri ve akıllı ajan sistemleri</a:t>
             </a:r>
             <a:r>
               <a:rPr sz="1550" b="0">
@@ -8090,7 +8099,7 @@
                 </a:solidFill>
                 <a:latin typeface="Segoe UI"/>
               </a:rPr>
-              <a:t> odaklı 4 kişilik öğrenci takımı.</a:t>
+              <a:t> üzerine çalışan 4 kişilik bir öğrenci takımıyız.</a:t>
             </a:r>
           </a:p>
           <a:p>
@@ -8109,7 +8118,7 @@
                 </a:solidFill>
                 <a:latin typeface="Segoe UI"/>
               </a:rPr>
-              <a:t>Kimliğimizin merkezinde “agent” odağı vardır: her kararı izlenebilir, açık kaynak bir çözüm.</a:t>
+              <a:t>Adımızın merkezinde “agent” var: kararları izlenebilir, tamamen açık kaynak bir sistem geliştiriyoruz.</a:t>
             </a:r>
           </a:p>
         </p:txBody>
@@ -8960,7 +8969,7 @@
         </p:nvSpPr>
         <p:spPr>
           <a:xfrm>
-            <a:off x="530352" y="621792"/>
+            <a:off x="566928" y="621792"/>
             <a:ext cx="11155680" cy="676656"/>
           </a:xfrm>
           <a:prstGeom prst="rect">
@@ -9002,8 +9011,8 @@
         </p:nvSpPr>
         <p:spPr>
           <a:xfrm>
-            <a:off x="585216" y="1353312"/>
-            <a:ext cx="960120" cy="64008"/>
+            <a:off x="576072" y="1371600"/>
+            <a:ext cx="6652260" cy="45720"/>
           </a:xfrm>
           <a:prstGeom prst="rect">
             <a:avLst/>
@@ -10494,7 +10503,7 @@
         </p:nvSpPr>
         <p:spPr>
           <a:xfrm>
-            <a:off x="530352" y="621792"/>
+            <a:off x="566928" y="621792"/>
             <a:ext cx="11155680" cy="676656"/>
           </a:xfrm>
           <a:prstGeom prst="rect">
@@ -10536,8 +10545,8 @@
         </p:nvSpPr>
         <p:spPr>
           <a:xfrm>
-            <a:off x="585216" y="1353312"/>
-            <a:ext cx="960120" cy="64008"/>
+            <a:off x="576072" y="1371600"/>
+            <a:ext cx="4169664" cy="45720"/>
           </a:xfrm>
           <a:prstGeom prst="rect">
             <a:avLst/>
@@ -12332,7 +12341,7 @@
         </p:nvSpPr>
         <p:spPr>
           <a:xfrm>
-            <a:off x="530352" y="621792"/>
+            <a:off x="566928" y="621792"/>
             <a:ext cx="11155680" cy="676656"/>
           </a:xfrm>
           <a:prstGeom prst="rect">
@@ -12374,8 +12383,8 @@
         </p:nvSpPr>
         <p:spPr>
           <a:xfrm>
-            <a:off x="585216" y="1353312"/>
-            <a:ext cx="960120" cy="64008"/>
+            <a:off x="576072" y="1371600"/>
+            <a:ext cx="5417820" cy="45720"/>
           </a:xfrm>
           <a:prstGeom prst="rect">
             <a:avLst/>
@@ -14090,7 +14099,7 @@
         </p:nvSpPr>
         <p:spPr>
           <a:xfrm>
-            <a:off x="530352" y="621792"/>
+            <a:off x="566928" y="621792"/>
             <a:ext cx="11155680" cy="676656"/>
           </a:xfrm>
           <a:prstGeom prst="rect">
@@ -14132,8 +14141,8 @@
         </p:nvSpPr>
         <p:spPr>
           <a:xfrm>
-            <a:off x="585216" y="1353312"/>
-            <a:ext cx="960120" cy="64008"/>
+            <a:off x="576072" y="1371600"/>
+            <a:ext cx="5843016" cy="45720"/>
           </a:xfrm>
           <a:prstGeom prst="rect">
             <a:avLst/>
@@ -16576,7 +16585,7 @@
         </p:nvSpPr>
         <p:spPr>
           <a:xfrm>
-            <a:off x="530352" y="621792"/>
+            <a:off x="566928" y="621792"/>
             <a:ext cx="11155680" cy="676656"/>
           </a:xfrm>
           <a:prstGeom prst="rect">
@@ -16618,8 +16627,8 @@
         </p:nvSpPr>
         <p:spPr>
           <a:xfrm>
-            <a:off x="585216" y="1353312"/>
-            <a:ext cx="960120" cy="64008"/>
+            <a:off x="576072" y="1371600"/>
+            <a:ext cx="3127248" cy="45720"/>
           </a:xfrm>
           <a:prstGeom prst="rect">
             <a:avLst/>
@@ -18175,7 +18184,7 @@
         </p:nvSpPr>
         <p:spPr>
           <a:xfrm>
-            <a:off x="530352" y="621792"/>
+            <a:off x="566928" y="621792"/>
             <a:ext cx="11155680" cy="676656"/>
           </a:xfrm>
           <a:prstGeom prst="rect">
@@ -18217,8 +18226,8 @@
         </p:nvSpPr>
         <p:spPr>
           <a:xfrm>
-            <a:off x="585216" y="1353312"/>
-            <a:ext cx="960120" cy="64008"/>
+            <a:off x="576072" y="1371600"/>
+            <a:ext cx="3223260" cy="45720"/>
           </a:xfrm>
           <a:prstGeom prst="rect">
             <a:avLst/>
@@ -19689,7 +19698,7 @@
         </p:nvSpPr>
         <p:spPr>
           <a:xfrm>
-            <a:off x="530352" y="621792"/>
+            <a:off x="566928" y="621792"/>
             <a:ext cx="11155680" cy="676656"/>
           </a:xfrm>
           <a:prstGeom prst="rect">
@@ -19731,8 +19740,8 @@
         </p:nvSpPr>
         <p:spPr>
           <a:xfrm>
-            <a:off x="585216" y="1353312"/>
-            <a:ext cx="960120" cy="64008"/>
+            <a:off x="576072" y="1371600"/>
+            <a:ext cx="4553712" cy="45720"/>
           </a:xfrm>
           <a:prstGeom prst="rect">
             <a:avLst/>

</xml_diff>

<commit_message>
chore: otomatik kayit 2026-07-16 17:55
</commit_message>
<xml_diff>
--- a/presentations/Agentra_Tech_Takim_Tanitim_Sunum.pptx
+++ b/presentations/Agentra_Tech_Takim_Tanitim_Sunum.pptx
@@ -6677,68 +6677,36 @@
           </a:p>
         </p:txBody>
       </p:sp>
-      <p:sp>
-        <p:nvSpPr>
-          <p:cNvPr id="7" name="Oval 6"/>
-          <p:cNvSpPr/>
-          <p:nvPr/>
-        </p:nvSpPr>
-        <p:spPr>
-          <a:xfrm>
-            <a:off x="859536" y="1901952"/>
-            <a:ext cx="786384" cy="786384"/>
-          </a:xfrm>
-          <a:prstGeom prst="ellipse">
-            <a:avLst/>
-          </a:prstGeom>
-          <a:solidFill>
-            <a:srgbClr val="2E323B"/>
-          </a:solidFill>
-          <a:ln w="15875">
+      <p:pic>
+        <p:nvPicPr>
+          <p:cNvPr id="7" name="Picture 6" descr="foto_seyma.png"/>
+          <p:cNvPicPr>
+            <a:picLocks noChangeAspect="1"/>
+          </p:cNvPicPr>
+          <p:nvPr/>
+        </p:nvPicPr>
+        <p:blipFill>
+          <a:blip r:embed="rId3"/>
+          <a:stretch>
+            <a:fillRect/>
+          </a:stretch>
+        </p:blipFill>
+        <p:spPr>
+          <a:xfrm>
+            <a:off x="877824" y="1901952"/>
+            <a:ext cx="783980" cy="1133856"/>
+          </a:xfrm>
+          <a:prstGeom prst="rect">
+            <a:avLst/>
+          </a:prstGeom>
+          <a:ln w="9525">
             <a:solidFill>
-              <a:srgbClr val="C9CDD4"/>
+              <a:srgbClr val="5B616B"/>
             </a:solidFill>
           </a:ln>
           <a:effectLst/>
         </p:spPr>
-        <p:style>
-          <a:lnRef idx="1">
-            <a:schemeClr val="accent1"/>
-          </a:lnRef>
-          <a:fillRef idx="3">
-            <a:schemeClr val="accent1"/>
-          </a:fillRef>
-          <a:effectRef idx="2">
-            <a:schemeClr val="accent1"/>
-          </a:effectRef>
-          <a:fontRef idx="minor">
-            <a:schemeClr val="lt1"/>
-          </a:fontRef>
-        </p:style>
-        <p:txBody>
-          <a:bodyPr rtlCol="0" anchor="ctr" wrap="square" lIns="76200" rIns="76200" tIns="38100" bIns="38100"/>
-          <a:lstStyle/>
-          <a:p>
-            <a:pPr algn="ctr">
-              <a:spcBef>
-                <a:spcPts val="0"/>
-              </a:spcBef>
-              <a:spcAft>
-                <a:spcPts val="0"/>
-              </a:spcAft>
-            </a:pPr>
-            <a:r>
-              <a:rPr sz="2500" b="0">
-                <a:solidFill>
-                  <a:srgbClr val="C9CDD4"/>
-                </a:solidFill>
-                <a:latin typeface="Segoe UI Semibold"/>
-              </a:rPr>
-              <a:t>Ş</a:t>
-            </a:r>
-          </a:p>
-        </p:txBody>
-      </p:sp>
+      </p:pic>
       <p:sp>
         <p:nvSpPr>
           <p:cNvPr id="8" name="TextBox 7"/>
@@ -7086,68 +7054,36 @@
           </a:p>
         </p:txBody>
       </p:sp>
-      <p:sp>
-        <p:nvSpPr>
-          <p:cNvPr id="15" name="Oval 14"/>
-          <p:cNvSpPr/>
-          <p:nvPr/>
-        </p:nvSpPr>
-        <p:spPr>
-          <a:xfrm>
-            <a:off x="6437376" y="1901952"/>
-            <a:ext cx="786384" cy="786384"/>
-          </a:xfrm>
-          <a:prstGeom prst="ellipse">
-            <a:avLst/>
-          </a:prstGeom>
-          <a:solidFill>
-            <a:srgbClr val="2E323B"/>
-          </a:solidFill>
-          <a:ln w="15875">
+      <p:pic>
+        <p:nvPicPr>
+          <p:cNvPr id="15" name="Picture 14" descr="foto_sina.png"/>
+          <p:cNvPicPr>
+            <a:picLocks noChangeAspect="1"/>
+          </p:cNvPicPr>
+          <p:nvPr/>
+        </p:nvPicPr>
+        <p:blipFill>
+          <a:blip r:embed="rId4"/>
+          <a:stretch>
+            <a:fillRect/>
+          </a:stretch>
+        </p:blipFill>
+        <p:spPr>
+          <a:xfrm>
+            <a:off x="6455664" y="1901952"/>
+            <a:ext cx="798559" cy="1133856"/>
+          </a:xfrm>
+          <a:prstGeom prst="rect">
+            <a:avLst/>
+          </a:prstGeom>
+          <a:ln w="9525">
             <a:solidFill>
-              <a:srgbClr val="C9CDD4"/>
+              <a:srgbClr val="5B616B"/>
             </a:solidFill>
           </a:ln>
           <a:effectLst/>
         </p:spPr>
-        <p:style>
-          <a:lnRef idx="1">
-            <a:schemeClr val="accent1"/>
-          </a:lnRef>
-          <a:fillRef idx="3">
-            <a:schemeClr val="accent1"/>
-          </a:fillRef>
-          <a:effectRef idx="2">
-            <a:schemeClr val="accent1"/>
-          </a:effectRef>
-          <a:fontRef idx="minor">
-            <a:schemeClr val="lt1"/>
-          </a:fontRef>
-        </p:style>
-        <p:txBody>
-          <a:bodyPr rtlCol="0" anchor="ctr" wrap="square" lIns="76200" rIns="76200" tIns="38100" bIns="38100"/>
-          <a:lstStyle/>
-          <a:p>
-            <a:pPr algn="ctr">
-              <a:spcBef>
-                <a:spcPts val="0"/>
-              </a:spcBef>
-              <a:spcAft>
-                <a:spcPts val="0"/>
-              </a:spcAft>
-            </a:pPr>
-            <a:r>
-              <a:rPr sz="2500" b="0">
-                <a:solidFill>
-                  <a:srgbClr val="C9CDD4"/>
-                </a:solidFill>
-                <a:latin typeface="Segoe UI Semibold"/>
-              </a:rPr>
-              <a:t>M</a:t>
-            </a:r>
-          </a:p>
-        </p:txBody>
-      </p:sp>
+      </p:pic>
       <p:sp>
         <p:nvSpPr>
           <p:cNvPr id="16" name="TextBox 15"/>
@@ -7433,68 +7369,36 @@
           </a:p>
         </p:txBody>
       </p:sp>
-      <p:sp>
-        <p:nvSpPr>
-          <p:cNvPr id="22" name="Oval 21"/>
-          <p:cNvSpPr/>
-          <p:nvPr/>
-        </p:nvSpPr>
-        <p:spPr>
-          <a:xfrm>
-            <a:off x="859536" y="4169664"/>
-            <a:ext cx="786384" cy="786384"/>
-          </a:xfrm>
-          <a:prstGeom prst="ellipse">
-            <a:avLst/>
-          </a:prstGeom>
-          <a:solidFill>
-            <a:srgbClr val="2E323B"/>
-          </a:solidFill>
-          <a:ln w="15875">
+      <p:pic>
+        <p:nvPicPr>
+          <p:cNvPr id="22" name="Picture 21" descr="foto_emine.png"/>
+          <p:cNvPicPr>
+            <a:picLocks noChangeAspect="1"/>
+          </p:cNvPicPr>
+          <p:nvPr/>
+        </p:nvPicPr>
+        <p:blipFill>
+          <a:blip r:embed="rId5"/>
+          <a:stretch>
+            <a:fillRect/>
+          </a:stretch>
+        </p:blipFill>
+        <p:spPr>
+          <a:xfrm>
+            <a:off x="877824" y="4169664"/>
+            <a:ext cx="745105" cy="1133856"/>
+          </a:xfrm>
+          <a:prstGeom prst="rect">
+            <a:avLst/>
+          </a:prstGeom>
+          <a:ln w="9525">
             <a:solidFill>
-              <a:srgbClr val="C9CDD4"/>
+              <a:srgbClr val="5B616B"/>
             </a:solidFill>
           </a:ln>
           <a:effectLst/>
         </p:spPr>
-        <p:style>
-          <a:lnRef idx="1">
-            <a:schemeClr val="accent1"/>
-          </a:lnRef>
-          <a:fillRef idx="3">
-            <a:schemeClr val="accent1"/>
-          </a:fillRef>
-          <a:effectRef idx="2">
-            <a:schemeClr val="accent1"/>
-          </a:effectRef>
-          <a:fontRef idx="minor">
-            <a:schemeClr val="lt1"/>
-          </a:fontRef>
-        </p:style>
-        <p:txBody>
-          <a:bodyPr rtlCol="0" anchor="ctr" wrap="square" lIns="76200" rIns="76200" tIns="38100" bIns="38100"/>
-          <a:lstStyle/>
-          <a:p>
-            <a:pPr algn="ctr">
-              <a:spcBef>
-                <a:spcPts val="0"/>
-              </a:spcBef>
-              <a:spcAft>
-                <a:spcPts val="0"/>
-              </a:spcAft>
-            </a:pPr>
-            <a:r>
-              <a:rPr sz="2500" b="0">
-                <a:solidFill>
-                  <a:srgbClr val="C9CDD4"/>
-                </a:solidFill>
-                <a:latin typeface="Segoe UI Semibold"/>
-              </a:rPr>
-              <a:t>E</a:t>
-            </a:r>
-          </a:p>
-        </p:txBody>
-      </p:sp>
+      </p:pic>
       <p:sp>
         <p:nvSpPr>
           <p:cNvPr id="23" name="TextBox 22"/>
@@ -7780,68 +7684,36 @@
           </a:p>
         </p:txBody>
       </p:sp>
-      <p:sp>
-        <p:nvSpPr>
-          <p:cNvPr id="29" name="Oval 28"/>
-          <p:cNvSpPr/>
-          <p:nvPr/>
-        </p:nvSpPr>
-        <p:spPr>
-          <a:xfrm>
-            <a:off x="6437376" y="4169664"/>
-            <a:ext cx="786384" cy="786384"/>
-          </a:xfrm>
-          <a:prstGeom prst="ellipse">
-            <a:avLst/>
-          </a:prstGeom>
-          <a:solidFill>
-            <a:srgbClr val="2E323B"/>
-          </a:solidFill>
-          <a:ln w="15875">
+      <p:pic>
+        <p:nvPicPr>
+          <p:cNvPr id="29" name="Picture 28" descr="foto_zeynep.png"/>
+          <p:cNvPicPr>
+            <a:picLocks noChangeAspect="1"/>
+          </p:cNvPicPr>
+          <p:nvPr/>
+        </p:nvPicPr>
+        <p:blipFill>
+          <a:blip r:embed="rId6"/>
+          <a:stretch>
+            <a:fillRect/>
+          </a:stretch>
+        </p:blipFill>
+        <p:spPr>
+          <a:xfrm>
+            <a:off x="6455664" y="4169664"/>
+            <a:ext cx="594465" cy="1133856"/>
+          </a:xfrm>
+          <a:prstGeom prst="rect">
+            <a:avLst/>
+          </a:prstGeom>
+          <a:ln w="9525">
             <a:solidFill>
-              <a:srgbClr val="C9CDD4"/>
+              <a:srgbClr val="5B616B"/>
             </a:solidFill>
           </a:ln>
           <a:effectLst/>
         </p:spPr>
-        <p:style>
-          <a:lnRef idx="1">
-            <a:schemeClr val="accent1"/>
-          </a:lnRef>
-          <a:fillRef idx="3">
-            <a:schemeClr val="accent1"/>
-          </a:fillRef>
-          <a:effectRef idx="2">
-            <a:schemeClr val="accent1"/>
-          </a:effectRef>
-          <a:fontRef idx="minor">
-            <a:schemeClr val="lt1"/>
-          </a:fontRef>
-        </p:style>
-        <p:txBody>
-          <a:bodyPr rtlCol="0" anchor="ctr" wrap="square" lIns="76200" rIns="76200" tIns="38100" bIns="38100"/>
-          <a:lstStyle/>
-          <a:p>
-            <a:pPr algn="ctr">
-              <a:spcBef>
-                <a:spcPts val="0"/>
-              </a:spcBef>
-              <a:spcAft>
-                <a:spcPts val="0"/>
-              </a:spcAft>
-            </a:pPr>
-            <a:r>
-              <a:rPr sz="2500" b="0">
-                <a:solidFill>
-                  <a:srgbClr val="C9CDD4"/>
-                </a:solidFill>
-                <a:latin typeface="Segoe UI Semibold"/>
-              </a:rPr>
-              <a:t>Z</a:t>
-            </a:r>
-          </a:p>
-        </p:txBody>
-      </p:sp>
+      </p:pic>
       <p:sp>
         <p:nvSpPr>
           <p:cNvPr id="30" name="TextBox 29"/>

</xml_diff>

<commit_message>
chore: otomatik kayit 2026-07-16 21:35
</commit_message>
<xml_diff>
--- a/presentations/Agentra_Tech_Takim_Tanitim_Sunum.pptx
+++ b/presentations/Agentra_Tech_Takim_Tanitim_Sunum.pptx
@@ -4956,7 +4956,7 @@
                 </a:solidFill>
                 <a:latin typeface="Segoe UI Semibold"/>
               </a:rPr>
-              <a:t>Türkçe dil teknolojileri ve akıllı ajan sistemleri</a:t>
+              <a:t>akıllı ajan sistemleri</a:t>
             </a:r>
             <a:r>
               <a:rPr sz="1600" b="0">
@@ -6863,8 +6863,8 @@
         </p:nvSpPr>
         <p:spPr>
           <a:xfrm>
-            <a:off x="877824" y="3090672"/>
-            <a:ext cx="4919472" cy="566928"/>
+            <a:off x="877824" y="3017520"/>
+            <a:ext cx="4956048" cy="658368"/>
           </a:xfrm>
           <a:prstGeom prst="rect">
             <a:avLst/>
@@ -6879,7 +6879,7 @@
           <a:p>
             <a:pPr algn="l">
               <a:lnSpc>
-                <a:spcPct val="106000"/>
+                <a:spcPct val="105000"/>
               </a:lnSpc>
               <a:spcBef>
                 <a:spcPts val="0"/>
@@ -6889,13 +6889,13 @@
               </a:spcAft>
             </a:pPr>
             <a:r>
-              <a:rPr sz="1250" b="0">
+              <a:rPr sz="1150" b="0">
                 <a:solidFill>
                   <a:srgbClr val="989EA8"/>
                 </a:solidFill>
                 <a:latin typeface="Segoe UI"/>
               </a:rPr>
-              <a:t>Görev 1 içerik analizi: sınıflandırma, bilgi çıkarımı, mevzuat RAG; değerlendirme ve entegrasyon.</a:t>
+              <a:t>Görev 1 içerik analizi hattı: tür sınıflandırma, bilgi çıkarımı ve BM25 tabanlı mevzuat önerisi (RAG). Değerlendirme metrikleri ve uçtan uca entegrasyon; kaptan olarak ekip koordinasyonu.</a:t>
             </a:r>
           </a:p>
         </p:txBody>
@@ -7240,8 +7240,8 @@
         </p:nvSpPr>
         <p:spPr>
           <a:xfrm>
-            <a:off x="6455664" y="3090672"/>
-            <a:ext cx="4919472" cy="566928"/>
+            <a:off x="6455664" y="3017520"/>
+            <a:ext cx="4956048" cy="658368"/>
           </a:xfrm>
           <a:prstGeom prst="rect">
             <a:avLst/>
@@ -7256,7 +7256,7 @@
           <a:p>
             <a:pPr algn="l">
               <a:lnSpc>
-                <a:spcPct val="106000"/>
+                <a:spcPct val="105000"/>
               </a:lnSpc>
               <a:spcBef>
                 <a:spcPts val="0"/>
@@ -7266,13 +7266,13 @@
               </a:spcAft>
             </a:pPr>
             <a:r>
-              <a:rPr sz="1250" b="0">
+              <a:rPr sz="1150" b="0">
                 <a:solidFill>
                   <a:srgbClr val="989EA8"/>
                 </a:solidFill>
                 <a:latin typeface="Segoe UI"/>
               </a:rPr>
-              <a:t>Mimari ve orkestrasyon; model-agnostik LLM katmanı; Görev 2 taslak üretimi (OCR, özet).</a:t>
+              <a:t>Sistem mimarisi ve orkestratör tasarımı; model-agnostik LLM katmanı (offline/çevrimiçi otomatik tespit). OCR ve özetleme ajanları; Görev 2 resmî yazı taslağı ve format öz-denetimi.</a:t>
             </a:r>
           </a:p>
         </p:txBody>
@@ -7555,8 +7555,8 @@
         </p:nvSpPr>
         <p:spPr>
           <a:xfrm>
-            <a:off x="877824" y="5358384"/>
-            <a:ext cx="4919472" cy="566928"/>
+            <a:off x="877824" y="5285232"/>
+            <a:ext cx="4956048" cy="658368"/>
           </a:xfrm>
           <a:prstGeom prst="rect">
             <a:avLst/>
@@ -7571,7 +7571,7 @@
           <a:p>
             <a:pPr algn="l">
               <a:lnSpc>
-                <a:spcPct val="106000"/>
+                <a:spcPct val="105000"/>
               </a:lnSpc>
               <a:spcBef>
                 <a:spcPts val="0"/>
@@ -7581,13 +7581,13 @@
               </a:spcAft>
             </a:pPr>
             <a:r>
-              <a:rPr sz="1250" b="0">
+              <a:rPr sz="1150" b="0">
                 <a:solidFill>
                   <a:srgbClr val="989EA8"/>
                 </a:solidFill>
                 <a:latin typeface="Segoe UI"/>
               </a:rPr>
-              <a:t>Veri seti ve etiketleme; test kapsamı; dokümantasyon; sunum ve demo; şartname uyumu.</a:t>
+              <a:t>Sentetik kurgu evrak veri setleri ve etiketleme; 500+ otomatik testle kapsam güvencesi; teknik rapor ve dokümantasyon; sunum ve demo hazırlığı; TEKNOFEST şartname uyum takibi.</a:t>
             </a:r>
           </a:p>
         </p:txBody>
@@ -7870,8 +7870,8 @@
         </p:nvSpPr>
         <p:spPr>
           <a:xfrm>
-            <a:off x="6455664" y="5358384"/>
-            <a:ext cx="4919472" cy="566928"/>
+            <a:off x="6455664" y="5285232"/>
+            <a:ext cx="4956048" cy="658368"/>
           </a:xfrm>
           <a:prstGeom prst="rect">
             <a:avLst/>
@@ -7886,7 +7886,7 @@
           <a:p>
             <a:pPr algn="l">
               <a:lnSpc>
-                <a:spcPct val="106000"/>
+                <a:spcPct val="105000"/>
               </a:lnSpc>
               <a:spcBef>
                 <a:spcPts val="0"/>
@@ -7896,13 +7896,13 @@
               </a:spcAft>
             </a:pPr>
             <a:r>
-              <a:rPr sz="1250" b="0">
+              <a:rPr sz="1150" b="0">
                 <a:solidFill>
                   <a:srgbClr val="989EA8"/>
                 </a:solidFill>
                 <a:latin typeface="Segoe UI"/>
               </a:rPr>
-              <a:t>Görev 1 eksik bilgi; Görev 2 yönlendirme ve kullanıcı etkileşimi; triyaj, KVKK; web arayüzü.</a:t>
+              <a:t>Görev 1 eksik bilgi tespiti; Görev 2 birim yönlendirme, kullanıcı bilgilendirme ve eksik bilgi talebi. Önceliklendirme/triyaj, KVKK maskeleme ve web arayüzü.</a:t>
             </a:r>
           </a:p>
         </p:txBody>
@@ -10212,8 +10212,8 @@
         </p:nvSpPr>
         <p:spPr>
           <a:xfrm>
-            <a:off x="566928" y="5468112"/>
-            <a:ext cx="10972800" cy="365760"/>
+            <a:off x="566928" y="5431536"/>
+            <a:ext cx="11055096" cy="822960"/>
           </a:xfrm>
           <a:prstGeom prst="rect">
             <a:avLst/>
@@ -10227,6 +10227,9 @@
           <a:lstStyle/>
           <a:p>
             <a:pPr algn="l">
+              <a:lnSpc>
+                <a:spcPct val="118000"/>
+              </a:lnSpc>
               <a:spcBef>
                 <a:spcPts val="0"/>
               </a:spcBef>
@@ -10235,13 +10238,85 @@
               </a:spcAft>
             </a:pPr>
             <a:r>
-              <a:rPr sz="1200" b="0">
+              <a:rPr sz="1150" b="0">
                 <a:solidFill>
                   <a:srgbClr val="989EA8"/>
                 </a:solidFill>
                 <a:latin typeface="Segoe UI"/>
               </a:rPr>
-              <a:t>Her yetenek bir sorumluya ve gerçek bir kod modülüne bağlıdır.</a:t>
+              <a:t>Her yetenek bir sorumluya ve gerçek bir kod modülüne (11 uzman ajan + orkestratör) bağlıdır.  </a:t>
+            </a:r>
+            <a:r>
+              <a:rPr sz="1150" b="0">
+                <a:solidFill>
+                  <a:srgbClr val="C9CDD4"/>
+                </a:solidFill>
+                <a:latin typeface="Segoe UI Semibold"/>
+              </a:rPr>
+              <a:t>Şeyma Nur</a:t>
+            </a:r>
+            <a:r>
+              <a:rPr sz="1150" b="0">
+                <a:solidFill>
+                  <a:srgbClr val="989EA8"/>
+                </a:solidFill>
+                <a:latin typeface="Segoe UI"/>
+              </a:rPr>
+              <a:t> içerik analizi + koordinasyon/entegrasyon · </a:t>
+            </a:r>
+            <a:r>
+              <a:rPr sz="1150" b="0">
+                <a:solidFill>
+                  <a:srgbClr val="C9CDD4"/>
+                </a:solidFill>
+                <a:latin typeface="Segoe UI Semibold"/>
+              </a:rPr>
+              <a:t>Sina</a:t>
+            </a:r>
+            <a:r>
+              <a:rPr sz="1150" b="0">
+                <a:solidFill>
+                  <a:srgbClr val="989EA8"/>
+                </a:solidFill>
+                <a:latin typeface="Segoe UI"/>
+              </a:rPr>
+              <a:t> mimari, OCR, özet, taslak · </a:t>
+            </a:r>
+            <a:r>
+              <a:rPr sz="1150" b="0">
+                <a:solidFill>
+                  <a:srgbClr val="C9CDD4"/>
+                </a:solidFill>
+                <a:latin typeface="Segoe UI Semibold"/>
+              </a:rPr>
+              <a:t>Zeynep</a:t>
+            </a:r>
+            <a:r>
+              <a:rPr sz="1150" b="0">
+                <a:solidFill>
+                  <a:srgbClr val="989EA8"/>
+                </a:solidFill>
+                <a:latin typeface="Segoe UI"/>
+              </a:rPr>
+              <a:t> eksik bilgi, yönlendirme, etkileşim, KVKK · </a:t>
+            </a:r>
+            <a:r>
+              <a:rPr sz="1150" b="0">
+                <a:solidFill>
+                  <a:srgbClr val="C9CDD4"/>
+                </a:solidFill>
+                <a:latin typeface="Segoe UI Semibold"/>
+              </a:rPr>
+              <a:t>Emine</a:t>
+            </a:r>
+            <a:r>
+              <a:rPr sz="1150" b="0">
+                <a:solidFill>
+                  <a:srgbClr val="989EA8"/>
+                </a:solidFill>
+                <a:latin typeface="Segoe UI"/>
+              </a:rPr>
+              <a:t> veri, test, doküman altyapısı.</a:t>
             </a:r>
           </a:p>
         </p:txBody>

</xml_diff>

<commit_message>
chore: otomatik kayit 2026-07-16 22:56
</commit_message>
<xml_diff>
--- a/presentations/Agentra_Tech_Takim_Tanitim_Sunum.pptx
+++ b/presentations/Agentra_Tech_Takim_Tanitim_Sunum.pptx
@@ -5,18 +5,18 @@
     <p:sldMasterId id="2147483648" r:id="rId1"/>
   </p:sldMasterIdLst>
   <p:sldIdLst>
-    <p:sldId id="256" r:id="rId7"/>
-    <p:sldId id="257" r:id="rId8"/>
-    <p:sldId id="258" r:id="rId9"/>
-    <p:sldId id="259" r:id="rId10"/>
-    <p:sldId id="260" r:id="rId11"/>
-    <p:sldId id="261" r:id="rId12"/>
-    <p:sldId id="262" r:id="rId13"/>
-    <p:sldId id="263" r:id="rId14"/>
-    <p:sldId id="264" r:id="rId15"/>
-    <p:sldId id="265" r:id="rId16"/>
+    <p:sldId id="256" r:id="rId2"/>
+    <p:sldId id="257" r:id="rId3"/>
+    <p:sldId id="258" r:id="rId4"/>
+    <p:sldId id="259" r:id="rId5"/>
+    <p:sldId id="260" r:id="rId6"/>
+    <p:sldId id="261" r:id="rId7"/>
+    <p:sldId id="262" r:id="rId8"/>
+    <p:sldId id="263" r:id="rId9"/>
+    <p:sldId id="264" r:id="rId10"/>
+    <p:sldId id="265" r:id="rId11"/>
   </p:sldIdLst>
-  <p:sldSz cx="12191695" cy="6858000" type="screen4x3"/>
+  <p:sldSz cx="12192000" cy="6858000"/>
   <p:notesSz cx="6858000" cy="9144000"/>
   <p:defaultTextStyle>
     <a:defPPr>
@@ -113,6 +113,22 @@
       </a:defRPr>
     </a:lvl9pPr>
   </p:defaultTextStyle>
+  <p:extLst>
+    <p:ext uri="{EFAFB233-063F-42B5-8137-9DF3F51BA10A}">
+      <p15:sldGuideLst xmlns:p15="http://schemas.microsoft.com/office/powerpoint/2012/main">
+        <p15:guide id="1" orient="horz" pos="2160">
+          <p15:clr>
+            <a:srgbClr val="A4A3A4"/>
+          </p15:clr>
+        </p15:guide>
+        <p15:guide id="2" pos="2880">
+          <p15:clr>
+            <a:srgbClr val="A4A3A4"/>
+          </p15:clr>
+        </p15:guide>
+      </p15:sldGuideLst>
+    </p:ext>
+  </p:extLst>
 </p:presentation>
 </file>
 
@@ -154,10 +170,9 @@
           <a:lstStyle/>
           <a:p>
             <a:r>
-              <a:rPr lang="en-US" smtClean="0"/>
+              <a:rPr lang="en-US"/>
               <a:t>Click to edit Master title style</a:t>
             </a:r>
-            <a:endParaRPr lang="en-US"/>
           </a:p>
         </p:txBody>
       </p:sp>
@@ -273,10 +288,9 @@
           </a:lstStyle>
           <a:p>
             <a:r>
-              <a:rPr lang="en-US" smtClean="0"/>
+              <a:rPr lang="en-US"/>
               <a:t>Click to edit Master subtitle style</a:t>
             </a:r>
-            <a:endParaRPr lang="en-US"/>
           </a:p>
         </p:txBody>
       </p:sp>
@@ -297,7 +311,7 @@
           <a:p>
             <a:fld id="{5BCAD085-E8A6-8845-BD4E-CB4CCA059FC4}" type="datetimeFigureOut">
               <a:rPr lang="en-US" smtClean="0"/>
-              <a:t>1/27/13</a:t>
+              <a:t>7/16/2026</a:t>
             </a:fld>
             <a:endParaRPr lang="en-US"/>
           </a:p>
@@ -391,10 +405,9 @@
           <a:lstStyle/>
           <a:p>
             <a:r>
-              <a:rPr lang="en-US" smtClean="0"/>
+              <a:rPr lang="en-US"/>
               <a:t>Click to edit Master title style</a:t>
             </a:r>
-            <a:endParaRPr lang="en-US"/>
           </a:p>
         </p:txBody>
       </p:sp>
@@ -415,38 +428,37 @@
           <a:p>
             <a:pPr lvl="0"/>
             <a:r>
-              <a:rPr lang="en-US" smtClean="0"/>
+              <a:rPr lang="en-US"/>
               <a:t>Click to edit Master text styles</a:t>
             </a:r>
           </a:p>
           <a:p>
             <a:pPr lvl="1"/>
             <a:r>
-              <a:rPr lang="en-US" smtClean="0"/>
+              <a:rPr lang="en-US"/>
               <a:t>Second level</a:t>
             </a:r>
           </a:p>
           <a:p>
             <a:pPr lvl="2"/>
             <a:r>
-              <a:rPr lang="en-US" smtClean="0"/>
+              <a:rPr lang="en-US"/>
               <a:t>Third level</a:t>
             </a:r>
           </a:p>
           <a:p>
             <a:pPr lvl="3"/>
             <a:r>
-              <a:rPr lang="en-US" smtClean="0"/>
+              <a:rPr lang="en-US"/>
               <a:t>Fourth level</a:t>
             </a:r>
           </a:p>
           <a:p>
             <a:pPr lvl="4"/>
             <a:r>
-              <a:rPr lang="en-US" smtClean="0"/>
+              <a:rPr lang="en-US"/>
               <a:t>Fifth level</a:t>
             </a:r>
-            <a:endParaRPr lang="en-US"/>
           </a:p>
         </p:txBody>
       </p:sp>
@@ -467,7 +479,7 @@
           <a:p>
             <a:fld id="{5BCAD085-E8A6-8845-BD4E-CB4CCA059FC4}" type="datetimeFigureOut">
               <a:rPr lang="en-US" smtClean="0"/>
-              <a:t>1/27/13</a:t>
+              <a:t>7/16/2026</a:t>
             </a:fld>
             <a:endParaRPr lang="en-US"/>
           </a:p>
@@ -566,10 +578,9 @@
           <a:lstStyle/>
           <a:p>
             <a:r>
-              <a:rPr lang="en-US" smtClean="0"/>
+              <a:rPr lang="en-US"/>
               <a:t>Click to edit Master title style</a:t>
             </a:r>
-            <a:endParaRPr lang="en-US"/>
           </a:p>
         </p:txBody>
       </p:sp>
@@ -595,38 +606,37 @@
           <a:p>
             <a:pPr lvl="0"/>
             <a:r>
-              <a:rPr lang="en-US" smtClean="0"/>
+              <a:rPr lang="en-US"/>
               <a:t>Click to edit Master text styles</a:t>
             </a:r>
           </a:p>
           <a:p>
             <a:pPr lvl="1"/>
             <a:r>
-              <a:rPr lang="en-US" smtClean="0"/>
+              <a:rPr lang="en-US"/>
               <a:t>Second level</a:t>
             </a:r>
           </a:p>
           <a:p>
             <a:pPr lvl="2"/>
             <a:r>
-              <a:rPr lang="en-US" smtClean="0"/>
+              <a:rPr lang="en-US"/>
               <a:t>Third level</a:t>
             </a:r>
           </a:p>
           <a:p>
             <a:pPr lvl="3"/>
             <a:r>
-              <a:rPr lang="en-US" smtClean="0"/>
+              <a:rPr lang="en-US"/>
               <a:t>Fourth level</a:t>
             </a:r>
           </a:p>
           <a:p>
             <a:pPr lvl="4"/>
             <a:r>
-              <a:rPr lang="en-US" smtClean="0"/>
+              <a:rPr lang="en-US"/>
               <a:t>Fifth level</a:t>
             </a:r>
-            <a:endParaRPr lang="en-US"/>
           </a:p>
         </p:txBody>
       </p:sp>
@@ -647,7 +657,7 @@
           <a:p>
             <a:fld id="{5BCAD085-E8A6-8845-BD4E-CB4CCA059FC4}" type="datetimeFigureOut">
               <a:rPr lang="en-US" smtClean="0"/>
-              <a:t>1/27/13</a:t>
+              <a:t>7/16/2026</a:t>
             </a:fld>
             <a:endParaRPr lang="en-US"/>
           </a:p>
@@ -741,10 +751,9 @@
           <a:lstStyle/>
           <a:p>
             <a:r>
-              <a:rPr lang="en-US" smtClean="0"/>
+              <a:rPr lang="en-US"/>
               <a:t>Click to edit Master title style</a:t>
             </a:r>
-            <a:endParaRPr lang="en-US"/>
           </a:p>
         </p:txBody>
       </p:sp>
@@ -765,38 +774,37 @@
           <a:p>
             <a:pPr lvl="0"/>
             <a:r>
-              <a:rPr lang="en-US" smtClean="0"/>
+              <a:rPr lang="en-US"/>
               <a:t>Click to edit Master text styles</a:t>
             </a:r>
           </a:p>
           <a:p>
             <a:pPr lvl="1"/>
             <a:r>
-              <a:rPr lang="en-US" smtClean="0"/>
+              <a:rPr lang="en-US"/>
               <a:t>Second level</a:t>
             </a:r>
           </a:p>
           <a:p>
             <a:pPr lvl="2"/>
             <a:r>
-              <a:rPr lang="en-US" smtClean="0"/>
+              <a:rPr lang="en-US"/>
               <a:t>Third level</a:t>
             </a:r>
           </a:p>
           <a:p>
             <a:pPr lvl="3"/>
             <a:r>
-              <a:rPr lang="en-US" smtClean="0"/>
+              <a:rPr lang="en-US"/>
               <a:t>Fourth level</a:t>
             </a:r>
           </a:p>
           <a:p>
             <a:pPr lvl="4"/>
             <a:r>
-              <a:rPr lang="en-US" smtClean="0"/>
+              <a:rPr lang="en-US"/>
               <a:t>Fifth level</a:t>
             </a:r>
-            <a:endParaRPr lang="en-US"/>
           </a:p>
         </p:txBody>
       </p:sp>
@@ -817,7 +825,7 @@
           <a:p>
             <a:fld id="{5BCAD085-E8A6-8845-BD4E-CB4CCA059FC4}" type="datetimeFigureOut">
               <a:rPr lang="en-US" smtClean="0"/>
-              <a:t>1/27/13</a:t>
+              <a:t>7/16/2026</a:t>
             </a:fld>
             <a:endParaRPr lang="en-US"/>
           </a:p>
@@ -920,10 +928,9 @@
           </a:lstStyle>
           <a:p>
             <a:r>
-              <a:rPr lang="en-US" smtClean="0"/>
+              <a:rPr lang="en-US"/>
               <a:t>Click to edit Master title style</a:t>
             </a:r>
-            <a:endParaRPr lang="en-US"/>
           </a:p>
         </p:txBody>
       </p:sp>
@@ -1040,7 +1047,7 @@
           <a:p>
             <a:pPr lvl="0"/>
             <a:r>
-              <a:rPr lang="en-US" smtClean="0"/>
+              <a:rPr lang="en-US"/>
               <a:t>Click to edit Master text styles</a:t>
             </a:r>
           </a:p>
@@ -1063,7 +1070,7 @@
           <a:p>
             <a:fld id="{5BCAD085-E8A6-8845-BD4E-CB4CCA059FC4}" type="datetimeFigureOut">
               <a:rPr lang="en-US" smtClean="0"/>
-              <a:t>1/27/13</a:t>
+              <a:t>7/16/2026</a:t>
             </a:fld>
             <a:endParaRPr lang="en-US"/>
           </a:p>
@@ -1157,10 +1164,9 @@
           <a:lstStyle/>
           <a:p>
             <a:r>
-              <a:rPr lang="en-US" smtClean="0"/>
+              <a:rPr lang="en-US"/>
               <a:t>Click to edit Master title style</a:t>
             </a:r>
-            <a:endParaRPr lang="en-US"/>
           </a:p>
         </p:txBody>
       </p:sp>
@@ -1214,38 +1220,37 @@
           <a:p>
             <a:pPr lvl="0"/>
             <a:r>
-              <a:rPr lang="en-US" smtClean="0"/>
+              <a:rPr lang="en-US"/>
               <a:t>Click to edit Master text styles</a:t>
             </a:r>
           </a:p>
           <a:p>
             <a:pPr lvl="1"/>
             <a:r>
-              <a:rPr lang="en-US" smtClean="0"/>
+              <a:rPr lang="en-US"/>
               <a:t>Second level</a:t>
             </a:r>
           </a:p>
           <a:p>
             <a:pPr lvl="2"/>
             <a:r>
-              <a:rPr lang="en-US" smtClean="0"/>
+              <a:rPr lang="en-US"/>
               <a:t>Third level</a:t>
             </a:r>
           </a:p>
           <a:p>
             <a:pPr lvl="3"/>
             <a:r>
-              <a:rPr lang="en-US" smtClean="0"/>
+              <a:rPr lang="en-US"/>
               <a:t>Fourth level</a:t>
             </a:r>
           </a:p>
           <a:p>
             <a:pPr lvl="4"/>
             <a:r>
-              <a:rPr lang="en-US" smtClean="0"/>
+              <a:rPr lang="en-US"/>
               <a:t>Fifth level</a:t>
             </a:r>
-            <a:endParaRPr lang="en-US"/>
           </a:p>
         </p:txBody>
       </p:sp>
@@ -1299,38 +1304,37 @@
           <a:p>
             <a:pPr lvl="0"/>
             <a:r>
-              <a:rPr lang="en-US" smtClean="0"/>
+              <a:rPr lang="en-US"/>
               <a:t>Click to edit Master text styles</a:t>
             </a:r>
           </a:p>
           <a:p>
             <a:pPr lvl="1"/>
             <a:r>
-              <a:rPr lang="en-US" smtClean="0"/>
+              <a:rPr lang="en-US"/>
               <a:t>Second level</a:t>
             </a:r>
           </a:p>
           <a:p>
             <a:pPr lvl="2"/>
             <a:r>
-              <a:rPr lang="en-US" smtClean="0"/>
+              <a:rPr lang="en-US"/>
               <a:t>Third level</a:t>
             </a:r>
           </a:p>
           <a:p>
             <a:pPr lvl="3"/>
             <a:r>
-              <a:rPr lang="en-US" smtClean="0"/>
+              <a:rPr lang="en-US"/>
               <a:t>Fourth level</a:t>
             </a:r>
           </a:p>
           <a:p>
             <a:pPr lvl="4"/>
             <a:r>
-              <a:rPr lang="en-US" smtClean="0"/>
+              <a:rPr lang="en-US"/>
               <a:t>Fifth level</a:t>
             </a:r>
-            <a:endParaRPr lang="en-US"/>
           </a:p>
         </p:txBody>
       </p:sp>
@@ -1351,7 +1355,7 @@
           <a:p>
             <a:fld id="{5BCAD085-E8A6-8845-BD4E-CB4CCA059FC4}" type="datetimeFigureOut">
               <a:rPr lang="en-US" smtClean="0"/>
-              <a:t>1/27/13</a:t>
+              <a:t>7/16/2026</a:t>
             </a:fld>
             <a:endParaRPr lang="en-US"/>
           </a:p>
@@ -1449,10 +1453,9 @@
           </a:lstStyle>
           <a:p>
             <a:r>
-              <a:rPr lang="en-US" smtClean="0"/>
+              <a:rPr lang="en-US"/>
               <a:t>Click to edit Master title style</a:t>
             </a:r>
-            <a:endParaRPr lang="en-US"/>
           </a:p>
         </p:txBody>
       </p:sp>
@@ -1515,7 +1518,7 @@
           <a:p>
             <a:pPr lvl="0"/>
             <a:r>
-              <a:rPr lang="en-US" smtClean="0"/>
+              <a:rPr lang="en-US"/>
               <a:t>Click to edit Master text styles</a:t>
             </a:r>
           </a:p>
@@ -1571,38 +1574,37 @@
           <a:p>
             <a:pPr lvl="0"/>
             <a:r>
-              <a:rPr lang="en-US" smtClean="0"/>
+              <a:rPr lang="en-US"/>
               <a:t>Click to edit Master text styles</a:t>
             </a:r>
           </a:p>
           <a:p>
             <a:pPr lvl="1"/>
             <a:r>
-              <a:rPr lang="en-US" smtClean="0"/>
+              <a:rPr lang="en-US"/>
               <a:t>Second level</a:t>
             </a:r>
           </a:p>
           <a:p>
             <a:pPr lvl="2"/>
             <a:r>
-              <a:rPr lang="en-US" smtClean="0"/>
+              <a:rPr lang="en-US"/>
               <a:t>Third level</a:t>
             </a:r>
           </a:p>
           <a:p>
             <a:pPr lvl="3"/>
             <a:r>
-              <a:rPr lang="en-US" smtClean="0"/>
+              <a:rPr lang="en-US"/>
               <a:t>Fourth level</a:t>
             </a:r>
           </a:p>
           <a:p>
             <a:pPr lvl="4"/>
             <a:r>
-              <a:rPr lang="en-US" smtClean="0"/>
+              <a:rPr lang="en-US"/>
               <a:t>Fifth level</a:t>
             </a:r>
-            <a:endParaRPr lang="en-US"/>
           </a:p>
         </p:txBody>
       </p:sp>
@@ -1665,7 +1667,7 @@
           <a:p>
             <a:pPr lvl="0"/>
             <a:r>
-              <a:rPr lang="en-US" smtClean="0"/>
+              <a:rPr lang="en-US"/>
               <a:t>Click to edit Master text styles</a:t>
             </a:r>
           </a:p>
@@ -1721,38 +1723,37 @@
           <a:p>
             <a:pPr lvl="0"/>
             <a:r>
-              <a:rPr lang="en-US" smtClean="0"/>
+              <a:rPr lang="en-US"/>
               <a:t>Click to edit Master text styles</a:t>
             </a:r>
           </a:p>
           <a:p>
             <a:pPr lvl="1"/>
             <a:r>
-              <a:rPr lang="en-US" smtClean="0"/>
+              <a:rPr lang="en-US"/>
               <a:t>Second level</a:t>
             </a:r>
           </a:p>
           <a:p>
             <a:pPr lvl="2"/>
             <a:r>
-              <a:rPr lang="en-US" smtClean="0"/>
+              <a:rPr lang="en-US"/>
               <a:t>Third level</a:t>
             </a:r>
           </a:p>
           <a:p>
             <a:pPr lvl="3"/>
             <a:r>
-              <a:rPr lang="en-US" smtClean="0"/>
+              <a:rPr lang="en-US"/>
               <a:t>Fourth level</a:t>
             </a:r>
           </a:p>
           <a:p>
             <a:pPr lvl="4"/>
             <a:r>
-              <a:rPr lang="en-US" smtClean="0"/>
+              <a:rPr lang="en-US"/>
               <a:t>Fifth level</a:t>
             </a:r>
-            <a:endParaRPr lang="en-US"/>
           </a:p>
         </p:txBody>
       </p:sp>
@@ -1773,7 +1774,7 @@
           <a:p>
             <a:fld id="{5BCAD085-E8A6-8845-BD4E-CB4CCA059FC4}" type="datetimeFigureOut">
               <a:rPr lang="en-US" smtClean="0"/>
-              <a:t>1/27/13</a:t>
+              <a:t>7/16/2026</a:t>
             </a:fld>
             <a:endParaRPr lang="en-US"/>
           </a:p>
@@ -1867,10 +1868,9 @@
           <a:lstStyle/>
           <a:p>
             <a:r>
-              <a:rPr lang="en-US" smtClean="0"/>
+              <a:rPr lang="en-US"/>
               <a:t>Click to edit Master title style</a:t>
             </a:r>
-            <a:endParaRPr lang="en-US"/>
           </a:p>
         </p:txBody>
       </p:sp>
@@ -1891,7 +1891,7 @@
           <a:p>
             <a:fld id="{5BCAD085-E8A6-8845-BD4E-CB4CCA059FC4}" type="datetimeFigureOut">
               <a:rPr lang="en-US" smtClean="0"/>
-              <a:t>1/27/13</a:t>
+              <a:t>7/16/2026</a:t>
             </a:fld>
             <a:endParaRPr lang="en-US"/>
           </a:p>
@@ -1986,7 +1986,7 @@
           <a:p>
             <a:fld id="{5BCAD085-E8A6-8845-BD4E-CB4CCA059FC4}" type="datetimeFigureOut">
               <a:rPr lang="en-US" smtClean="0"/>
-              <a:t>1/27/13</a:t>
+              <a:t>7/16/2026</a:t>
             </a:fld>
             <a:endParaRPr lang="en-US"/>
           </a:p>
@@ -2089,10 +2089,9 @@
           </a:lstStyle>
           <a:p>
             <a:r>
-              <a:rPr lang="en-US" smtClean="0"/>
+              <a:rPr lang="en-US"/>
               <a:t>Click to edit Master title style</a:t>
             </a:r>
-            <a:endParaRPr lang="en-US"/>
           </a:p>
         </p:txBody>
       </p:sp>
@@ -2146,38 +2145,37 @@
           <a:p>
             <a:pPr lvl="0"/>
             <a:r>
-              <a:rPr lang="en-US" smtClean="0"/>
+              <a:rPr lang="en-US"/>
               <a:t>Click to edit Master text styles</a:t>
             </a:r>
           </a:p>
           <a:p>
             <a:pPr lvl="1"/>
             <a:r>
-              <a:rPr lang="en-US" smtClean="0"/>
+              <a:rPr lang="en-US"/>
               <a:t>Second level</a:t>
             </a:r>
           </a:p>
           <a:p>
             <a:pPr lvl="2"/>
             <a:r>
-              <a:rPr lang="en-US" smtClean="0"/>
+              <a:rPr lang="en-US"/>
               <a:t>Third level</a:t>
             </a:r>
           </a:p>
           <a:p>
             <a:pPr lvl="3"/>
             <a:r>
-              <a:rPr lang="en-US" smtClean="0"/>
+              <a:rPr lang="en-US"/>
               <a:t>Fourth level</a:t>
             </a:r>
           </a:p>
           <a:p>
             <a:pPr lvl="4"/>
             <a:r>
-              <a:rPr lang="en-US" smtClean="0"/>
+              <a:rPr lang="en-US"/>
               <a:t>Fifth level</a:t>
             </a:r>
-            <a:endParaRPr lang="en-US"/>
           </a:p>
         </p:txBody>
       </p:sp>
@@ -2240,7 +2238,7 @@
           <a:p>
             <a:pPr lvl="0"/>
             <a:r>
-              <a:rPr lang="en-US" smtClean="0"/>
+              <a:rPr lang="en-US"/>
               <a:t>Click to edit Master text styles</a:t>
             </a:r>
           </a:p>
@@ -2263,7 +2261,7 @@
           <a:p>
             <a:fld id="{5BCAD085-E8A6-8845-BD4E-CB4CCA059FC4}" type="datetimeFigureOut">
               <a:rPr lang="en-US" smtClean="0"/>
-              <a:t>1/27/13</a:t>
+              <a:t>7/16/2026</a:t>
             </a:fld>
             <a:endParaRPr lang="en-US"/>
           </a:p>
@@ -2366,10 +2364,9 @@
           </a:lstStyle>
           <a:p>
             <a:r>
-              <a:rPr lang="en-US" smtClean="0"/>
+              <a:rPr lang="en-US"/>
               <a:t>Click to edit Master title style</a:t>
             </a:r>
-            <a:endParaRPr lang="en-US"/>
           </a:p>
         </p:txBody>
       </p:sp>
@@ -2493,7 +2490,7 @@
           <a:p>
             <a:pPr lvl="0"/>
             <a:r>
-              <a:rPr lang="en-US" smtClean="0"/>
+              <a:rPr lang="en-US"/>
               <a:t>Click to edit Master text styles</a:t>
             </a:r>
           </a:p>
@@ -2516,7 +2513,7 @@
           <a:p>
             <a:fld id="{5BCAD085-E8A6-8845-BD4E-CB4CCA059FC4}" type="datetimeFigureOut">
               <a:rPr lang="en-US" smtClean="0"/>
-              <a:t>1/27/13</a:t>
+              <a:t>7/16/2026</a:t>
             </a:fld>
             <a:endParaRPr lang="en-US"/>
           </a:p>
@@ -2625,10 +2622,9 @@
           <a:lstStyle/>
           <a:p>
             <a:r>
-              <a:rPr lang="en-US" smtClean="0"/>
+              <a:rPr lang="en-US"/>
               <a:t>Click to edit Master title style</a:t>
             </a:r>
-            <a:endParaRPr lang="en-US"/>
           </a:p>
         </p:txBody>
       </p:sp>
@@ -2659,38 +2655,37 @@
           <a:p>
             <a:pPr lvl="0"/>
             <a:r>
-              <a:rPr lang="en-US" smtClean="0"/>
+              <a:rPr lang="en-US"/>
               <a:t>Click to edit Master text styles</a:t>
             </a:r>
           </a:p>
           <a:p>
             <a:pPr lvl="1"/>
             <a:r>
-              <a:rPr lang="en-US" smtClean="0"/>
+              <a:rPr lang="en-US"/>
               <a:t>Second level</a:t>
             </a:r>
           </a:p>
           <a:p>
             <a:pPr lvl="2"/>
             <a:r>
-              <a:rPr lang="en-US" smtClean="0"/>
+              <a:rPr lang="en-US"/>
               <a:t>Third level</a:t>
             </a:r>
           </a:p>
           <a:p>
             <a:pPr lvl="3"/>
             <a:r>
-              <a:rPr lang="en-US" smtClean="0"/>
+              <a:rPr lang="en-US"/>
               <a:t>Fourth level</a:t>
             </a:r>
           </a:p>
           <a:p>
             <a:pPr lvl="4"/>
             <a:r>
-              <a:rPr lang="en-US" smtClean="0"/>
+              <a:rPr lang="en-US"/>
               <a:t>Fifth level</a:t>
             </a:r>
-            <a:endParaRPr lang="en-US"/>
           </a:p>
         </p:txBody>
       </p:sp>
@@ -2729,7 +2724,7 @@
           <a:p>
             <a:fld id="{5BCAD085-E8A6-8845-BD4E-CB4CCA059FC4}" type="datetimeFigureOut">
               <a:rPr lang="en-US" smtClean="0"/>
-              <a:t>1/27/13</a:t>
+              <a:t>7/16/2026</a:t>
             </a:fld>
             <a:endParaRPr lang="en-US"/>
           </a:p>
@@ -3088,7 +3083,7 @@
 </file>
 
 <file path=ppt/slides/slide1.xml><?xml version="1.0" encoding="utf-8"?>
-<p:sld xmlns:a="http://schemas.openxmlformats.org/drawingml/2006/main" xmlns:p="http://schemas.openxmlformats.org/presentationml/2006/main" xmlns:r="http://schemas.openxmlformats.org/officeDocument/2006/relationships">
+<p:sld xmlns:a="http://schemas.openxmlformats.org/drawingml/2006/main" xmlns:r="http://schemas.openxmlformats.org/officeDocument/2006/relationships" xmlns:p="http://schemas.openxmlformats.org/presentationml/2006/main">
   <p:cSld>
     <p:bg>
       <p:bgPr>
@@ -3104,7 +3099,14 @@
         <p:cNvGrpSpPr/>
         <p:nvPr/>
       </p:nvGrpSpPr>
-      <p:grpSpPr/>
+      <p:grpSpPr>
+        <a:xfrm>
+          <a:off x="0" y="0"/>
+          <a:ext cx="0" cy="0"/>
+          <a:chOff x="0" y="0"/>
+          <a:chExt cx="0" cy="0"/>
+        </a:xfrm>
+      </p:grpSpPr>
       <p:sp>
         <p:nvSpPr>
           <p:cNvPr id="2" name="TextBox 1"/>
@@ -3122,7 +3124,7 @@
           <a:noFill/>
         </p:spPr>
         <p:txBody>
-          <a:bodyPr wrap="square" anchor="t" lIns="0" rIns="0" tIns="0" bIns="0">
+          <a:bodyPr wrap="square" lIns="0" tIns="0" rIns="0" bIns="0" anchor="t">
             <a:spAutoFit/>
           </a:bodyPr>
           <a:lstStyle/>
@@ -3188,7 +3190,7 @@
           <a:noFill/>
         </p:spPr>
         <p:txBody>
-          <a:bodyPr wrap="square" anchor="t" lIns="0" rIns="0" tIns="0" bIns="0">
+          <a:bodyPr wrap="square" lIns="0" tIns="0" rIns="0" bIns="0" anchor="t">
             <a:spAutoFit/>
           </a:bodyPr>
           <a:lstStyle/>
@@ -3273,7 +3275,7 @@
           </a:fontRef>
         </p:style>
         <p:txBody>
-          <a:bodyPr rtlCol="0" anchor="ctr" wrap="square" lIns="76200" rIns="76200" tIns="38100" bIns="38100"/>
+          <a:bodyPr wrap="square" lIns="76200" tIns="38100" rIns="76200" bIns="38100" rtlCol="0" anchor="ctr"/>
           <a:lstStyle/>
           <a:p>
             <a:pPr algn="ctr">
@@ -3337,7 +3339,7 @@
           </a:fontRef>
         </p:style>
         <p:txBody>
-          <a:bodyPr rtlCol="0" anchor="ctr" wrap="square" lIns="76200" rIns="76200" tIns="38100" bIns="38100"/>
+          <a:bodyPr wrap="square" lIns="76200" tIns="38100" rIns="76200" bIns="38100" rtlCol="0" anchor="ctr"/>
           <a:lstStyle/>
           <a:p>
             <a:pPr algn="ctr">
@@ -3401,7 +3403,7 @@
           </a:fontRef>
         </p:style>
         <p:txBody>
-          <a:bodyPr rtlCol="0" anchor="ctr" wrap="square" lIns="76200" rIns="76200" tIns="38100" bIns="38100"/>
+          <a:bodyPr wrap="square" lIns="76200" tIns="38100" rIns="76200" bIns="38100" rtlCol="0" anchor="ctr"/>
           <a:lstStyle/>
           <a:p>
             <a:pPr algn="ctr">
@@ -3441,7 +3443,7 @@
           <a:noFill/>
         </p:spPr>
         <p:txBody>
-          <a:bodyPr wrap="square" anchor="t" lIns="0" rIns="0" tIns="0" bIns="0">
+          <a:bodyPr wrap="square" lIns="0" tIns="0" rIns="0" bIns="0" anchor="t">
             <a:spAutoFit/>
           </a:bodyPr>
           <a:lstStyle/>
@@ -3484,7 +3486,7 @@
 </file>
 
 <file path=ppt/slides/slide10.xml><?xml version="1.0" encoding="utf-8"?>
-<p:sld xmlns:a="http://schemas.openxmlformats.org/drawingml/2006/main" xmlns:p="http://schemas.openxmlformats.org/presentationml/2006/main" xmlns:r="http://schemas.openxmlformats.org/officeDocument/2006/relationships">
+<p:sld xmlns:a="http://schemas.openxmlformats.org/drawingml/2006/main" xmlns:r="http://schemas.openxmlformats.org/officeDocument/2006/relationships" xmlns:p="http://schemas.openxmlformats.org/presentationml/2006/main">
   <p:cSld>
     <p:bg>
       <p:bgPr>
@@ -3500,7 +3502,14 @@
         <p:cNvGrpSpPr/>
         <p:nvPr/>
       </p:nvGrpSpPr>
-      <p:grpSpPr/>
+      <p:grpSpPr>
+        <a:xfrm>
+          <a:off x="0" y="0"/>
+          <a:ext cx="0" cy="0"/>
+          <a:chOff x="0" y="0"/>
+          <a:chExt cx="0" cy="0"/>
+        </a:xfrm>
+      </p:grpSpPr>
       <p:sp>
         <p:nvSpPr>
           <p:cNvPr id="2" name="TextBox 1"/>
@@ -3518,7 +3527,7 @@
           <a:noFill/>
         </p:spPr>
         <p:txBody>
-          <a:bodyPr wrap="square" anchor="t" lIns="0" rIns="0" tIns="0" bIns="0">
+          <a:bodyPr wrap="square" lIns="0" tIns="0" rIns="0" bIns="0" anchor="t">
             <a:spAutoFit/>
           </a:bodyPr>
           <a:lstStyle/>
@@ -3584,7 +3593,7 @@
           <a:noFill/>
         </p:spPr>
         <p:txBody>
-          <a:bodyPr wrap="square" anchor="t" lIns="0" rIns="0" tIns="0" bIns="0">
+          <a:bodyPr wrap="square" lIns="0" tIns="0" rIns="0" bIns="0" anchor="t">
             <a:spAutoFit/>
           </a:bodyPr>
           <a:lstStyle/>
@@ -3654,6 +3663,7 @@
           <a:lstStyle/>
           <a:p>
             <a:pPr algn="ctr"/>
+            <a:endParaRPr/>
           </a:p>
         </p:txBody>
       </p:sp>
@@ -3674,7 +3684,7 @@
           <a:noFill/>
         </p:spPr>
         <p:txBody>
-          <a:bodyPr wrap="square" anchor="t" lIns="0" rIns="0" tIns="0" bIns="0">
+          <a:bodyPr wrap="square" lIns="0" tIns="0" rIns="0" bIns="0" anchor="t">
             <a:spAutoFit/>
           </a:bodyPr>
           <a:lstStyle/>
@@ -3725,7 +3735,7 @@
           <a:noFill/>
         </p:spPr>
         <p:txBody>
-          <a:bodyPr wrap="square" anchor="t" lIns="0" rIns="0" tIns="0" bIns="0">
+          <a:bodyPr wrap="square" lIns="0" tIns="0" rIns="0" bIns="0" anchor="t">
             <a:spAutoFit/>
           </a:bodyPr>
           <a:lstStyle/>
@@ -3777,7 +3787,7 @@
 </file>
 
 <file path=ppt/slides/slide2.xml><?xml version="1.0" encoding="utf-8"?>
-<p:sld xmlns:a="http://schemas.openxmlformats.org/drawingml/2006/main" xmlns:p="http://schemas.openxmlformats.org/presentationml/2006/main" xmlns:r="http://schemas.openxmlformats.org/officeDocument/2006/relationships">
+<p:sld xmlns:a="http://schemas.openxmlformats.org/drawingml/2006/main" xmlns:r="http://schemas.openxmlformats.org/officeDocument/2006/relationships" xmlns:p="http://schemas.openxmlformats.org/presentationml/2006/main">
   <p:cSld>
     <p:bg>
       <p:bgPr>
@@ -3793,7 +3803,14 @@
         <p:cNvGrpSpPr/>
         <p:nvPr/>
       </p:nvGrpSpPr>
-      <p:grpSpPr/>
+      <p:grpSpPr>
+        <a:xfrm>
+          <a:off x="0" y="0"/>
+          <a:ext cx="0" cy="0"/>
+          <a:chOff x="0" y="0"/>
+          <a:chExt cx="0" cy="0"/>
+        </a:xfrm>
+      </p:grpSpPr>
       <p:sp>
         <p:nvSpPr>
           <p:cNvPr id="2" name="TextBox 1"/>
@@ -3811,7 +3828,7 @@
           <a:noFill/>
         </p:spPr>
         <p:txBody>
-          <a:bodyPr wrap="square" anchor="t" lIns="0" rIns="0" tIns="0" bIns="0">
+          <a:bodyPr wrap="square" lIns="0" tIns="0" rIns="0" bIns="0" anchor="t">
             <a:spAutoFit/>
           </a:bodyPr>
           <a:lstStyle/>
@@ -3853,7 +3870,7 @@
           <a:noFill/>
         </p:spPr>
         <p:txBody>
-          <a:bodyPr wrap="square" anchor="t" lIns="0" rIns="0" tIns="0" bIns="0">
+          <a:bodyPr wrap="square" lIns="0" tIns="0" rIns="0" bIns="0" anchor="t">
             <a:spAutoFit/>
           </a:bodyPr>
           <a:lstStyle/>
@@ -3947,6 +3964,7 @@
           <a:lstStyle/>
           <a:p>
             <a:pPr algn="ctr"/>
+            <a:endParaRPr/>
           </a:p>
         </p:txBody>
       </p:sp>
@@ -3991,6 +4009,7 @@
           <a:lstStyle/>
           <a:p>
             <a:pPr algn="ctr"/>
+            <a:endParaRPr/>
           </a:p>
         </p:txBody>
       </p:sp>
@@ -4011,7 +4030,7 @@
           <a:noFill/>
         </p:spPr>
         <p:txBody>
-          <a:bodyPr wrap="square" anchor="t" lIns="0" rIns="0" tIns="0" bIns="0">
+          <a:bodyPr wrap="square" lIns="0" tIns="0" rIns="0" bIns="0" anchor="t">
             <a:spAutoFit/>
           </a:bodyPr>
           <a:lstStyle/>
@@ -4053,7 +4072,7 @@
           <a:noFill/>
         </p:spPr>
         <p:txBody>
-          <a:bodyPr wrap="square" anchor="t" lIns="0" rIns="0" tIns="0" bIns="0">
+          <a:bodyPr wrap="square" lIns="0" tIns="0" rIns="0" bIns="0" anchor="t">
             <a:spAutoFit/>
           </a:bodyPr>
           <a:lstStyle/>
@@ -4126,6 +4145,7 @@
           <a:lstStyle/>
           <a:p>
             <a:pPr algn="ctr"/>
+            <a:endParaRPr/>
           </a:p>
         </p:txBody>
       </p:sp>
@@ -4170,6 +4190,7 @@
           <a:lstStyle/>
           <a:p>
             <a:pPr algn="ctr"/>
+            <a:endParaRPr/>
           </a:p>
         </p:txBody>
       </p:sp>
@@ -4190,7 +4211,7 @@
           <a:noFill/>
         </p:spPr>
         <p:txBody>
-          <a:bodyPr wrap="square" anchor="t" lIns="0" rIns="0" tIns="0" bIns="0">
+          <a:bodyPr wrap="square" lIns="0" tIns="0" rIns="0" bIns="0" anchor="t">
             <a:spAutoFit/>
           </a:bodyPr>
           <a:lstStyle/>
@@ -4232,7 +4253,7 @@
           <a:noFill/>
         </p:spPr>
         <p:txBody>
-          <a:bodyPr wrap="square" anchor="t" lIns="0" rIns="0" tIns="0" bIns="0">
+          <a:bodyPr wrap="square" lIns="0" tIns="0" rIns="0" bIns="0" anchor="t">
             <a:spAutoFit/>
           </a:bodyPr>
           <a:lstStyle/>
@@ -4305,6 +4326,7 @@
           <a:lstStyle/>
           <a:p>
             <a:pPr algn="ctr"/>
+            <a:endParaRPr/>
           </a:p>
         </p:txBody>
       </p:sp>
@@ -4349,6 +4371,7 @@
           <a:lstStyle/>
           <a:p>
             <a:pPr algn="ctr"/>
+            <a:endParaRPr/>
           </a:p>
         </p:txBody>
       </p:sp>
@@ -4369,7 +4392,7 @@
           <a:noFill/>
         </p:spPr>
         <p:txBody>
-          <a:bodyPr wrap="square" anchor="t" lIns="0" rIns="0" tIns="0" bIns="0">
+          <a:bodyPr wrap="square" lIns="0" tIns="0" rIns="0" bIns="0" anchor="t">
             <a:spAutoFit/>
           </a:bodyPr>
           <a:lstStyle/>
@@ -4411,7 +4434,7 @@
           <a:noFill/>
         </p:spPr>
         <p:txBody>
-          <a:bodyPr wrap="square" anchor="t" lIns="0" rIns="0" tIns="0" bIns="0">
+          <a:bodyPr wrap="square" lIns="0" tIns="0" rIns="0" bIns="0" anchor="t">
             <a:spAutoFit/>
           </a:bodyPr>
           <a:lstStyle/>
@@ -4484,6 +4507,7 @@
           <a:lstStyle/>
           <a:p>
             <a:pPr algn="ctr"/>
+            <a:endParaRPr/>
           </a:p>
         </p:txBody>
       </p:sp>
@@ -4528,6 +4552,7 @@
           <a:lstStyle/>
           <a:p>
             <a:pPr algn="ctr"/>
+            <a:endParaRPr/>
           </a:p>
         </p:txBody>
       </p:sp>
@@ -4548,7 +4573,7 @@
           <a:noFill/>
         </p:spPr>
         <p:txBody>
-          <a:bodyPr wrap="square" anchor="t" lIns="0" rIns="0" tIns="0" bIns="0">
+          <a:bodyPr wrap="square" lIns="0" tIns="0" rIns="0" bIns="0" anchor="t">
             <a:spAutoFit/>
           </a:bodyPr>
           <a:lstStyle/>
@@ -4590,7 +4615,7 @@
           <a:noFill/>
         </p:spPr>
         <p:txBody>
-          <a:bodyPr wrap="square" anchor="t" lIns="0" rIns="0" tIns="0" bIns="0">
+          <a:bodyPr wrap="square" lIns="0" tIns="0" rIns="0" bIns="0" anchor="t">
             <a:spAutoFit/>
           </a:bodyPr>
           <a:lstStyle/>
@@ -4663,6 +4688,7 @@
           <a:lstStyle/>
           <a:p>
             <a:pPr algn="ctr"/>
+            <a:endParaRPr/>
           </a:p>
         </p:txBody>
       </p:sp>
@@ -4707,6 +4733,7 @@
           <a:lstStyle/>
           <a:p>
             <a:pPr algn="ctr"/>
+            <a:endParaRPr/>
           </a:p>
         </p:txBody>
       </p:sp>
@@ -4727,7 +4754,7 @@
           <a:noFill/>
         </p:spPr>
         <p:txBody>
-          <a:bodyPr wrap="square" anchor="t" lIns="0" rIns="0" tIns="0" bIns="0">
+          <a:bodyPr wrap="square" lIns="0" tIns="0" rIns="0" bIns="0" anchor="t">
             <a:spAutoFit/>
           </a:bodyPr>
           <a:lstStyle/>
@@ -4769,7 +4796,7 @@
           <a:noFill/>
         </p:spPr>
         <p:txBody>
-          <a:bodyPr wrap="square" anchor="t" lIns="0" rIns="0" tIns="0" bIns="0">
+          <a:bodyPr wrap="square" lIns="0" tIns="0" rIns="0" bIns="0" anchor="t">
             <a:spAutoFit/>
           </a:bodyPr>
           <a:lstStyle/>
@@ -4842,6 +4869,7 @@
           <a:lstStyle/>
           <a:p>
             <a:pPr algn="ctr"/>
+            <a:endParaRPr/>
           </a:p>
         </p:txBody>
       </p:sp>
@@ -4886,6 +4914,7 @@
           <a:lstStyle/>
           <a:p>
             <a:pPr algn="ctr"/>
+            <a:endParaRPr/>
           </a:p>
         </p:txBody>
       </p:sp>
@@ -4906,7 +4935,7 @@
           <a:noFill/>
         </p:spPr>
         <p:txBody>
-          <a:bodyPr wrap="square" anchor="t" lIns="0" rIns="0" tIns="0" bIns="0">
+          <a:bodyPr wrap="square" lIns="0" tIns="0" rIns="0" bIns="0" anchor="t">
             <a:spAutoFit/>
           </a:bodyPr>
           <a:lstStyle/>
@@ -5006,7 +5035,7 @@
           <a:noFill/>
         </p:spPr>
         <p:txBody>
-          <a:bodyPr wrap="square" anchor="t" lIns="0" rIns="0" tIns="0" bIns="0">
+          <a:bodyPr wrap="square" lIns="0" tIns="0" rIns="0" bIns="0" anchor="t">
             <a:spAutoFit/>
           </a:bodyPr>
           <a:lstStyle/>
@@ -5072,6 +5101,7 @@
           <a:lstStyle/>
           <a:p>
             <a:pPr algn="ctr"/>
+            <a:endParaRPr/>
           </a:p>
         </p:txBody>
       </p:sp>
@@ -5092,7 +5122,7 @@
           <a:noFill/>
         </p:spPr>
         <p:txBody>
-          <a:bodyPr wrap="square" anchor="t" lIns="0" rIns="0" tIns="0" bIns="0">
+          <a:bodyPr wrap="square" lIns="0" tIns="0" rIns="0" bIns="0" anchor="t">
             <a:spAutoFit/>
           </a:bodyPr>
           <a:lstStyle/>
@@ -5143,7 +5173,7 @@
           <a:noFill/>
         </p:spPr>
         <p:txBody>
-          <a:bodyPr wrap="square" anchor="t" lIns="0" rIns="0" tIns="0" bIns="0">
+          <a:bodyPr wrap="square" lIns="0" tIns="0" rIns="0" bIns="0" anchor="t">
             <a:spAutoFit/>
           </a:bodyPr>
           <a:lstStyle/>
@@ -5177,7 +5207,7 @@
 </file>
 
 <file path=ppt/slides/slide3.xml><?xml version="1.0" encoding="utf-8"?>
-<p:sld xmlns:a="http://schemas.openxmlformats.org/drawingml/2006/main" xmlns:p="http://schemas.openxmlformats.org/presentationml/2006/main" xmlns:r="http://schemas.openxmlformats.org/officeDocument/2006/relationships">
+<p:sld xmlns:a="http://schemas.openxmlformats.org/drawingml/2006/main" xmlns:r="http://schemas.openxmlformats.org/officeDocument/2006/relationships" xmlns:p="http://schemas.openxmlformats.org/presentationml/2006/main">
   <p:cSld>
     <p:bg>
       <p:bgPr>
@@ -5193,7 +5223,14 @@
         <p:cNvGrpSpPr/>
         <p:nvPr/>
       </p:nvGrpSpPr>
-      <p:grpSpPr/>
+      <p:grpSpPr>
+        <a:xfrm>
+          <a:off x="0" y="0"/>
+          <a:ext cx="0" cy="0"/>
+          <a:chOff x="0" y="0"/>
+          <a:chExt cx="0" cy="0"/>
+        </a:xfrm>
+      </p:grpSpPr>
       <p:sp>
         <p:nvSpPr>
           <p:cNvPr id="2" name="TextBox 1"/>
@@ -5211,7 +5248,7 @@
           <a:noFill/>
         </p:spPr>
         <p:txBody>
-          <a:bodyPr wrap="square" anchor="t" lIns="0" rIns="0" tIns="0" bIns="0">
+          <a:bodyPr wrap="square" lIns="0" tIns="0" rIns="0" bIns="0" anchor="t">
             <a:spAutoFit/>
           </a:bodyPr>
           <a:lstStyle/>
@@ -5253,7 +5290,7 @@
           <a:noFill/>
         </p:spPr>
         <p:txBody>
-          <a:bodyPr wrap="square" anchor="t" lIns="0" rIns="0" tIns="0" bIns="0">
+          <a:bodyPr wrap="square" lIns="0" tIns="0" rIns="0" bIns="0" anchor="t">
             <a:spAutoFit/>
           </a:bodyPr>
           <a:lstStyle/>
@@ -5347,6 +5384,7 @@
           <a:lstStyle/>
           <a:p>
             <a:pPr algn="ctr"/>
+            <a:endParaRPr/>
           </a:p>
         </p:txBody>
       </p:sp>
@@ -5391,6 +5429,7 @@
           <a:lstStyle/>
           <a:p>
             <a:pPr algn="ctr"/>
+            <a:endParaRPr/>
           </a:p>
         </p:txBody>
       </p:sp>
@@ -5411,7 +5450,7 @@
           <a:noFill/>
         </p:spPr>
         <p:txBody>
-          <a:bodyPr wrap="square" anchor="t" lIns="0" rIns="0" tIns="0" bIns="0">
+          <a:bodyPr wrap="square" lIns="0" tIns="0" rIns="0" bIns="0" anchor="t">
             <a:spAutoFit/>
           </a:bodyPr>
           <a:lstStyle/>
@@ -5453,7 +5492,7 @@
           <a:noFill/>
         </p:spPr>
         <p:txBody>
-          <a:bodyPr wrap="square" anchor="t" lIns="0" rIns="0" tIns="0" bIns="0">
+          <a:bodyPr wrap="square" lIns="0" tIns="0" rIns="0" bIns="0" anchor="t">
             <a:spAutoFit/>
           </a:bodyPr>
           <a:lstStyle/>
@@ -5585,7 +5624,7 @@
           <a:noFill/>
         </p:spPr>
         <p:txBody>
-          <a:bodyPr wrap="square" anchor="t" lIns="0" rIns="0" tIns="0" bIns="0">
+          <a:bodyPr wrap="square" lIns="0" tIns="0" rIns="0" bIns="0" anchor="t">
             <a:spAutoFit/>
           </a:bodyPr>
           <a:lstStyle/>
@@ -5655,6 +5694,7 @@
           <a:lstStyle/>
           <a:p>
             <a:pPr algn="ctr"/>
+            <a:endParaRPr/>
           </a:p>
         </p:txBody>
       </p:sp>
@@ -5699,6 +5739,7 @@
           <a:lstStyle/>
           <a:p>
             <a:pPr algn="ctr"/>
+            <a:endParaRPr/>
           </a:p>
         </p:txBody>
       </p:sp>
@@ -5719,7 +5760,7 @@
           <a:noFill/>
         </p:spPr>
         <p:txBody>
-          <a:bodyPr wrap="square" anchor="t" lIns="0" rIns="0" tIns="0" bIns="0">
+          <a:bodyPr wrap="square" lIns="0" tIns="0" rIns="0" bIns="0" anchor="t">
             <a:spAutoFit/>
           </a:bodyPr>
           <a:lstStyle/>
@@ -5761,7 +5802,7 @@
           <a:noFill/>
         </p:spPr>
         <p:txBody>
-          <a:bodyPr wrap="square" anchor="t" lIns="0" rIns="0" tIns="0" bIns="0">
+          <a:bodyPr wrap="square" lIns="0" tIns="0" rIns="0" bIns="0" anchor="t">
             <a:spAutoFit/>
           </a:bodyPr>
           <a:lstStyle/>
@@ -5831,6 +5872,7 @@
           <a:lstStyle/>
           <a:p>
             <a:pPr algn="ctr"/>
+            <a:endParaRPr/>
           </a:p>
         </p:txBody>
       </p:sp>
@@ -5875,6 +5917,7 @@
           <a:lstStyle/>
           <a:p>
             <a:pPr algn="ctr"/>
+            <a:endParaRPr/>
           </a:p>
         </p:txBody>
       </p:sp>
@@ -5895,7 +5938,7 @@
           <a:noFill/>
         </p:spPr>
         <p:txBody>
-          <a:bodyPr wrap="square" anchor="t" lIns="0" rIns="0" tIns="0" bIns="0">
+          <a:bodyPr wrap="square" lIns="0" tIns="0" rIns="0" bIns="0" anchor="t">
             <a:spAutoFit/>
           </a:bodyPr>
           <a:lstStyle/>
@@ -5937,7 +5980,7 @@
           <a:noFill/>
         </p:spPr>
         <p:txBody>
-          <a:bodyPr wrap="square" anchor="t" lIns="0" rIns="0" tIns="0" bIns="0">
+          <a:bodyPr wrap="square" lIns="0" tIns="0" rIns="0" bIns="0" anchor="t">
             <a:spAutoFit/>
           </a:bodyPr>
           <a:lstStyle/>
@@ -6007,6 +6050,7 @@
           <a:lstStyle/>
           <a:p>
             <a:pPr algn="ctr"/>
+            <a:endParaRPr/>
           </a:p>
         </p:txBody>
       </p:sp>
@@ -6051,6 +6095,7 @@
           <a:lstStyle/>
           <a:p>
             <a:pPr algn="ctr"/>
+            <a:endParaRPr/>
           </a:p>
         </p:txBody>
       </p:sp>
@@ -6071,7 +6116,7 @@
           <a:noFill/>
         </p:spPr>
         <p:txBody>
-          <a:bodyPr wrap="square" anchor="t" lIns="0" rIns="0" tIns="0" bIns="0">
+          <a:bodyPr wrap="square" lIns="0" tIns="0" rIns="0" bIns="0" anchor="t">
             <a:spAutoFit/>
           </a:bodyPr>
           <a:lstStyle/>
@@ -6113,7 +6158,7 @@
           <a:noFill/>
         </p:spPr>
         <p:txBody>
-          <a:bodyPr wrap="square" anchor="t" lIns="0" rIns="0" tIns="0" bIns="0">
+          <a:bodyPr wrap="square" lIns="0" tIns="0" rIns="0" bIns="0" anchor="t">
             <a:spAutoFit/>
           </a:bodyPr>
           <a:lstStyle/>
@@ -6183,6 +6228,7 @@
           <a:lstStyle/>
           <a:p>
             <a:pPr algn="ctr"/>
+            <a:endParaRPr/>
           </a:p>
         </p:txBody>
       </p:sp>
@@ -6227,6 +6273,7 @@
           <a:lstStyle/>
           <a:p>
             <a:pPr algn="ctr"/>
+            <a:endParaRPr/>
           </a:p>
         </p:txBody>
       </p:sp>
@@ -6247,7 +6294,7 @@
           <a:noFill/>
         </p:spPr>
         <p:txBody>
-          <a:bodyPr wrap="square" anchor="t" lIns="0" rIns="0" tIns="0" bIns="0">
+          <a:bodyPr wrap="square" lIns="0" tIns="0" rIns="0" bIns="0" anchor="t">
             <a:spAutoFit/>
           </a:bodyPr>
           <a:lstStyle/>
@@ -6289,7 +6336,7 @@
           <a:noFill/>
         </p:spPr>
         <p:txBody>
-          <a:bodyPr wrap="square" anchor="t" lIns="0" rIns="0" tIns="0" bIns="0">
+          <a:bodyPr wrap="square" lIns="0" tIns="0" rIns="0" bIns="0" anchor="t">
             <a:spAutoFit/>
           </a:bodyPr>
           <a:lstStyle/>
@@ -6355,6 +6402,7 @@
           <a:lstStyle/>
           <a:p>
             <a:pPr algn="ctr"/>
+            <a:endParaRPr/>
           </a:p>
         </p:txBody>
       </p:sp>
@@ -6375,7 +6423,7 @@
           <a:noFill/>
         </p:spPr>
         <p:txBody>
-          <a:bodyPr wrap="square" anchor="t" lIns="0" rIns="0" tIns="0" bIns="0">
+          <a:bodyPr wrap="square" lIns="0" tIns="0" rIns="0" bIns="0" anchor="t">
             <a:spAutoFit/>
           </a:bodyPr>
           <a:lstStyle/>
@@ -6426,7 +6474,7 @@
           <a:noFill/>
         </p:spPr>
         <p:txBody>
-          <a:bodyPr wrap="square" anchor="t" lIns="0" rIns="0" tIns="0" bIns="0">
+          <a:bodyPr wrap="square" lIns="0" tIns="0" rIns="0" bIns="0" anchor="t">
             <a:spAutoFit/>
           </a:bodyPr>
           <a:lstStyle/>
@@ -6460,7 +6508,7 @@
 </file>
 
 <file path=ppt/slides/slide4.xml><?xml version="1.0" encoding="utf-8"?>
-<p:sld xmlns:a="http://schemas.openxmlformats.org/drawingml/2006/main" xmlns:p="http://schemas.openxmlformats.org/presentationml/2006/main" xmlns:r="http://schemas.openxmlformats.org/officeDocument/2006/relationships">
+<p:sld xmlns:a="http://schemas.openxmlformats.org/drawingml/2006/main" xmlns:r="http://schemas.openxmlformats.org/officeDocument/2006/relationships" xmlns:p="http://schemas.openxmlformats.org/presentationml/2006/main">
   <p:cSld>
     <p:bg>
       <p:bgPr>
@@ -6476,7 +6524,14 @@
         <p:cNvGrpSpPr/>
         <p:nvPr/>
       </p:nvGrpSpPr>
-      <p:grpSpPr/>
+      <p:grpSpPr>
+        <a:xfrm>
+          <a:off x="0" y="0"/>
+          <a:ext cx="0" cy="0"/>
+          <a:chOff x="0" y="0"/>
+          <a:chExt cx="0" cy="0"/>
+        </a:xfrm>
+      </p:grpSpPr>
       <p:sp>
         <p:nvSpPr>
           <p:cNvPr id="2" name="TextBox 1"/>
@@ -6494,7 +6549,7 @@
           <a:noFill/>
         </p:spPr>
         <p:txBody>
-          <a:bodyPr wrap="square" anchor="t" lIns="0" rIns="0" tIns="0" bIns="0">
+          <a:bodyPr wrap="square" lIns="0" tIns="0" rIns="0" bIns="0" anchor="t">
             <a:spAutoFit/>
           </a:bodyPr>
           <a:lstStyle/>
@@ -6536,7 +6591,7 @@
           <a:noFill/>
         </p:spPr>
         <p:txBody>
-          <a:bodyPr wrap="square" anchor="t" lIns="0" rIns="0" tIns="0" bIns="0">
+          <a:bodyPr wrap="square" lIns="0" tIns="0" rIns="0" bIns="0" anchor="t">
             <a:spAutoFit/>
           </a:bodyPr>
           <a:lstStyle/>
@@ -6630,6 +6685,7 @@
           <a:lstStyle/>
           <a:p>
             <a:pPr algn="ctr"/>
+            <a:endParaRPr/>
           </a:p>
         </p:txBody>
       </p:sp>
@@ -6674,6 +6730,7 @@
           <a:lstStyle/>
           <a:p>
             <a:pPr algn="ctr"/>
+            <a:endParaRPr/>
           </a:p>
         </p:txBody>
       </p:sp>
@@ -6724,7 +6781,7 @@
           <a:noFill/>
         </p:spPr>
         <p:txBody>
-          <a:bodyPr wrap="square" anchor="t" lIns="0" rIns="0" tIns="0" bIns="0">
+          <a:bodyPr wrap="square" lIns="0" tIns="0" rIns="0" bIns="0" anchor="t">
             <a:spAutoFit/>
           </a:bodyPr>
           <a:lstStyle/>
@@ -6766,7 +6823,7 @@
           <a:noFill/>
         </p:spPr>
         <p:txBody>
-          <a:bodyPr wrap="square" anchor="t" lIns="0" rIns="0" tIns="0" bIns="0">
+          <a:bodyPr wrap="square" lIns="0" tIns="0" rIns="0" bIns="0" anchor="t">
             <a:spAutoFit/>
           </a:bodyPr>
           <a:lstStyle/>
@@ -6832,7 +6889,7 @@
           </a:fontRef>
         </p:style>
         <p:txBody>
-          <a:bodyPr rtlCol="0" anchor="ctr" wrap="square" lIns="76200" rIns="76200" tIns="38100" bIns="38100"/>
+          <a:bodyPr wrap="square" lIns="76200" tIns="38100" rIns="76200" bIns="38100" rtlCol="0" anchor="ctr"/>
           <a:lstStyle/>
           <a:p>
             <a:pPr algn="ctr">
@@ -6863,7 +6920,7 @@
         </p:nvSpPr>
         <p:spPr>
           <a:xfrm>
-            <a:off x="877824" y="3017520"/>
+            <a:off x="877824" y="3079700"/>
             <a:ext cx="4956048" cy="658368"/>
           </a:xfrm>
           <a:prstGeom prst="rect">
@@ -6872,7 +6929,7 @@
           <a:noFill/>
         </p:spPr>
         <p:txBody>
-          <a:bodyPr wrap="square" anchor="t" lIns="0" rIns="0" tIns="0" bIns="0">
+          <a:bodyPr wrap="square" lIns="0" tIns="0" rIns="0" bIns="0" anchor="t">
             <a:spAutoFit/>
           </a:bodyPr>
           <a:lstStyle/>
@@ -6889,13 +6946,400 @@
               </a:spcAft>
             </a:pPr>
             <a:r>
-              <a:rPr sz="1150" b="0">
-                <a:solidFill>
-                  <a:srgbClr val="989EA8"/>
-                </a:solidFill>
-                <a:latin typeface="Segoe UI"/>
-              </a:rPr>
-              <a:t>Görev 1 içerik analizi hattı: tür sınıflandırma, bilgi çıkarımı ve BM25 tabanlı mevzuat önerisi (RAG). Değerlendirme metrikleri ve uçtan uca entegrasyon; kaptan olarak ekip koordinasyonu.</a:t>
+              <a:rPr sz="1150" b="0" dirty="0" err="1">
+                <a:solidFill>
+                  <a:srgbClr val="989EA8"/>
+                </a:solidFill>
+                <a:latin typeface="Segoe UI"/>
+              </a:rPr>
+              <a:t>Görev</a:t>
+            </a:r>
+            <a:r>
+              <a:rPr sz="1150" b="0" dirty="0">
+                <a:solidFill>
+                  <a:srgbClr val="989EA8"/>
+                </a:solidFill>
+                <a:latin typeface="Segoe UI"/>
+              </a:rPr>
+              <a:t> 1 </a:t>
+            </a:r>
+            <a:r>
+              <a:rPr sz="1150" b="0" dirty="0" err="1">
+                <a:solidFill>
+                  <a:srgbClr val="989EA8"/>
+                </a:solidFill>
+                <a:latin typeface="Segoe UI"/>
+              </a:rPr>
+              <a:t>içerik</a:t>
+            </a:r>
+            <a:r>
+              <a:rPr sz="1150" b="0" dirty="0">
+                <a:solidFill>
+                  <a:srgbClr val="989EA8"/>
+                </a:solidFill>
+                <a:latin typeface="Segoe UI"/>
+              </a:rPr>
+              <a:t> </a:t>
+            </a:r>
+            <a:r>
+              <a:rPr sz="1150" b="0" dirty="0" err="1">
+                <a:solidFill>
+                  <a:srgbClr val="989EA8"/>
+                </a:solidFill>
+                <a:latin typeface="Segoe UI"/>
+              </a:rPr>
+              <a:t>analizi</a:t>
+            </a:r>
+            <a:r>
+              <a:rPr sz="1150" b="0" dirty="0">
+                <a:solidFill>
+                  <a:srgbClr val="989EA8"/>
+                </a:solidFill>
+                <a:latin typeface="Segoe UI"/>
+              </a:rPr>
+              <a:t> </a:t>
+            </a:r>
+            <a:r>
+              <a:rPr sz="1150" b="0" dirty="0" err="1">
+                <a:solidFill>
+                  <a:srgbClr val="989EA8"/>
+                </a:solidFill>
+                <a:latin typeface="Segoe UI"/>
+              </a:rPr>
+              <a:t>hattı</a:t>
+            </a:r>
+            <a:r>
+              <a:rPr sz="1150" b="0" dirty="0">
+                <a:solidFill>
+                  <a:srgbClr val="989EA8"/>
+                </a:solidFill>
+                <a:latin typeface="Segoe UI"/>
+              </a:rPr>
+              <a:t>: </a:t>
+            </a:r>
+            <a:r>
+              <a:rPr sz="1150" b="0" dirty="0" err="1">
+                <a:solidFill>
+                  <a:srgbClr val="989EA8"/>
+                </a:solidFill>
+                <a:latin typeface="Segoe UI"/>
+              </a:rPr>
+              <a:t>tür</a:t>
+            </a:r>
+            <a:r>
+              <a:rPr sz="1150" b="0" dirty="0">
+                <a:solidFill>
+                  <a:srgbClr val="989EA8"/>
+                </a:solidFill>
+                <a:latin typeface="Segoe UI"/>
+              </a:rPr>
+              <a:t> </a:t>
+            </a:r>
+            <a:r>
+              <a:rPr sz="1150" b="0" dirty="0" err="1">
+                <a:solidFill>
+                  <a:srgbClr val="989EA8"/>
+                </a:solidFill>
+                <a:latin typeface="Segoe UI"/>
+              </a:rPr>
+              <a:t>sınıflandırma</a:t>
+            </a:r>
+            <a:r>
+              <a:rPr sz="1150" b="0" dirty="0">
+                <a:solidFill>
+                  <a:srgbClr val="989EA8"/>
+                </a:solidFill>
+                <a:latin typeface="Segoe UI"/>
+              </a:rPr>
+              <a:t>, </a:t>
+            </a:r>
+            <a:r>
+              <a:rPr sz="1150" b="0" dirty="0" err="1">
+                <a:solidFill>
+                  <a:srgbClr val="989EA8"/>
+                </a:solidFill>
+                <a:latin typeface="Segoe UI"/>
+              </a:rPr>
+              <a:t>bilgi</a:t>
+            </a:r>
+            <a:r>
+              <a:rPr sz="1150" b="0" dirty="0">
+                <a:solidFill>
+                  <a:srgbClr val="989EA8"/>
+                </a:solidFill>
+                <a:latin typeface="Segoe UI"/>
+              </a:rPr>
+              <a:t> </a:t>
+            </a:r>
+            <a:r>
+              <a:rPr sz="1150" b="0" dirty="0" err="1">
+                <a:solidFill>
+                  <a:srgbClr val="989EA8"/>
+                </a:solidFill>
+                <a:latin typeface="Segoe UI"/>
+              </a:rPr>
+              <a:t>çıkarımı</a:t>
+            </a:r>
+            <a:r>
+              <a:rPr sz="1150" b="0" dirty="0">
+                <a:solidFill>
+                  <a:srgbClr val="989EA8"/>
+                </a:solidFill>
+                <a:latin typeface="Segoe UI"/>
+              </a:rPr>
+              <a:t> </a:t>
+            </a:r>
+            <a:r>
+              <a:rPr sz="1150" b="0" dirty="0" err="1">
+                <a:solidFill>
+                  <a:srgbClr val="989EA8"/>
+                </a:solidFill>
+                <a:latin typeface="Segoe UI"/>
+              </a:rPr>
+              <a:t>ve</a:t>
+            </a:r>
+            <a:r>
+              <a:rPr sz="1150" b="0" dirty="0">
+                <a:solidFill>
+                  <a:srgbClr val="989EA8"/>
+                </a:solidFill>
+                <a:latin typeface="Segoe UI"/>
+              </a:rPr>
+              <a:t> BM25 </a:t>
+            </a:r>
+            <a:r>
+              <a:rPr sz="1150" b="0" dirty="0" err="1">
+                <a:solidFill>
+                  <a:srgbClr val="989EA8"/>
+                </a:solidFill>
+                <a:latin typeface="Segoe UI"/>
+              </a:rPr>
+              <a:t>tabanlı</a:t>
+            </a:r>
+            <a:r>
+              <a:rPr sz="1150" b="0" dirty="0">
+                <a:solidFill>
+                  <a:srgbClr val="989EA8"/>
+                </a:solidFill>
+                <a:latin typeface="Segoe UI"/>
+              </a:rPr>
+              <a:t> </a:t>
+            </a:r>
+            <a:r>
+              <a:rPr sz="1150" b="0" dirty="0" err="1">
+                <a:solidFill>
+                  <a:srgbClr val="989EA8"/>
+                </a:solidFill>
+                <a:latin typeface="Segoe UI"/>
+              </a:rPr>
+              <a:t>mevzuat</a:t>
+            </a:r>
+            <a:r>
+              <a:rPr sz="1150" b="0" dirty="0">
+                <a:solidFill>
+                  <a:srgbClr val="989EA8"/>
+                </a:solidFill>
+                <a:latin typeface="Segoe UI"/>
+              </a:rPr>
+              <a:t> </a:t>
+            </a:r>
+            <a:r>
+              <a:rPr sz="1150" b="0" dirty="0" err="1">
+                <a:solidFill>
+                  <a:srgbClr val="989EA8"/>
+                </a:solidFill>
+                <a:latin typeface="Segoe UI"/>
+              </a:rPr>
+              <a:t>önerisi</a:t>
+            </a:r>
+            <a:r>
+              <a:rPr sz="1150" b="0" dirty="0">
+                <a:solidFill>
+                  <a:srgbClr val="989EA8"/>
+                </a:solidFill>
+                <a:latin typeface="Segoe UI"/>
+              </a:rPr>
+              <a:t> (RAG). </a:t>
+            </a:r>
+            <a:r>
+              <a:rPr sz="1150" b="0" dirty="0" err="1">
+                <a:solidFill>
+                  <a:srgbClr val="989EA8"/>
+                </a:solidFill>
+                <a:latin typeface="Segoe UI"/>
+              </a:rPr>
+              <a:t>Değerlendirme</a:t>
+            </a:r>
+            <a:r>
+              <a:rPr sz="1150" b="0" dirty="0">
+                <a:solidFill>
+                  <a:srgbClr val="989EA8"/>
+                </a:solidFill>
+                <a:latin typeface="Segoe UI"/>
+              </a:rPr>
+              <a:t> </a:t>
+            </a:r>
+            <a:r>
+              <a:rPr sz="1150" b="0" dirty="0" err="1">
+                <a:solidFill>
+                  <a:srgbClr val="989EA8"/>
+                </a:solidFill>
+                <a:latin typeface="Segoe UI"/>
+              </a:rPr>
+              <a:t>metrikleri</a:t>
+            </a:r>
+            <a:r>
+              <a:rPr sz="1150" b="0" dirty="0">
+                <a:solidFill>
+                  <a:srgbClr val="989EA8"/>
+                </a:solidFill>
+                <a:latin typeface="Segoe UI"/>
+              </a:rPr>
+              <a:t> </a:t>
+            </a:r>
+            <a:r>
+              <a:rPr sz="1150" b="0" dirty="0" err="1">
+                <a:solidFill>
+                  <a:srgbClr val="989EA8"/>
+                </a:solidFill>
+                <a:latin typeface="Segoe UI"/>
+              </a:rPr>
+              <a:t>ve</a:t>
+            </a:r>
+            <a:r>
+              <a:rPr sz="1150" b="0" dirty="0">
+                <a:solidFill>
+                  <a:srgbClr val="989EA8"/>
+                </a:solidFill>
+                <a:latin typeface="Segoe UI"/>
+              </a:rPr>
+              <a:t> </a:t>
+            </a:r>
+            <a:r>
+              <a:rPr sz="1150" b="0" dirty="0" err="1">
+                <a:solidFill>
+                  <a:srgbClr val="989EA8"/>
+                </a:solidFill>
+                <a:latin typeface="Segoe UI"/>
+              </a:rPr>
+              <a:t>uçtan</a:t>
+            </a:r>
+            <a:r>
+              <a:rPr sz="1150" b="0" dirty="0">
+                <a:solidFill>
+                  <a:srgbClr val="989EA8"/>
+                </a:solidFill>
+                <a:latin typeface="Segoe UI"/>
+              </a:rPr>
+              <a:t> </a:t>
+            </a:r>
+            <a:r>
+              <a:rPr sz="1150" b="0" dirty="0" err="1">
+                <a:solidFill>
+                  <a:srgbClr val="989EA8"/>
+                </a:solidFill>
+                <a:latin typeface="Segoe UI"/>
+              </a:rPr>
+              <a:t>uca</a:t>
+            </a:r>
+            <a:r>
+              <a:rPr sz="1150" b="0" dirty="0">
+                <a:solidFill>
+                  <a:srgbClr val="989EA8"/>
+                </a:solidFill>
+                <a:latin typeface="Segoe UI"/>
+              </a:rPr>
+              <a:t> </a:t>
+            </a:r>
+            <a:r>
+              <a:rPr sz="1150" b="0" dirty="0" err="1">
+                <a:solidFill>
+                  <a:srgbClr val="989EA8"/>
+                </a:solidFill>
+                <a:latin typeface="Segoe UI"/>
+              </a:rPr>
+              <a:t>entegrasyon</a:t>
+            </a:r>
+            <a:r>
+              <a:rPr sz="1150" b="0" dirty="0">
+                <a:solidFill>
+                  <a:srgbClr val="989EA8"/>
+                </a:solidFill>
+                <a:latin typeface="Segoe UI"/>
+              </a:rPr>
+              <a:t>; </a:t>
+            </a:r>
+            <a:r>
+              <a:rPr sz="1150" b="0" dirty="0" err="1">
+                <a:solidFill>
+                  <a:srgbClr val="989EA8"/>
+                </a:solidFill>
+                <a:latin typeface="Segoe UI"/>
+              </a:rPr>
+              <a:t>kaptan</a:t>
+            </a:r>
+            <a:r>
+              <a:rPr sz="1150" b="0" dirty="0">
+                <a:solidFill>
+                  <a:srgbClr val="989EA8"/>
+                </a:solidFill>
+                <a:latin typeface="Segoe UI"/>
+              </a:rPr>
+              <a:t> </a:t>
+            </a:r>
+            <a:r>
+              <a:rPr sz="1150" b="0" dirty="0" err="1">
+                <a:solidFill>
+                  <a:srgbClr val="989EA8"/>
+                </a:solidFill>
+                <a:latin typeface="Segoe UI"/>
+              </a:rPr>
+              <a:t>olarak</a:t>
+            </a:r>
+            <a:r>
+              <a:rPr sz="1150" b="0" dirty="0">
+                <a:solidFill>
+                  <a:srgbClr val="989EA8"/>
+                </a:solidFill>
+                <a:latin typeface="Segoe UI"/>
+              </a:rPr>
+              <a:t> </a:t>
+            </a:r>
+            <a:r>
+              <a:rPr sz="1150" b="0" dirty="0" err="1">
+                <a:solidFill>
+                  <a:srgbClr val="989EA8"/>
+                </a:solidFill>
+                <a:latin typeface="Segoe UI"/>
+              </a:rPr>
+              <a:t>ekip</a:t>
+            </a:r>
+            <a:r>
+              <a:rPr sz="1150" b="0" dirty="0">
+                <a:solidFill>
+                  <a:srgbClr val="989EA8"/>
+                </a:solidFill>
+                <a:latin typeface="Segoe UI"/>
+              </a:rPr>
+              <a:t> </a:t>
+            </a:r>
+            <a:r>
+              <a:rPr sz="1150" b="0" dirty="0" err="1">
+                <a:solidFill>
+                  <a:srgbClr val="989EA8"/>
+                </a:solidFill>
+                <a:latin typeface="Segoe UI"/>
+              </a:rPr>
+              <a:t>koordinasyonu</a:t>
+            </a:r>
+            <a:r>
+              <a:rPr sz="1150" b="0" dirty="0">
+                <a:solidFill>
+                  <a:srgbClr val="989EA8"/>
+                </a:solidFill>
+                <a:latin typeface="Segoe UI"/>
+              </a:rPr>
+              <a:t>.</a:t>
             </a:r>
           </a:p>
         </p:txBody>
@@ -6939,7 +7383,7 @@
           </a:fontRef>
         </p:style>
         <p:txBody>
-          <a:bodyPr rtlCol="0" anchor="ctr" wrap="square" lIns="76200" rIns="76200" tIns="38100" bIns="38100"/>
+          <a:bodyPr wrap="square" lIns="76200" tIns="38100" rIns="76200" bIns="38100" rtlCol="0" anchor="ctr"/>
           <a:lstStyle/>
           <a:p>
             <a:pPr algn="ctr">
@@ -7007,6 +7451,7 @@
           <a:lstStyle/>
           <a:p>
             <a:pPr algn="ctr"/>
+            <a:endParaRPr/>
           </a:p>
         </p:txBody>
       </p:sp>
@@ -7051,6 +7496,7 @@
           <a:lstStyle/>
           <a:p>
             <a:pPr algn="ctr"/>
+            <a:endParaRPr/>
           </a:p>
         </p:txBody>
       </p:sp>
@@ -7101,7 +7547,7 @@
           <a:noFill/>
         </p:spPr>
         <p:txBody>
-          <a:bodyPr wrap="square" anchor="t" lIns="0" rIns="0" tIns="0" bIns="0">
+          <a:bodyPr wrap="square" lIns="0" tIns="0" rIns="0" bIns="0" anchor="t">
             <a:spAutoFit/>
           </a:bodyPr>
           <a:lstStyle/>
@@ -7143,7 +7589,7 @@
           <a:noFill/>
         </p:spPr>
         <p:txBody>
-          <a:bodyPr wrap="square" anchor="t" lIns="0" rIns="0" tIns="0" bIns="0">
+          <a:bodyPr wrap="square" lIns="0" tIns="0" rIns="0" bIns="0" anchor="t">
             <a:spAutoFit/>
           </a:bodyPr>
           <a:lstStyle/>
@@ -7209,7 +7655,7 @@
           </a:fontRef>
         </p:style>
         <p:txBody>
-          <a:bodyPr rtlCol="0" anchor="ctr" wrap="square" lIns="76200" rIns="76200" tIns="38100" bIns="38100"/>
+          <a:bodyPr wrap="square" lIns="76200" tIns="38100" rIns="76200" bIns="38100" rtlCol="0" anchor="ctr"/>
           <a:lstStyle/>
           <a:p>
             <a:pPr algn="ctr">
@@ -7240,7 +7686,7 @@
         </p:nvSpPr>
         <p:spPr>
           <a:xfrm>
-            <a:off x="6455664" y="3017520"/>
+            <a:off x="6455664" y="3079700"/>
             <a:ext cx="4956048" cy="658368"/>
           </a:xfrm>
           <a:prstGeom prst="rect">
@@ -7249,7 +7695,7 @@
           <a:noFill/>
         </p:spPr>
         <p:txBody>
-          <a:bodyPr wrap="square" anchor="t" lIns="0" rIns="0" tIns="0" bIns="0">
+          <a:bodyPr wrap="square" lIns="0" tIns="0" rIns="0" bIns="0" anchor="t">
             <a:spAutoFit/>
           </a:bodyPr>
           <a:lstStyle/>
@@ -7266,13 +7712,346 @@
               </a:spcAft>
             </a:pPr>
             <a:r>
-              <a:rPr sz="1150" b="0">
-                <a:solidFill>
-                  <a:srgbClr val="989EA8"/>
-                </a:solidFill>
-                <a:latin typeface="Segoe UI"/>
-              </a:rPr>
-              <a:t>Sistem mimarisi ve orkestratör tasarımı; model-agnostik LLM katmanı (offline/çevrimiçi otomatik tespit). OCR ve özetleme ajanları; Görev 2 resmî yazı taslağı ve format öz-denetimi.</a:t>
+              <a:rPr sz="1150" b="0" dirty="0" err="1">
+                <a:solidFill>
+                  <a:srgbClr val="989EA8"/>
+                </a:solidFill>
+                <a:latin typeface="Segoe UI"/>
+              </a:rPr>
+              <a:t>Sistem</a:t>
+            </a:r>
+            <a:r>
+              <a:rPr sz="1150" b="0" dirty="0">
+                <a:solidFill>
+                  <a:srgbClr val="989EA8"/>
+                </a:solidFill>
+                <a:latin typeface="Segoe UI"/>
+              </a:rPr>
+              <a:t> </a:t>
+            </a:r>
+            <a:r>
+              <a:rPr sz="1150" b="0" dirty="0" err="1">
+                <a:solidFill>
+                  <a:srgbClr val="989EA8"/>
+                </a:solidFill>
+                <a:latin typeface="Segoe UI"/>
+              </a:rPr>
+              <a:t>mimarisi</a:t>
+            </a:r>
+            <a:r>
+              <a:rPr sz="1150" b="0" dirty="0">
+                <a:solidFill>
+                  <a:srgbClr val="989EA8"/>
+                </a:solidFill>
+                <a:latin typeface="Segoe UI"/>
+              </a:rPr>
+              <a:t> </a:t>
+            </a:r>
+            <a:r>
+              <a:rPr sz="1150" b="0" dirty="0" err="1">
+                <a:solidFill>
+                  <a:srgbClr val="989EA8"/>
+                </a:solidFill>
+                <a:latin typeface="Segoe UI"/>
+              </a:rPr>
+              <a:t>ve</a:t>
+            </a:r>
+            <a:r>
+              <a:rPr sz="1150" b="0" dirty="0">
+                <a:solidFill>
+                  <a:srgbClr val="989EA8"/>
+                </a:solidFill>
+                <a:latin typeface="Segoe UI"/>
+              </a:rPr>
+              <a:t> </a:t>
+            </a:r>
+            <a:r>
+              <a:rPr sz="1150" b="0" dirty="0" err="1">
+                <a:solidFill>
+                  <a:srgbClr val="989EA8"/>
+                </a:solidFill>
+                <a:latin typeface="Segoe UI"/>
+              </a:rPr>
+              <a:t>orkestratör</a:t>
+            </a:r>
+            <a:r>
+              <a:rPr sz="1150" b="0" dirty="0">
+                <a:solidFill>
+                  <a:srgbClr val="989EA8"/>
+                </a:solidFill>
+                <a:latin typeface="Segoe UI"/>
+              </a:rPr>
+              <a:t> </a:t>
+            </a:r>
+            <a:r>
+              <a:rPr sz="1150" b="0" dirty="0" err="1">
+                <a:solidFill>
+                  <a:srgbClr val="989EA8"/>
+                </a:solidFill>
+                <a:latin typeface="Segoe UI"/>
+              </a:rPr>
+              <a:t>tasarımı</a:t>
+            </a:r>
+            <a:r>
+              <a:rPr sz="1150" b="0" dirty="0">
+                <a:solidFill>
+                  <a:srgbClr val="989EA8"/>
+                </a:solidFill>
+                <a:latin typeface="Segoe UI"/>
+              </a:rPr>
+              <a:t>; model-</a:t>
+            </a:r>
+            <a:r>
+              <a:rPr sz="1150" b="0" dirty="0" err="1">
+                <a:solidFill>
+                  <a:srgbClr val="989EA8"/>
+                </a:solidFill>
+                <a:latin typeface="Segoe UI"/>
+              </a:rPr>
+              <a:t>agnostik</a:t>
+            </a:r>
+            <a:r>
+              <a:rPr sz="1150" b="0" dirty="0">
+                <a:solidFill>
+                  <a:srgbClr val="989EA8"/>
+                </a:solidFill>
+                <a:latin typeface="Segoe UI"/>
+              </a:rPr>
+              <a:t> LLM </a:t>
+            </a:r>
+            <a:r>
+              <a:rPr sz="1150" b="0" dirty="0" err="1">
+                <a:solidFill>
+                  <a:srgbClr val="989EA8"/>
+                </a:solidFill>
+                <a:latin typeface="Segoe UI"/>
+              </a:rPr>
+              <a:t>katmanı</a:t>
+            </a:r>
+            <a:r>
+              <a:rPr sz="1150" b="0" dirty="0">
+                <a:solidFill>
+                  <a:srgbClr val="989EA8"/>
+                </a:solidFill>
+                <a:latin typeface="Segoe UI"/>
+              </a:rPr>
+              <a:t> (offline/</a:t>
+            </a:r>
+            <a:r>
+              <a:rPr sz="1150" b="0" dirty="0" err="1">
+                <a:solidFill>
+                  <a:srgbClr val="989EA8"/>
+                </a:solidFill>
+                <a:latin typeface="Segoe UI"/>
+              </a:rPr>
+              <a:t>çevrimiçi</a:t>
+            </a:r>
+            <a:r>
+              <a:rPr sz="1150" b="0" dirty="0">
+                <a:solidFill>
+                  <a:srgbClr val="989EA8"/>
+                </a:solidFill>
+                <a:latin typeface="Segoe UI"/>
+              </a:rPr>
+              <a:t> </a:t>
+            </a:r>
+            <a:r>
+              <a:rPr sz="1150" b="0" dirty="0" err="1">
+                <a:solidFill>
+                  <a:srgbClr val="989EA8"/>
+                </a:solidFill>
+                <a:latin typeface="Segoe UI"/>
+              </a:rPr>
+              <a:t>otomatik</a:t>
+            </a:r>
+            <a:r>
+              <a:rPr sz="1150" b="0" dirty="0">
+                <a:solidFill>
+                  <a:srgbClr val="989EA8"/>
+                </a:solidFill>
+                <a:latin typeface="Segoe UI"/>
+              </a:rPr>
+              <a:t> </a:t>
+            </a:r>
+            <a:r>
+              <a:rPr sz="1150" b="0" dirty="0" err="1">
+                <a:solidFill>
+                  <a:srgbClr val="989EA8"/>
+                </a:solidFill>
+                <a:latin typeface="Segoe UI"/>
+              </a:rPr>
+              <a:t>tespit</a:t>
+            </a:r>
+            <a:r>
+              <a:rPr sz="1150" b="0" dirty="0">
+                <a:solidFill>
+                  <a:srgbClr val="989EA8"/>
+                </a:solidFill>
+                <a:latin typeface="Segoe UI"/>
+              </a:rPr>
+              <a:t>). OCR </a:t>
+            </a:r>
+            <a:r>
+              <a:rPr sz="1150" b="0" dirty="0" err="1">
+                <a:solidFill>
+                  <a:srgbClr val="989EA8"/>
+                </a:solidFill>
+                <a:latin typeface="Segoe UI"/>
+              </a:rPr>
+              <a:t>ve</a:t>
+            </a:r>
+            <a:r>
+              <a:rPr sz="1150" b="0" dirty="0">
+                <a:solidFill>
+                  <a:srgbClr val="989EA8"/>
+                </a:solidFill>
+                <a:latin typeface="Segoe UI"/>
+              </a:rPr>
+              <a:t> </a:t>
+            </a:r>
+            <a:r>
+              <a:rPr sz="1150" b="0" dirty="0" err="1">
+                <a:solidFill>
+                  <a:srgbClr val="989EA8"/>
+                </a:solidFill>
+                <a:latin typeface="Segoe UI"/>
+              </a:rPr>
+              <a:t>özetleme</a:t>
+            </a:r>
+            <a:r>
+              <a:rPr sz="1150" b="0" dirty="0">
+                <a:solidFill>
+                  <a:srgbClr val="989EA8"/>
+                </a:solidFill>
+                <a:latin typeface="Segoe UI"/>
+              </a:rPr>
+              <a:t> </a:t>
+            </a:r>
+            <a:r>
+              <a:rPr sz="1150" b="0" dirty="0" err="1">
+                <a:solidFill>
+                  <a:srgbClr val="989EA8"/>
+                </a:solidFill>
+                <a:latin typeface="Segoe UI"/>
+              </a:rPr>
+              <a:t>ajanları</a:t>
+            </a:r>
+            <a:r>
+              <a:rPr sz="1150" b="0" dirty="0">
+                <a:solidFill>
+                  <a:srgbClr val="989EA8"/>
+                </a:solidFill>
+                <a:latin typeface="Segoe UI"/>
+              </a:rPr>
+              <a:t>; </a:t>
+            </a:r>
+            <a:r>
+              <a:rPr sz="1150" b="0" dirty="0" err="1">
+                <a:solidFill>
+                  <a:srgbClr val="989EA8"/>
+                </a:solidFill>
+                <a:latin typeface="Segoe UI"/>
+              </a:rPr>
+              <a:t>Görev</a:t>
+            </a:r>
+            <a:r>
+              <a:rPr sz="1150" b="0" dirty="0">
+                <a:solidFill>
+                  <a:srgbClr val="989EA8"/>
+                </a:solidFill>
+                <a:latin typeface="Segoe UI"/>
+              </a:rPr>
+              <a:t> 2 </a:t>
+            </a:r>
+            <a:r>
+              <a:rPr sz="1150" b="0" dirty="0" err="1">
+                <a:solidFill>
+                  <a:srgbClr val="989EA8"/>
+                </a:solidFill>
+                <a:latin typeface="Segoe UI"/>
+              </a:rPr>
+              <a:t>resmî</a:t>
+            </a:r>
+            <a:r>
+              <a:rPr sz="1150" b="0" dirty="0">
+                <a:solidFill>
+                  <a:srgbClr val="989EA8"/>
+                </a:solidFill>
+                <a:latin typeface="Segoe UI"/>
+              </a:rPr>
+              <a:t> </a:t>
+            </a:r>
+            <a:r>
+              <a:rPr sz="1150" b="0" dirty="0" err="1">
+                <a:solidFill>
+                  <a:srgbClr val="989EA8"/>
+                </a:solidFill>
+                <a:latin typeface="Segoe UI"/>
+              </a:rPr>
+              <a:t>yazı</a:t>
+            </a:r>
+            <a:r>
+              <a:rPr sz="1150" b="0" dirty="0">
+                <a:solidFill>
+                  <a:srgbClr val="989EA8"/>
+                </a:solidFill>
+                <a:latin typeface="Segoe UI"/>
+              </a:rPr>
+              <a:t> </a:t>
+            </a:r>
+            <a:r>
+              <a:rPr sz="1150" b="0" dirty="0" err="1">
+                <a:solidFill>
+                  <a:srgbClr val="989EA8"/>
+                </a:solidFill>
+                <a:latin typeface="Segoe UI"/>
+              </a:rPr>
+              <a:t>taslağı</a:t>
+            </a:r>
+            <a:r>
+              <a:rPr sz="1150" b="0" dirty="0">
+                <a:solidFill>
+                  <a:srgbClr val="989EA8"/>
+                </a:solidFill>
+                <a:latin typeface="Segoe UI"/>
+              </a:rPr>
+              <a:t> </a:t>
+            </a:r>
+            <a:r>
+              <a:rPr sz="1150" b="0" dirty="0" err="1">
+                <a:solidFill>
+                  <a:srgbClr val="989EA8"/>
+                </a:solidFill>
+                <a:latin typeface="Segoe UI"/>
+              </a:rPr>
+              <a:t>ve</a:t>
+            </a:r>
+            <a:r>
+              <a:rPr sz="1150" b="0" dirty="0">
+                <a:solidFill>
+                  <a:srgbClr val="989EA8"/>
+                </a:solidFill>
+                <a:latin typeface="Segoe UI"/>
+              </a:rPr>
+              <a:t> format </a:t>
+            </a:r>
+            <a:r>
+              <a:rPr sz="1150" b="0" dirty="0" err="1">
+                <a:solidFill>
+                  <a:srgbClr val="989EA8"/>
+                </a:solidFill>
+                <a:latin typeface="Segoe UI"/>
+              </a:rPr>
+              <a:t>öz-denetimi</a:t>
+            </a:r>
+            <a:r>
+              <a:rPr sz="1150" b="0" dirty="0">
+                <a:solidFill>
+                  <a:srgbClr val="989EA8"/>
+                </a:solidFill>
+                <a:latin typeface="Segoe UI"/>
+              </a:rPr>
+              <a:t>.</a:t>
             </a:r>
           </a:p>
         </p:txBody>
@@ -7322,6 +8101,7 @@
           <a:lstStyle/>
           <a:p>
             <a:pPr algn="ctr"/>
+            <a:endParaRPr/>
           </a:p>
         </p:txBody>
       </p:sp>
@@ -7366,6 +8146,7 @@
           <a:lstStyle/>
           <a:p>
             <a:pPr algn="ctr"/>
+            <a:endParaRPr/>
           </a:p>
         </p:txBody>
       </p:sp>
@@ -7416,7 +8197,7 @@
           <a:noFill/>
         </p:spPr>
         <p:txBody>
-          <a:bodyPr wrap="square" anchor="t" lIns="0" rIns="0" tIns="0" bIns="0">
+          <a:bodyPr wrap="square" lIns="0" tIns="0" rIns="0" bIns="0" anchor="t">
             <a:spAutoFit/>
           </a:bodyPr>
           <a:lstStyle/>
@@ -7458,7 +8239,7 @@
           <a:noFill/>
         </p:spPr>
         <p:txBody>
-          <a:bodyPr wrap="square" anchor="t" lIns="0" rIns="0" tIns="0" bIns="0">
+          <a:bodyPr wrap="square" lIns="0" tIns="0" rIns="0" bIns="0" anchor="t">
             <a:spAutoFit/>
           </a:bodyPr>
           <a:lstStyle/>
@@ -7524,7 +8305,7 @@
           </a:fontRef>
         </p:style>
         <p:txBody>
-          <a:bodyPr rtlCol="0" anchor="ctr" wrap="square" lIns="76200" rIns="76200" tIns="38100" bIns="38100"/>
+          <a:bodyPr wrap="square" lIns="76200" tIns="38100" rIns="76200" bIns="38100" rtlCol="0" anchor="ctr"/>
           <a:lstStyle/>
           <a:p>
             <a:pPr algn="ctr">
@@ -7555,7 +8336,7 @@
         </p:nvSpPr>
         <p:spPr>
           <a:xfrm>
-            <a:off x="877824" y="5285232"/>
+            <a:off x="877824" y="5321808"/>
             <a:ext cx="4956048" cy="658368"/>
           </a:xfrm>
           <a:prstGeom prst="rect">
@@ -7564,7 +8345,7 @@
           <a:noFill/>
         </p:spPr>
         <p:txBody>
-          <a:bodyPr wrap="square" anchor="t" lIns="0" rIns="0" tIns="0" bIns="0">
+          <a:bodyPr wrap="square" lIns="0" tIns="0" rIns="0" bIns="0" anchor="t">
             <a:spAutoFit/>
           </a:bodyPr>
           <a:lstStyle/>
@@ -7581,13 +8362,382 @@
               </a:spcAft>
             </a:pPr>
             <a:r>
-              <a:rPr sz="1150" b="0">
-                <a:solidFill>
-                  <a:srgbClr val="989EA8"/>
-                </a:solidFill>
-                <a:latin typeface="Segoe UI"/>
-              </a:rPr>
-              <a:t>Sentetik kurgu evrak veri setleri ve etiketleme; 500+ otomatik testle kapsam güvencesi; teknik rapor ve dokümantasyon; sunum ve demo hazırlığı; TEKNOFEST şartname uyum takibi.</a:t>
+              <a:rPr sz="1150" b="0" dirty="0" err="1">
+                <a:solidFill>
+                  <a:srgbClr val="989EA8"/>
+                </a:solidFill>
+                <a:latin typeface="Segoe UI"/>
+              </a:rPr>
+              <a:t>Sentetik</a:t>
+            </a:r>
+            <a:r>
+              <a:rPr sz="1150" b="0" dirty="0">
+                <a:solidFill>
+                  <a:srgbClr val="989EA8"/>
+                </a:solidFill>
+                <a:latin typeface="Segoe UI"/>
+              </a:rPr>
+              <a:t> </a:t>
+            </a:r>
+            <a:r>
+              <a:rPr sz="1150" b="0" dirty="0" err="1">
+                <a:solidFill>
+                  <a:srgbClr val="989EA8"/>
+                </a:solidFill>
+                <a:latin typeface="Segoe UI"/>
+              </a:rPr>
+              <a:t>kurgu</a:t>
+            </a:r>
+            <a:r>
+              <a:rPr sz="1150" b="0" dirty="0">
+                <a:solidFill>
+                  <a:srgbClr val="989EA8"/>
+                </a:solidFill>
+                <a:latin typeface="Segoe UI"/>
+              </a:rPr>
+              <a:t> </a:t>
+            </a:r>
+            <a:r>
+              <a:rPr sz="1150" b="0" dirty="0" err="1">
+                <a:solidFill>
+                  <a:srgbClr val="989EA8"/>
+                </a:solidFill>
+                <a:latin typeface="Segoe UI"/>
+              </a:rPr>
+              <a:t>evrak</a:t>
+            </a:r>
+            <a:r>
+              <a:rPr sz="1150" b="0" dirty="0">
+                <a:solidFill>
+                  <a:srgbClr val="989EA8"/>
+                </a:solidFill>
+                <a:latin typeface="Segoe UI"/>
+              </a:rPr>
+              <a:t> </a:t>
+            </a:r>
+            <a:r>
+              <a:rPr sz="1150" b="0" dirty="0" err="1">
+                <a:solidFill>
+                  <a:srgbClr val="989EA8"/>
+                </a:solidFill>
+                <a:latin typeface="Segoe UI"/>
+              </a:rPr>
+              <a:t>veri</a:t>
+            </a:r>
+            <a:r>
+              <a:rPr sz="1150" b="0" dirty="0">
+                <a:solidFill>
+                  <a:srgbClr val="989EA8"/>
+                </a:solidFill>
+                <a:latin typeface="Segoe UI"/>
+              </a:rPr>
+              <a:t> </a:t>
+            </a:r>
+            <a:r>
+              <a:rPr sz="1150" b="0" dirty="0" err="1">
+                <a:solidFill>
+                  <a:srgbClr val="989EA8"/>
+                </a:solidFill>
+                <a:latin typeface="Segoe UI"/>
+              </a:rPr>
+              <a:t>setleri</a:t>
+            </a:r>
+            <a:r>
+              <a:rPr sz="1150" b="0" dirty="0">
+                <a:solidFill>
+                  <a:srgbClr val="989EA8"/>
+                </a:solidFill>
+                <a:latin typeface="Segoe UI"/>
+              </a:rPr>
+              <a:t> </a:t>
+            </a:r>
+            <a:r>
+              <a:rPr sz="1150" b="0" dirty="0" err="1">
+                <a:solidFill>
+                  <a:srgbClr val="989EA8"/>
+                </a:solidFill>
+                <a:latin typeface="Segoe UI"/>
+              </a:rPr>
+              <a:t>ve</a:t>
+            </a:r>
+            <a:r>
+              <a:rPr sz="1150" b="0" dirty="0">
+                <a:solidFill>
+                  <a:srgbClr val="989EA8"/>
+                </a:solidFill>
+                <a:latin typeface="Segoe UI"/>
+              </a:rPr>
+              <a:t> </a:t>
+            </a:r>
+            <a:r>
+              <a:rPr sz="1150" b="0" dirty="0" err="1">
+                <a:solidFill>
+                  <a:srgbClr val="989EA8"/>
+                </a:solidFill>
+                <a:latin typeface="Segoe UI"/>
+              </a:rPr>
+              <a:t>etiketleme</a:t>
+            </a:r>
+            <a:r>
+              <a:rPr sz="1150" b="0" dirty="0">
+                <a:solidFill>
+                  <a:srgbClr val="989EA8"/>
+                </a:solidFill>
+                <a:latin typeface="Segoe UI"/>
+              </a:rPr>
+              <a:t>; 500+ </a:t>
+            </a:r>
+            <a:r>
+              <a:rPr sz="1150" b="0" dirty="0" err="1">
+                <a:solidFill>
+                  <a:srgbClr val="989EA8"/>
+                </a:solidFill>
+                <a:latin typeface="Segoe UI"/>
+              </a:rPr>
+              <a:t>otomatik</a:t>
+            </a:r>
+            <a:r>
+              <a:rPr sz="1150" b="0" dirty="0">
+                <a:solidFill>
+                  <a:srgbClr val="989EA8"/>
+                </a:solidFill>
+                <a:latin typeface="Segoe UI"/>
+              </a:rPr>
+              <a:t> </a:t>
+            </a:r>
+            <a:r>
+              <a:rPr sz="1150" b="0" dirty="0" err="1">
+                <a:solidFill>
+                  <a:srgbClr val="989EA8"/>
+                </a:solidFill>
+                <a:latin typeface="Segoe UI"/>
+              </a:rPr>
+              <a:t>testle</a:t>
+            </a:r>
+            <a:r>
+              <a:rPr sz="1150" b="0" dirty="0">
+                <a:solidFill>
+                  <a:srgbClr val="989EA8"/>
+                </a:solidFill>
+                <a:latin typeface="Segoe UI"/>
+              </a:rPr>
+              <a:t> </a:t>
+            </a:r>
+            <a:r>
+              <a:rPr sz="1150" b="0" dirty="0" err="1">
+                <a:solidFill>
+                  <a:srgbClr val="989EA8"/>
+                </a:solidFill>
+                <a:latin typeface="Segoe UI"/>
+              </a:rPr>
+              <a:t>kapsam</a:t>
+            </a:r>
+            <a:r>
+              <a:rPr sz="1150" b="0" dirty="0">
+                <a:solidFill>
+                  <a:srgbClr val="989EA8"/>
+                </a:solidFill>
+                <a:latin typeface="Segoe UI"/>
+              </a:rPr>
+              <a:t> </a:t>
+            </a:r>
+            <a:r>
+              <a:rPr sz="1150" b="0" dirty="0" err="1">
+                <a:solidFill>
+                  <a:srgbClr val="989EA8"/>
+                </a:solidFill>
+                <a:latin typeface="Segoe UI"/>
+              </a:rPr>
+              <a:t>güvencesi</a:t>
+            </a:r>
+            <a:r>
+              <a:rPr sz="1150" b="0" dirty="0">
+                <a:solidFill>
+                  <a:srgbClr val="989EA8"/>
+                </a:solidFill>
+                <a:latin typeface="Segoe UI"/>
+              </a:rPr>
+              <a:t>; </a:t>
+            </a:r>
+            <a:r>
+              <a:rPr sz="1150" b="0" dirty="0" err="1">
+                <a:solidFill>
+                  <a:srgbClr val="989EA8"/>
+                </a:solidFill>
+                <a:latin typeface="Segoe UI"/>
+              </a:rPr>
+              <a:t>teknik</a:t>
+            </a:r>
+            <a:r>
+              <a:rPr sz="1150" b="0" dirty="0">
+                <a:solidFill>
+                  <a:srgbClr val="989EA8"/>
+                </a:solidFill>
+                <a:latin typeface="Segoe UI"/>
+              </a:rPr>
+              <a:t> </a:t>
+            </a:r>
+            <a:r>
+              <a:rPr sz="1150" b="0" dirty="0" err="1">
+                <a:solidFill>
+                  <a:srgbClr val="989EA8"/>
+                </a:solidFill>
+                <a:latin typeface="Segoe UI"/>
+              </a:rPr>
+              <a:t>rapor</a:t>
+            </a:r>
+            <a:r>
+              <a:rPr sz="1150" b="0" dirty="0">
+                <a:solidFill>
+                  <a:srgbClr val="989EA8"/>
+                </a:solidFill>
+                <a:latin typeface="Segoe UI"/>
+              </a:rPr>
+              <a:t> </a:t>
+            </a:r>
+            <a:r>
+              <a:rPr sz="1150" b="0" dirty="0" err="1">
+                <a:solidFill>
+                  <a:srgbClr val="989EA8"/>
+                </a:solidFill>
+                <a:latin typeface="Segoe UI"/>
+              </a:rPr>
+              <a:t>ve</a:t>
+            </a:r>
+            <a:r>
+              <a:rPr sz="1150" b="0" dirty="0">
+                <a:solidFill>
+                  <a:srgbClr val="989EA8"/>
+                </a:solidFill>
+                <a:latin typeface="Segoe UI"/>
+              </a:rPr>
+              <a:t> </a:t>
+            </a:r>
+            <a:r>
+              <a:rPr sz="1150" b="0" dirty="0" err="1">
+                <a:solidFill>
+                  <a:srgbClr val="989EA8"/>
+                </a:solidFill>
+                <a:latin typeface="Segoe UI"/>
+              </a:rPr>
+              <a:t>dokümantasyon</a:t>
+            </a:r>
+            <a:r>
+              <a:rPr sz="1150" b="0" dirty="0">
+                <a:solidFill>
+                  <a:srgbClr val="989EA8"/>
+                </a:solidFill>
+                <a:latin typeface="Segoe UI"/>
+              </a:rPr>
+              <a:t>; </a:t>
+            </a:r>
+            <a:r>
+              <a:rPr sz="1150" b="0" dirty="0" err="1">
+                <a:solidFill>
+                  <a:srgbClr val="989EA8"/>
+                </a:solidFill>
+                <a:latin typeface="Segoe UI"/>
+              </a:rPr>
+              <a:t>sunum</a:t>
+            </a:r>
+            <a:r>
+              <a:rPr sz="1150" b="0" dirty="0">
+                <a:solidFill>
+                  <a:srgbClr val="989EA8"/>
+                </a:solidFill>
+                <a:latin typeface="Segoe UI"/>
+              </a:rPr>
+              <a:t> </a:t>
+            </a:r>
+            <a:r>
+              <a:rPr sz="1150" b="0" dirty="0" err="1">
+                <a:solidFill>
+                  <a:srgbClr val="989EA8"/>
+                </a:solidFill>
+                <a:latin typeface="Segoe UI"/>
+              </a:rPr>
+              <a:t>ve</a:t>
+            </a:r>
+            <a:r>
+              <a:rPr sz="1150" b="0" dirty="0">
+                <a:solidFill>
+                  <a:srgbClr val="989EA8"/>
+                </a:solidFill>
+                <a:latin typeface="Segoe UI"/>
+              </a:rPr>
+              <a:t> demo </a:t>
+            </a:r>
+            <a:r>
+              <a:rPr sz="1150" b="0" dirty="0" err="1">
+                <a:solidFill>
+                  <a:srgbClr val="989EA8"/>
+                </a:solidFill>
+                <a:latin typeface="Segoe UI"/>
+              </a:rPr>
+              <a:t>hazırlığı</a:t>
+            </a:r>
+            <a:r>
+              <a:rPr sz="1150" b="0" dirty="0">
+                <a:solidFill>
+                  <a:srgbClr val="989EA8"/>
+                </a:solidFill>
+                <a:latin typeface="Segoe UI"/>
+              </a:rPr>
+              <a:t>; TEKNOFEST </a:t>
+            </a:r>
+            <a:r>
+              <a:rPr sz="1150" b="0" dirty="0" err="1">
+                <a:solidFill>
+                  <a:srgbClr val="989EA8"/>
+                </a:solidFill>
+                <a:latin typeface="Segoe UI"/>
+              </a:rPr>
+              <a:t>şartname</a:t>
+            </a:r>
+            <a:r>
+              <a:rPr sz="1150" b="0" dirty="0">
+                <a:solidFill>
+                  <a:srgbClr val="989EA8"/>
+                </a:solidFill>
+                <a:latin typeface="Segoe UI"/>
+              </a:rPr>
+              <a:t> </a:t>
+            </a:r>
+            <a:r>
+              <a:rPr sz="1150" b="0" dirty="0" err="1">
+                <a:solidFill>
+                  <a:srgbClr val="989EA8"/>
+                </a:solidFill>
+                <a:latin typeface="Segoe UI"/>
+              </a:rPr>
+              <a:t>uyum</a:t>
+            </a:r>
+            <a:r>
+              <a:rPr sz="1150" b="0" dirty="0">
+                <a:solidFill>
+                  <a:srgbClr val="989EA8"/>
+                </a:solidFill>
+                <a:latin typeface="Segoe UI"/>
+              </a:rPr>
+              <a:t> </a:t>
+            </a:r>
+            <a:r>
+              <a:rPr sz="1150" b="0" dirty="0" err="1">
+                <a:solidFill>
+                  <a:srgbClr val="989EA8"/>
+                </a:solidFill>
+                <a:latin typeface="Segoe UI"/>
+              </a:rPr>
+              <a:t>takibi</a:t>
+            </a:r>
+            <a:r>
+              <a:rPr sz="1150" b="0" dirty="0">
+                <a:solidFill>
+                  <a:srgbClr val="989EA8"/>
+                </a:solidFill>
+                <a:latin typeface="Segoe UI"/>
+              </a:rPr>
+              <a:t>.</a:t>
             </a:r>
           </a:p>
         </p:txBody>
@@ -7637,6 +8787,7 @@
           <a:lstStyle/>
           <a:p>
             <a:pPr algn="ctr"/>
+            <a:endParaRPr/>
           </a:p>
         </p:txBody>
       </p:sp>
@@ -7681,6 +8832,7 @@
           <a:lstStyle/>
           <a:p>
             <a:pPr algn="ctr"/>
+            <a:endParaRPr/>
           </a:p>
         </p:txBody>
       </p:sp>
@@ -7731,7 +8883,7 @@
           <a:noFill/>
         </p:spPr>
         <p:txBody>
-          <a:bodyPr wrap="square" anchor="t" lIns="0" rIns="0" tIns="0" bIns="0">
+          <a:bodyPr wrap="square" lIns="0" tIns="0" rIns="0" bIns="0" anchor="t">
             <a:spAutoFit/>
           </a:bodyPr>
           <a:lstStyle/>
@@ -7773,7 +8925,7 @@
           <a:noFill/>
         </p:spPr>
         <p:txBody>
-          <a:bodyPr wrap="square" anchor="t" lIns="0" rIns="0" tIns="0" bIns="0">
+          <a:bodyPr wrap="square" lIns="0" tIns="0" rIns="0" bIns="0" anchor="t">
             <a:spAutoFit/>
           </a:bodyPr>
           <a:lstStyle/>
@@ -7839,7 +8991,7 @@
           </a:fontRef>
         </p:style>
         <p:txBody>
-          <a:bodyPr rtlCol="0" anchor="ctr" wrap="square" lIns="76200" rIns="76200" tIns="38100" bIns="38100"/>
+          <a:bodyPr wrap="square" lIns="76200" tIns="38100" rIns="76200" bIns="38100" rtlCol="0" anchor="ctr"/>
           <a:lstStyle/>
           <a:p>
             <a:pPr algn="ctr">
@@ -7870,7 +9022,7 @@
         </p:nvSpPr>
         <p:spPr>
           <a:xfrm>
-            <a:off x="6455664" y="5285232"/>
+            <a:off x="6455664" y="5372386"/>
             <a:ext cx="4956048" cy="658368"/>
           </a:xfrm>
           <a:prstGeom prst="rect">
@@ -7879,7 +9031,7 @@
           <a:noFill/>
         </p:spPr>
         <p:txBody>
-          <a:bodyPr wrap="square" anchor="t" lIns="0" rIns="0" tIns="0" bIns="0">
+          <a:bodyPr wrap="square" lIns="0" tIns="0" rIns="0" bIns="0" anchor="t">
             <a:spAutoFit/>
           </a:bodyPr>
           <a:lstStyle/>
@@ -7896,13 +9048,328 @@
               </a:spcAft>
             </a:pPr>
             <a:r>
-              <a:rPr sz="1150" b="0">
-                <a:solidFill>
-                  <a:srgbClr val="989EA8"/>
-                </a:solidFill>
-                <a:latin typeface="Segoe UI"/>
-              </a:rPr>
-              <a:t>Görev 1 eksik bilgi tespiti; Görev 2 birim yönlendirme, kullanıcı bilgilendirme ve eksik bilgi talebi. Önceliklendirme/triyaj, KVKK maskeleme ve web arayüzü.</a:t>
+              <a:rPr sz="1150" b="0" dirty="0" err="1">
+                <a:solidFill>
+                  <a:srgbClr val="989EA8"/>
+                </a:solidFill>
+                <a:latin typeface="Segoe UI"/>
+              </a:rPr>
+              <a:t>Görev</a:t>
+            </a:r>
+            <a:r>
+              <a:rPr sz="1150" b="0" dirty="0">
+                <a:solidFill>
+                  <a:srgbClr val="989EA8"/>
+                </a:solidFill>
+                <a:latin typeface="Segoe UI"/>
+              </a:rPr>
+              <a:t> 1 </a:t>
+            </a:r>
+            <a:r>
+              <a:rPr sz="1150" b="0" dirty="0" err="1">
+                <a:solidFill>
+                  <a:srgbClr val="989EA8"/>
+                </a:solidFill>
+                <a:latin typeface="Segoe UI"/>
+              </a:rPr>
+              <a:t>eksik</a:t>
+            </a:r>
+            <a:r>
+              <a:rPr sz="1150" b="0" dirty="0">
+                <a:solidFill>
+                  <a:srgbClr val="989EA8"/>
+                </a:solidFill>
+                <a:latin typeface="Segoe UI"/>
+              </a:rPr>
+              <a:t> </a:t>
+            </a:r>
+            <a:r>
+              <a:rPr sz="1150" b="0" dirty="0" err="1">
+                <a:solidFill>
+                  <a:srgbClr val="989EA8"/>
+                </a:solidFill>
+                <a:latin typeface="Segoe UI"/>
+              </a:rPr>
+              <a:t>bilgi</a:t>
+            </a:r>
+            <a:r>
+              <a:rPr sz="1150" b="0" dirty="0">
+                <a:solidFill>
+                  <a:srgbClr val="989EA8"/>
+                </a:solidFill>
+                <a:latin typeface="Segoe UI"/>
+              </a:rPr>
+              <a:t> </a:t>
+            </a:r>
+            <a:r>
+              <a:rPr sz="1150" b="0" dirty="0" err="1">
+                <a:solidFill>
+                  <a:srgbClr val="989EA8"/>
+                </a:solidFill>
+                <a:latin typeface="Segoe UI"/>
+              </a:rPr>
+              <a:t>tespiti</a:t>
+            </a:r>
+            <a:r>
+              <a:rPr sz="1150" b="0" dirty="0">
+                <a:solidFill>
+                  <a:srgbClr val="989EA8"/>
+                </a:solidFill>
+                <a:latin typeface="Segoe UI"/>
+              </a:rPr>
+              <a:t>; </a:t>
+            </a:r>
+            <a:r>
+              <a:rPr sz="1150" b="0" dirty="0" err="1">
+                <a:solidFill>
+                  <a:srgbClr val="989EA8"/>
+                </a:solidFill>
+                <a:latin typeface="Segoe UI"/>
+              </a:rPr>
+              <a:t>Görev</a:t>
+            </a:r>
+            <a:r>
+              <a:rPr sz="1150" b="0" dirty="0">
+                <a:solidFill>
+                  <a:srgbClr val="989EA8"/>
+                </a:solidFill>
+                <a:latin typeface="Segoe UI"/>
+              </a:rPr>
+              <a:t> 2 </a:t>
+            </a:r>
+            <a:r>
+              <a:rPr sz="1150" b="0" dirty="0" err="1">
+                <a:solidFill>
+                  <a:srgbClr val="989EA8"/>
+                </a:solidFill>
+                <a:latin typeface="Segoe UI"/>
+              </a:rPr>
+              <a:t>birim</a:t>
+            </a:r>
+            <a:r>
+              <a:rPr sz="1150" b="0" dirty="0">
+                <a:solidFill>
+                  <a:srgbClr val="989EA8"/>
+                </a:solidFill>
+                <a:latin typeface="Segoe UI"/>
+              </a:rPr>
+              <a:t> </a:t>
+            </a:r>
+            <a:r>
+              <a:rPr sz="1150" b="0" dirty="0" err="1">
+                <a:solidFill>
+                  <a:srgbClr val="989EA8"/>
+                </a:solidFill>
+                <a:latin typeface="Segoe UI"/>
+              </a:rPr>
+              <a:t>yönlendirme</a:t>
+            </a:r>
+            <a:r>
+              <a:rPr sz="1150" b="0" dirty="0">
+                <a:solidFill>
+                  <a:srgbClr val="989EA8"/>
+                </a:solidFill>
+                <a:latin typeface="Segoe UI"/>
+              </a:rPr>
+              <a:t>, </a:t>
+            </a:r>
+            <a:r>
+              <a:rPr sz="1150" b="0" dirty="0" err="1">
+                <a:solidFill>
+                  <a:srgbClr val="989EA8"/>
+                </a:solidFill>
+                <a:latin typeface="Segoe UI"/>
+              </a:rPr>
+              <a:t>kullanıcı</a:t>
+            </a:r>
+            <a:r>
+              <a:rPr sz="1150" b="0" dirty="0">
+                <a:solidFill>
+                  <a:srgbClr val="989EA8"/>
+                </a:solidFill>
+                <a:latin typeface="Segoe UI"/>
+              </a:rPr>
+              <a:t> </a:t>
+            </a:r>
+            <a:r>
+              <a:rPr sz="1150" b="0" dirty="0" err="1">
+                <a:solidFill>
+                  <a:srgbClr val="989EA8"/>
+                </a:solidFill>
+                <a:latin typeface="Segoe UI"/>
+              </a:rPr>
+              <a:t>bilgilendirme</a:t>
+            </a:r>
+            <a:r>
+              <a:rPr sz="1150" b="0" dirty="0">
+                <a:solidFill>
+                  <a:srgbClr val="989EA8"/>
+                </a:solidFill>
+                <a:latin typeface="Segoe UI"/>
+              </a:rPr>
+              <a:t> </a:t>
+            </a:r>
+            <a:r>
+              <a:rPr sz="1150" b="0" dirty="0" err="1">
+                <a:solidFill>
+                  <a:srgbClr val="989EA8"/>
+                </a:solidFill>
+                <a:latin typeface="Segoe UI"/>
+              </a:rPr>
+              <a:t>ve</a:t>
+            </a:r>
+            <a:r>
+              <a:rPr sz="1150" b="0" dirty="0">
+                <a:solidFill>
+                  <a:srgbClr val="989EA8"/>
+                </a:solidFill>
+                <a:latin typeface="Segoe UI"/>
+              </a:rPr>
+              <a:t> </a:t>
+            </a:r>
+            <a:r>
+              <a:rPr sz="1150" b="0" dirty="0" err="1">
+                <a:solidFill>
+                  <a:srgbClr val="989EA8"/>
+                </a:solidFill>
+                <a:latin typeface="Segoe UI"/>
+              </a:rPr>
+              <a:t>eksik</a:t>
+            </a:r>
+            <a:r>
+              <a:rPr sz="1150" b="0" dirty="0">
+                <a:solidFill>
+                  <a:srgbClr val="989EA8"/>
+                </a:solidFill>
+                <a:latin typeface="Segoe UI"/>
+              </a:rPr>
+              <a:t> </a:t>
+            </a:r>
+            <a:r>
+              <a:rPr sz="1150" b="0" dirty="0" err="1">
+                <a:solidFill>
+                  <a:srgbClr val="989EA8"/>
+                </a:solidFill>
+                <a:latin typeface="Segoe UI"/>
+              </a:rPr>
+              <a:t>bilgi</a:t>
+            </a:r>
+            <a:r>
+              <a:rPr sz="1150" b="0" dirty="0">
+                <a:solidFill>
+                  <a:srgbClr val="989EA8"/>
+                </a:solidFill>
+                <a:latin typeface="Segoe UI"/>
+              </a:rPr>
+              <a:t> </a:t>
+            </a:r>
+            <a:r>
+              <a:rPr sz="1150" b="0" dirty="0" err="1">
+                <a:solidFill>
+                  <a:srgbClr val="989EA8"/>
+                </a:solidFill>
+                <a:latin typeface="Segoe UI"/>
+              </a:rPr>
+              <a:t>talebi</a:t>
+            </a:r>
+            <a:r>
+              <a:rPr sz="1150" b="0" dirty="0">
+                <a:solidFill>
+                  <a:srgbClr val="989EA8"/>
+                </a:solidFill>
+                <a:latin typeface="Segoe UI"/>
+              </a:rPr>
+              <a:t>. </a:t>
+            </a:r>
+            <a:r>
+              <a:rPr sz="1150" b="0" dirty="0" err="1">
+                <a:solidFill>
+                  <a:srgbClr val="989EA8"/>
+                </a:solidFill>
+                <a:latin typeface="Segoe UI"/>
+              </a:rPr>
+              <a:t>Önceliklendirme</a:t>
+            </a:r>
+            <a:r>
+              <a:rPr sz="1150" b="0" dirty="0">
+                <a:solidFill>
+                  <a:srgbClr val="989EA8"/>
+                </a:solidFill>
+                <a:latin typeface="Segoe UI"/>
+              </a:rPr>
+              <a:t>/</a:t>
+            </a:r>
+            <a:r>
+              <a:rPr sz="1150" b="0" dirty="0" err="1">
+                <a:solidFill>
+                  <a:srgbClr val="989EA8"/>
+                </a:solidFill>
+                <a:latin typeface="Segoe UI"/>
+              </a:rPr>
+              <a:t>triyaj</a:t>
+            </a:r>
+            <a:r>
+              <a:rPr sz="1150" b="0" dirty="0">
+                <a:solidFill>
+                  <a:srgbClr val="989EA8"/>
+                </a:solidFill>
+                <a:latin typeface="Segoe UI"/>
+              </a:rPr>
+              <a:t>, KVKK </a:t>
+            </a:r>
+            <a:r>
+              <a:rPr sz="1150" b="0" dirty="0" err="1">
+                <a:solidFill>
+                  <a:srgbClr val="989EA8"/>
+                </a:solidFill>
+                <a:latin typeface="Segoe UI"/>
+              </a:rPr>
+              <a:t>maskeleme</a:t>
+            </a:r>
+            <a:r>
+              <a:rPr sz="1150" b="0" dirty="0">
+                <a:solidFill>
+                  <a:srgbClr val="989EA8"/>
+                </a:solidFill>
+                <a:latin typeface="Segoe UI"/>
+              </a:rPr>
+              <a:t> </a:t>
+            </a:r>
+            <a:r>
+              <a:rPr sz="1150" b="0" dirty="0" err="1">
+                <a:solidFill>
+                  <a:srgbClr val="989EA8"/>
+                </a:solidFill>
+                <a:latin typeface="Segoe UI"/>
+              </a:rPr>
+              <a:t>ve</a:t>
+            </a:r>
+            <a:r>
+              <a:rPr sz="1150" b="0" dirty="0">
+                <a:solidFill>
+                  <a:srgbClr val="989EA8"/>
+                </a:solidFill>
+                <a:latin typeface="Segoe UI"/>
+              </a:rPr>
+              <a:t> web </a:t>
+            </a:r>
+            <a:r>
+              <a:rPr sz="1150" b="0" dirty="0" err="1">
+                <a:solidFill>
+                  <a:srgbClr val="989EA8"/>
+                </a:solidFill>
+                <a:latin typeface="Segoe UI"/>
+              </a:rPr>
+              <a:t>arayüzü</a:t>
+            </a:r>
+            <a:r>
+              <a:rPr sz="1150" b="0" dirty="0">
+                <a:solidFill>
+                  <a:srgbClr val="989EA8"/>
+                </a:solidFill>
+                <a:latin typeface="Segoe UI"/>
+              </a:rPr>
+              <a:t>.</a:t>
             </a:r>
           </a:p>
         </p:txBody>
@@ -7924,7 +9391,7 @@
           <a:noFill/>
         </p:spPr>
         <p:txBody>
-          <a:bodyPr wrap="square" anchor="t" lIns="0" rIns="0" tIns="0" bIns="0">
+          <a:bodyPr wrap="square" lIns="0" tIns="0" rIns="0" bIns="0" anchor="t">
             <a:spAutoFit/>
           </a:bodyPr>
           <a:lstStyle/>
@@ -7990,6 +9457,7 @@
           <a:lstStyle/>
           <a:p>
             <a:pPr algn="ctr"/>
+            <a:endParaRPr/>
           </a:p>
         </p:txBody>
       </p:sp>
@@ -8010,7 +9478,7 @@
           <a:noFill/>
         </p:spPr>
         <p:txBody>
-          <a:bodyPr wrap="square" anchor="t" lIns="0" rIns="0" tIns="0" bIns="0">
+          <a:bodyPr wrap="square" lIns="0" tIns="0" rIns="0" bIns="0" anchor="t">
             <a:spAutoFit/>
           </a:bodyPr>
           <a:lstStyle/>
@@ -8061,7 +9529,7 @@
           <a:noFill/>
         </p:spPr>
         <p:txBody>
-          <a:bodyPr wrap="square" anchor="t" lIns="0" rIns="0" tIns="0" bIns="0">
+          <a:bodyPr wrap="square" lIns="0" tIns="0" rIns="0" bIns="0" anchor="t">
             <a:spAutoFit/>
           </a:bodyPr>
           <a:lstStyle/>
@@ -8095,7 +9563,7 @@
 </file>
 
 <file path=ppt/slides/slide5.xml><?xml version="1.0" encoding="utf-8"?>
-<p:sld xmlns:a="http://schemas.openxmlformats.org/drawingml/2006/main" xmlns:p="http://schemas.openxmlformats.org/presentationml/2006/main" xmlns:r="http://schemas.openxmlformats.org/officeDocument/2006/relationships">
+<p:sld xmlns:a="http://schemas.openxmlformats.org/drawingml/2006/main" xmlns:r="http://schemas.openxmlformats.org/officeDocument/2006/relationships" xmlns:p="http://schemas.openxmlformats.org/presentationml/2006/main">
   <p:cSld>
     <p:bg>
       <p:bgPr>
@@ -8111,7 +9579,14 @@
         <p:cNvGrpSpPr/>
         <p:nvPr/>
       </p:nvGrpSpPr>
-      <p:grpSpPr/>
+      <p:grpSpPr>
+        <a:xfrm>
+          <a:off x="0" y="0"/>
+          <a:ext cx="0" cy="0"/>
+          <a:chOff x="0" y="0"/>
+          <a:chExt cx="0" cy="0"/>
+        </a:xfrm>
+      </p:grpSpPr>
       <p:sp>
         <p:nvSpPr>
           <p:cNvPr id="2" name="TextBox 1"/>
@@ -8129,7 +9604,7 @@
           <a:noFill/>
         </p:spPr>
         <p:txBody>
-          <a:bodyPr wrap="square" anchor="t" lIns="0" rIns="0" tIns="0" bIns="0">
+          <a:bodyPr wrap="square" lIns="0" tIns="0" rIns="0" bIns="0" anchor="t">
             <a:spAutoFit/>
           </a:bodyPr>
           <a:lstStyle/>
@@ -8171,7 +9646,7 @@
           <a:noFill/>
         </p:spPr>
         <p:txBody>
-          <a:bodyPr wrap="square" anchor="t" lIns="0" rIns="0" tIns="0" bIns="0">
+          <a:bodyPr wrap="square" lIns="0" tIns="0" rIns="0" bIns="0" anchor="t">
             <a:spAutoFit/>
           </a:bodyPr>
           <a:lstStyle/>
@@ -8265,6 +9740,7 @@
           <a:lstStyle/>
           <a:p>
             <a:pPr algn="ctr"/>
+            <a:endParaRPr/>
           </a:p>
         </p:txBody>
       </p:sp>
@@ -8311,6 +9787,7 @@
           <a:lstStyle/>
           <a:p>
             <a:pPr algn="ctr"/>
+            <a:endParaRPr/>
           </a:p>
         </p:txBody>
       </p:sp>
@@ -8355,6 +9832,7 @@
           <a:lstStyle/>
           <a:p>
             <a:pPr algn="ctr"/>
+            <a:endParaRPr/>
           </a:p>
         </p:txBody>
       </p:sp>
@@ -8399,6 +9877,7 @@
           <a:lstStyle/>
           <a:p>
             <a:pPr algn="ctr"/>
+            <a:endParaRPr/>
           </a:p>
         </p:txBody>
       </p:sp>
@@ -8419,7 +9898,7 @@
           <a:noFill/>
         </p:spPr>
         <p:txBody>
-          <a:bodyPr wrap="square" anchor="ctr" lIns="0" rIns="0" tIns="0" bIns="0">
+          <a:bodyPr wrap="square" lIns="0" tIns="0" rIns="0" bIns="0" anchor="ctr">
             <a:spAutoFit/>
           </a:bodyPr>
           <a:lstStyle/>
@@ -8461,7 +9940,7 @@
           <a:noFill/>
         </p:spPr>
         <p:txBody>
-          <a:bodyPr wrap="square" anchor="t" lIns="0" rIns="0" tIns="0" bIns="0">
+          <a:bodyPr wrap="square" lIns="0" tIns="0" rIns="0" bIns="0" anchor="t">
             <a:spAutoFit/>
           </a:bodyPr>
           <a:lstStyle/>
@@ -8527,7 +10006,7 @@
           </a:fontRef>
         </p:style>
         <p:txBody>
-          <a:bodyPr rtlCol="0" anchor="ctr" wrap="square" lIns="76200" rIns="76200" tIns="38100" bIns="38100"/>
+          <a:bodyPr wrap="square" lIns="76200" tIns="38100" rIns="76200" bIns="38100" rtlCol="0" anchor="ctr"/>
           <a:lstStyle/>
           <a:p>
             <a:pPr algn="ctr">
@@ -8591,6 +10070,7 @@
           <a:lstStyle/>
           <a:p>
             <a:pPr algn="ctr"/>
+            <a:endParaRPr/>
           </a:p>
         </p:txBody>
       </p:sp>
@@ -8611,7 +10091,7 @@
           <a:noFill/>
         </p:spPr>
         <p:txBody>
-          <a:bodyPr wrap="square" anchor="t" lIns="0" rIns="0" tIns="0" bIns="0">
+          <a:bodyPr wrap="square" lIns="0" tIns="0" rIns="0" bIns="0" anchor="t">
             <a:spAutoFit/>
           </a:bodyPr>
           <a:lstStyle/>
@@ -8677,7 +10157,7 @@
           </a:fontRef>
         </p:style>
         <p:txBody>
-          <a:bodyPr rtlCol="0" anchor="ctr" wrap="square" lIns="76200" rIns="76200" tIns="38100" bIns="38100"/>
+          <a:bodyPr wrap="square" lIns="76200" tIns="38100" rIns="76200" bIns="38100" rtlCol="0" anchor="ctr"/>
           <a:lstStyle/>
           <a:p>
             <a:pPr algn="ctr">
@@ -8717,7 +10197,7 @@
           <a:noFill/>
         </p:spPr>
         <p:txBody>
-          <a:bodyPr wrap="square" anchor="t" lIns="0" rIns="0" tIns="0" bIns="0">
+          <a:bodyPr wrap="square" lIns="0" tIns="0" rIns="0" bIns="0" anchor="t">
             <a:spAutoFit/>
           </a:bodyPr>
           <a:lstStyle/>
@@ -8783,7 +10263,7 @@
           </a:fontRef>
         </p:style>
         <p:txBody>
-          <a:bodyPr rtlCol="0" anchor="ctr" wrap="square" lIns="76200" rIns="76200" tIns="38100" bIns="38100"/>
+          <a:bodyPr wrap="square" lIns="76200" tIns="38100" rIns="76200" bIns="38100" rtlCol="0" anchor="ctr"/>
           <a:lstStyle/>
           <a:p>
             <a:pPr algn="ctr">
@@ -8847,6 +10327,7 @@
           <a:lstStyle/>
           <a:p>
             <a:pPr algn="ctr"/>
+            <a:endParaRPr/>
           </a:p>
         </p:txBody>
       </p:sp>
@@ -8867,7 +10348,7 @@
           <a:noFill/>
         </p:spPr>
         <p:txBody>
-          <a:bodyPr wrap="square" anchor="t" lIns="0" rIns="0" tIns="0" bIns="0">
+          <a:bodyPr wrap="square" lIns="0" tIns="0" rIns="0" bIns="0" anchor="t">
             <a:spAutoFit/>
           </a:bodyPr>
           <a:lstStyle/>
@@ -8933,7 +10414,7 @@
           </a:fontRef>
         </p:style>
         <p:txBody>
-          <a:bodyPr rtlCol="0" anchor="ctr" wrap="square" lIns="76200" rIns="76200" tIns="38100" bIns="38100"/>
+          <a:bodyPr wrap="square" lIns="76200" tIns="38100" rIns="76200" bIns="38100" rtlCol="0" anchor="ctr"/>
           <a:lstStyle/>
           <a:p>
             <a:pPr algn="ctr">
@@ -8973,7 +10454,7 @@
           <a:noFill/>
         </p:spPr>
         <p:txBody>
-          <a:bodyPr wrap="square" anchor="t" lIns="0" rIns="0" tIns="0" bIns="0">
+          <a:bodyPr wrap="square" lIns="0" tIns="0" rIns="0" bIns="0" anchor="t">
             <a:spAutoFit/>
           </a:bodyPr>
           <a:lstStyle/>
@@ -9039,7 +10520,7 @@
           </a:fontRef>
         </p:style>
         <p:txBody>
-          <a:bodyPr rtlCol="0" anchor="ctr" wrap="square" lIns="76200" rIns="76200" tIns="38100" bIns="38100"/>
+          <a:bodyPr wrap="square" lIns="76200" tIns="38100" rIns="76200" bIns="38100" rtlCol="0" anchor="ctr"/>
           <a:lstStyle/>
           <a:p>
             <a:pPr algn="ctr">
@@ -9103,6 +10584,7 @@
           <a:lstStyle/>
           <a:p>
             <a:pPr algn="ctr"/>
+            <a:endParaRPr/>
           </a:p>
         </p:txBody>
       </p:sp>
@@ -9123,7 +10605,7 @@
           <a:noFill/>
         </p:spPr>
         <p:txBody>
-          <a:bodyPr wrap="square" anchor="t" lIns="0" rIns="0" tIns="0" bIns="0">
+          <a:bodyPr wrap="square" lIns="0" tIns="0" rIns="0" bIns="0" anchor="t">
             <a:spAutoFit/>
           </a:bodyPr>
           <a:lstStyle/>
@@ -9189,7 +10671,7 @@
           </a:fontRef>
         </p:style>
         <p:txBody>
-          <a:bodyPr rtlCol="0" anchor="ctr" wrap="square" lIns="76200" rIns="76200" tIns="38100" bIns="38100"/>
+          <a:bodyPr wrap="square" lIns="76200" tIns="38100" rIns="76200" bIns="38100" rtlCol="0" anchor="ctr"/>
           <a:lstStyle/>
           <a:p>
             <a:pPr algn="ctr">
@@ -9257,6 +10739,7 @@
           <a:lstStyle/>
           <a:p>
             <a:pPr algn="ctr"/>
+            <a:endParaRPr/>
           </a:p>
         </p:txBody>
       </p:sp>
@@ -9303,6 +10786,7 @@
           <a:lstStyle/>
           <a:p>
             <a:pPr algn="ctr"/>
+            <a:endParaRPr/>
           </a:p>
         </p:txBody>
       </p:sp>
@@ -9347,6 +10831,7 @@
           <a:lstStyle/>
           <a:p>
             <a:pPr algn="ctr"/>
+            <a:endParaRPr/>
           </a:p>
         </p:txBody>
       </p:sp>
@@ -9391,6 +10876,7 @@
           <a:lstStyle/>
           <a:p>
             <a:pPr algn="ctr"/>
+            <a:endParaRPr/>
           </a:p>
         </p:txBody>
       </p:sp>
@@ -9411,7 +10897,7 @@
           <a:noFill/>
         </p:spPr>
         <p:txBody>
-          <a:bodyPr wrap="square" anchor="ctr" lIns="0" rIns="0" tIns="0" bIns="0">
+          <a:bodyPr wrap="square" lIns="0" tIns="0" rIns="0" bIns="0" anchor="ctr">
             <a:spAutoFit/>
           </a:bodyPr>
           <a:lstStyle/>
@@ -9453,7 +10939,7 @@
           <a:noFill/>
         </p:spPr>
         <p:txBody>
-          <a:bodyPr wrap="square" anchor="t" lIns="0" rIns="0" tIns="0" bIns="0">
+          <a:bodyPr wrap="square" lIns="0" tIns="0" rIns="0" bIns="0" anchor="t">
             <a:spAutoFit/>
           </a:bodyPr>
           <a:lstStyle/>
@@ -9519,7 +11005,7 @@
           </a:fontRef>
         </p:style>
         <p:txBody>
-          <a:bodyPr rtlCol="0" anchor="ctr" wrap="square" lIns="76200" rIns="76200" tIns="38100" bIns="38100"/>
+          <a:bodyPr wrap="square" lIns="76200" tIns="38100" rIns="76200" bIns="38100" rtlCol="0" anchor="ctr"/>
           <a:lstStyle/>
           <a:p>
             <a:pPr algn="ctr">
@@ -9583,6 +11069,7 @@
           <a:lstStyle/>
           <a:p>
             <a:pPr algn="ctr"/>
+            <a:endParaRPr/>
           </a:p>
         </p:txBody>
       </p:sp>
@@ -9603,7 +11090,7 @@
           <a:noFill/>
         </p:spPr>
         <p:txBody>
-          <a:bodyPr wrap="square" anchor="t" lIns="0" rIns="0" tIns="0" bIns="0">
+          <a:bodyPr wrap="square" lIns="0" tIns="0" rIns="0" bIns="0" anchor="t">
             <a:spAutoFit/>
           </a:bodyPr>
           <a:lstStyle/>
@@ -9669,7 +11156,7 @@
           </a:fontRef>
         </p:style>
         <p:txBody>
-          <a:bodyPr rtlCol="0" anchor="ctr" wrap="square" lIns="76200" rIns="76200" tIns="38100" bIns="38100"/>
+          <a:bodyPr wrap="square" lIns="76200" tIns="38100" rIns="76200" bIns="38100" rtlCol="0" anchor="ctr"/>
           <a:lstStyle/>
           <a:p>
             <a:pPr algn="ctr">
@@ -9709,7 +11196,7 @@
           <a:noFill/>
         </p:spPr>
         <p:txBody>
-          <a:bodyPr wrap="square" anchor="t" lIns="0" rIns="0" tIns="0" bIns="0">
+          <a:bodyPr wrap="square" lIns="0" tIns="0" rIns="0" bIns="0" anchor="t">
             <a:spAutoFit/>
           </a:bodyPr>
           <a:lstStyle/>
@@ -9775,7 +11262,7 @@
           </a:fontRef>
         </p:style>
         <p:txBody>
-          <a:bodyPr rtlCol="0" anchor="ctr" wrap="square" lIns="76200" rIns="76200" tIns="38100" bIns="38100"/>
+          <a:bodyPr wrap="square" lIns="76200" tIns="38100" rIns="76200" bIns="38100" rtlCol="0" anchor="ctr"/>
           <a:lstStyle/>
           <a:p>
             <a:pPr algn="ctr">
@@ -9839,6 +11326,7 @@
           <a:lstStyle/>
           <a:p>
             <a:pPr algn="ctr"/>
+            <a:endParaRPr/>
           </a:p>
         </p:txBody>
       </p:sp>
@@ -9859,7 +11347,7 @@
           <a:noFill/>
         </p:spPr>
         <p:txBody>
-          <a:bodyPr wrap="square" anchor="t" lIns="0" rIns="0" tIns="0" bIns="0">
+          <a:bodyPr wrap="square" lIns="0" tIns="0" rIns="0" bIns="0" anchor="t">
             <a:spAutoFit/>
           </a:bodyPr>
           <a:lstStyle/>
@@ -9925,7 +11413,7 @@
           </a:fontRef>
         </p:style>
         <p:txBody>
-          <a:bodyPr rtlCol="0" anchor="ctr" wrap="square" lIns="76200" rIns="76200" tIns="38100" bIns="38100"/>
+          <a:bodyPr wrap="square" lIns="76200" tIns="38100" rIns="76200" bIns="38100" rtlCol="0" anchor="ctr"/>
           <a:lstStyle/>
           <a:p>
             <a:pPr algn="ctr">
@@ -9965,7 +11453,7 @@
           <a:noFill/>
         </p:spPr>
         <p:txBody>
-          <a:bodyPr wrap="square" anchor="t" lIns="0" rIns="0" tIns="0" bIns="0">
+          <a:bodyPr wrap="square" lIns="0" tIns="0" rIns="0" bIns="0" anchor="t">
             <a:spAutoFit/>
           </a:bodyPr>
           <a:lstStyle/>
@@ -10031,7 +11519,7 @@
           </a:fontRef>
         </p:style>
         <p:txBody>
-          <a:bodyPr rtlCol="0" anchor="ctr" wrap="square" lIns="76200" rIns="76200" tIns="38100" bIns="38100"/>
+          <a:bodyPr wrap="square" lIns="76200" tIns="38100" rIns="76200" bIns="38100" rtlCol="0" anchor="ctr"/>
           <a:lstStyle/>
           <a:p>
             <a:pPr algn="ctr">
@@ -10095,6 +11583,7 @@
           <a:lstStyle/>
           <a:p>
             <a:pPr algn="ctr"/>
+            <a:endParaRPr/>
           </a:p>
         </p:txBody>
       </p:sp>
@@ -10115,7 +11604,7 @@
           <a:noFill/>
         </p:spPr>
         <p:txBody>
-          <a:bodyPr wrap="square" anchor="t" lIns="0" rIns="0" tIns="0" bIns="0">
+          <a:bodyPr wrap="square" lIns="0" tIns="0" rIns="0" bIns="0" anchor="t">
             <a:spAutoFit/>
           </a:bodyPr>
           <a:lstStyle/>
@@ -10181,7 +11670,7 @@
           </a:fontRef>
         </p:style>
         <p:txBody>
-          <a:bodyPr rtlCol="0" anchor="ctr" wrap="square" lIns="76200" rIns="76200" tIns="38100" bIns="38100"/>
+          <a:bodyPr wrap="square" lIns="76200" tIns="38100" rIns="76200" bIns="38100" rtlCol="0" anchor="ctr"/>
           <a:lstStyle/>
           <a:p>
             <a:pPr algn="ctr">
@@ -10221,7 +11710,7 @@
           <a:noFill/>
         </p:spPr>
         <p:txBody>
-          <a:bodyPr wrap="square" anchor="t" lIns="0" rIns="0" tIns="0" bIns="0">
+          <a:bodyPr wrap="square" lIns="0" tIns="0" rIns="0" bIns="0" anchor="t">
             <a:spAutoFit/>
           </a:bodyPr>
           <a:lstStyle/>
@@ -10362,6 +11851,7 @@
           <a:lstStyle/>
           <a:p>
             <a:pPr algn="ctr"/>
+            <a:endParaRPr/>
           </a:p>
         </p:txBody>
       </p:sp>
@@ -10382,7 +11872,7 @@
           <a:noFill/>
         </p:spPr>
         <p:txBody>
-          <a:bodyPr wrap="square" anchor="t" lIns="0" rIns="0" tIns="0" bIns="0">
+          <a:bodyPr wrap="square" lIns="0" tIns="0" rIns="0" bIns="0" anchor="t">
             <a:spAutoFit/>
           </a:bodyPr>
           <a:lstStyle/>
@@ -10433,7 +11923,7 @@
           <a:noFill/>
         </p:spPr>
         <p:txBody>
-          <a:bodyPr wrap="square" anchor="t" lIns="0" rIns="0" tIns="0" bIns="0">
+          <a:bodyPr wrap="square" lIns="0" tIns="0" rIns="0" bIns="0" anchor="t">
             <a:spAutoFit/>
           </a:bodyPr>
           <a:lstStyle/>
@@ -10467,7 +11957,7 @@
 </file>
 
 <file path=ppt/slides/slide6.xml><?xml version="1.0" encoding="utf-8"?>
-<p:sld xmlns:a="http://schemas.openxmlformats.org/drawingml/2006/main" xmlns:p="http://schemas.openxmlformats.org/presentationml/2006/main" xmlns:r="http://schemas.openxmlformats.org/officeDocument/2006/relationships">
+<p:sld xmlns:a="http://schemas.openxmlformats.org/drawingml/2006/main" xmlns:r="http://schemas.openxmlformats.org/officeDocument/2006/relationships" xmlns:p="http://schemas.openxmlformats.org/presentationml/2006/main">
   <p:cSld>
     <p:bg>
       <p:bgPr>
@@ -10483,7 +11973,14 @@
         <p:cNvGrpSpPr/>
         <p:nvPr/>
       </p:nvGrpSpPr>
-      <p:grpSpPr/>
+      <p:grpSpPr>
+        <a:xfrm>
+          <a:off x="0" y="0"/>
+          <a:ext cx="0" cy="0"/>
+          <a:chOff x="0" y="0"/>
+          <a:chExt cx="0" cy="0"/>
+        </a:xfrm>
+      </p:grpSpPr>
       <p:sp>
         <p:nvSpPr>
           <p:cNvPr id="2" name="TextBox 1"/>
@@ -10501,7 +11998,7 @@
           <a:noFill/>
         </p:spPr>
         <p:txBody>
-          <a:bodyPr wrap="square" anchor="t" lIns="0" rIns="0" tIns="0" bIns="0">
+          <a:bodyPr wrap="square" lIns="0" tIns="0" rIns="0" bIns="0" anchor="t">
             <a:spAutoFit/>
           </a:bodyPr>
           <a:lstStyle/>
@@ -10543,7 +12040,7 @@
           <a:noFill/>
         </p:spPr>
         <p:txBody>
-          <a:bodyPr wrap="square" anchor="t" lIns="0" rIns="0" tIns="0" bIns="0">
+          <a:bodyPr wrap="square" lIns="0" tIns="0" rIns="0" bIns="0" anchor="t">
             <a:spAutoFit/>
           </a:bodyPr>
           <a:lstStyle/>
@@ -10633,7 +12130,7 @@
           </a:fontRef>
         </p:style>
         <p:txBody>
-          <a:bodyPr rtlCol="0" anchor="ctr" wrap="square" lIns="76200" rIns="76200" tIns="38100" bIns="38100"/>
+          <a:bodyPr wrap="square" lIns="76200" tIns="38100" rIns="76200" bIns="38100" rtlCol="0" anchor="ctr"/>
           <a:lstStyle/>
           <a:p>
             <a:pPr algn="ctr">
@@ -10700,6 +12197,7 @@
           <a:lstStyle/>
           <a:p>
             <a:pPr algn="ctr"/>
+            <a:endParaRPr/>
           </a:p>
         </p:txBody>
       </p:sp>
@@ -10744,7 +12242,7 @@
           </a:fontRef>
         </p:style>
         <p:txBody>
-          <a:bodyPr rtlCol="0" anchor="ctr" wrap="square" lIns="76200" rIns="76200" tIns="38100" bIns="38100"/>
+          <a:bodyPr wrap="square" lIns="76200" tIns="38100" rIns="76200" bIns="38100" rtlCol="0" anchor="ctr"/>
           <a:lstStyle/>
           <a:p>
             <a:pPr algn="ctr">
@@ -10811,6 +12309,7 @@
           <a:lstStyle/>
           <a:p>
             <a:pPr algn="ctr"/>
+            <a:endParaRPr/>
           </a:p>
         </p:txBody>
       </p:sp>
@@ -10855,7 +12354,7 @@
           </a:fontRef>
         </p:style>
         <p:txBody>
-          <a:bodyPr rtlCol="0" anchor="ctr" wrap="square" lIns="76200" rIns="76200" tIns="38100" bIns="38100"/>
+          <a:bodyPr wrap="square" lIns="76200" tIns="38100" rIns="76200" bIns="38100" rtlCol="0" anchor="ctr"/>
           <a:lstStyle/>
           <a:p>
             <a:pPr algn="ctr">
@@ -10922,6 +12421,7 @@
           <a:lstStyle/>
           <a:p>
             <a:pPr algn="ctr"/>
+            <a:endParaRPr/>
           </a:p>
         </p:txBody>
       </p:sp>
@@ -10966,7 +12466,7 @@
           </a:fontRef>
         </p:style>
         <p:txBody>
-          <a:bodyPr rtlCol="0" anchor="ctr" wrap="square" lIns="76200" rIns="76200" tIns="38100" bIns="38100"/>
+          <a:bodyPr wrap="square" lIns="76200" tIns="38100" rIns="76200" bIns="38100" rtlCol="0" anchor="ctr"/>
           <a:lstStyle/>
           <a:p>
             <a:pPr algn="ctr">
@@ -11033,6 +12533,7 @@
           <a:lstStyle/>
           <a:p>
             <a:pPr algn="ctr"/>
+            <a:endParaRPr/>
           </a:p>
         </p:txBody>
       </p:sp>
@@ -11077,7 +12578,7 @@
           </a:fontRef>
         </p:style>
         <p:txBody>
-          <a:bodyPr rtlCol="0" anchor="ctr" wrap="square" lIns="76200" rIns="76200" tIns="38100" bIns="38100"/>
+          <a:bodyPr wrap="square" lIns="76200" tIns="38100" rIns="76200" bIns="38100" rtlCol="0" anchor="ctr"/>
           <a:lstStyle/>
           <a:p>
             <a:pPr algn="ctr">
@@ -11117,7 +12618,7 @@
           <a:noFill/>
         </p:spPr>
         <p:txBody>
-          <a:bodyPr wrap="square" anchor="t" lIns="0" rIns="0" tIns="0" bIns="0">
+          <a:bodyPr wrap="square" lIns="0" tIns="0" rIns="0" bIns="0" anchor="t">
             <a:spAutoFit/>
           </a:bodyPr>
           <a:lstStyle/>
@@ -11187,6 +12688,7 @@
           <a:lstStyle/>
           <a:p>
             <a:pPr algn="ctr"/>
+            <a:endParaRPr/>
           </a:p>
         </p:txBody>
       </p:sp>
@@ -11231,6 +12733,7 @@
           <a:lstStyle/>
           <a:p>
             <a:pPr algn="ctr"/>
+            <a:endParaRPr/>
           </a:p>
         </p:txBody>
       </p:sp>
@@ -11251,7 +12754,7 @@
           <a:noFill/>
         </p:spPr>
         <p:txBody>
-          <a:bodyPr wrap="square" anchor="t" lIns="0" rIns="0" tIns="0" bIns="0">
+          <a:bodyPr wrap="square" lIns="0" tIns="0" rIns="0" bIns="0" anchor="t">
             <a:spAutoFit/>
           </a:bodyPr>
           <a:lstStyle/>
@@ -11293,7 +12796,7 @@
           <a:noFill/>
         </p:spPr>
         <p:txBody>
-          <a:bodyPr wrap="square" anchor="t" lIns="0" rIns="0" tIns="0" bIns="0">
+          <a:bodyPr wrap="square" lIns="0" tIns="0" rIns="0" bIns="0" anchor="t">
             <a:spAutoFit/>
           </a:bodyPr>
           <a:lstStyle/>
@@ -11437,6 +12940,7 @@
           <a:lstStyle/>
           <a:p>
             <a:pPr algn="ctr"/>
+            <a:endParaRPr/>
           </a:p>
         </p:txBody>
       </p:sp>
@@ -11481,6 +12985,7 @@
           <a:lstStyle/>
           <a:p>
             <a:pPr algn="ctr"/>
+            <a:endParaRPr/>
           </a:p>
         </p:txBody>
       </p:sp>
@@ -11501,7 +13006,7 @@
           <a:noFill/>
         </p:spPr>
         <p:txBody>
-          <a:bodyPr wrap="square" anchor="t" lIns="0" rIns="0" tIns="0" bIns="0">
+          <a:bodyPr wrap="square" lIns="0" tIns="0" rIns="0" bIns="0" anchor="t">
             <a:spAutoFit/>
           </a:bodyPr>
           <a:lstStyle/>
@@ -11543,7 +13048,7 @@
           <a:noFill/>
         </p:spPr>
         <p:txBody>
-          <a:bodyPr wrap="square" anchor="t" lIns="0" rIns="0" tIns="0" bIns="0">
+          <a:bodyPr wrap="square" lIns="0" tIns="0" rIns="0" bIns="0" anchor="t">
             <a:spAutoFit/>
           </a:bodyPr>
           <a:lstStyle/>
@@ -11687,6 +13192,7 @@
           <a:lstStyle/>
           <a:p>
             <a:pPr algn="ctr"/>
+            <a:endParaRPr/>
           </a:p>
         </p:txBody>
       </p:sp>
@@ -11731,6 +13237,7 @@
           <a:lstStyle/>
           <a:p>
             <a:pPr algn="ctr"/>
+            <a:endParaRPr/>
           </a:p>
         </p:txBody>
       </p:sp>
@@ -11751,7 +13258,7 @@
           <a:noFill/>
         </p:spPr>
         <p:txBody>
-          <a:bodyPr wrap="square" anchor="t" lIns="0" rIns="0" tIns="0" bIns="0">
+          <a:bodyPr wrap="square" lIns="0" tIns="0" rIns="0" bIns="0" anchor="t">
             <a:spAutoFit/>
           </a:bodyPr>
           <a:lstStyle/>
@@ -11793,7 +13300,7 @@
           <a:noFill/>
         </p:spPr>
         <p:txBody>
-          <a:bodyPr wrap="square" anchor="t" lIns="0" rIns="0" tIns="0" bIns="0">
+          <a:bodyPr wrap="square" lIns="0" tIns="0" rIns="0" bIns="0" anchor="t">
             <a:spAutoFit/>
           </a:bodyPr>
           <a:lstStyle/>
@@ -11933,6 +13440,7 @@
           <a:lstStyle/>
           <a:p>
             <a:pPr algn="ctr"/>
+            <a:endParaRPr/>
           </a:p>
         </p:txBody>
       </p:sp>
@@ -11953,7 +13461,7 @@
           <a:noFill/>
         </p:spPr>
         <p:txBody>
-          <a:bodyPr wrap="square" anchor="t" lIns="0" rIns="0" tIns="0" bIns="0">
+          <a:bodyPr wrap="square" lIns="0" tIns="0" rIns="0" bIns="0" anchor="t">
             <a:spAutoFit/>
           </a:bodyPr>
           <a:lstStyle/>
@@ -12004,7 +13512,7 @@
           <a:noFill/>
         </p:spPr>
         <p:txBody>
-          <a:bodyPr wrap="square" anchor="t" lIns="0" rIns="0" tIns="0" bIns="0">
+          <a:bodyPr wrap="square" lIns="0" tIns="0" rIns="0" bIns="0" anchor="t">
             <a:spAutoFit/>
           </a:bodyPr>
           <a:lstStyle/>
@@ -12038,7 +13546,7 @@
 </file>
 
 <file path=ppt/slides/slide7.xml><?xml version="1.0" encoding="utf-8"?>
-<p:sld xmlns:a="http://schemas.openxmlformats.org/drawingml/2006/main" xmlns:p="http://schemas.openxmlformats.org/presentationml/2006/main" xmlns:r="http://schemas.openxmlformats.org/officeDocument/2006/relationships">
+<p:sld xmlns:a="http://schemas.openxmlformats.org/drawingml/2006/main" xmlns:r="http://schemas.openxmlformats.org/officeDocument/2006/relationships" xmlns:p="http://schemas.openxmlformats.org/presentationml/2006/main">
   <p:cSld>
     <p:bg>
       <p:bgPr>
@@ -12054,7 +13562,14 @@
         <p:cNvGrpSpPr/>
         <p:nvPr/>
       </p:nvGrpSpPr>
-      <p:grpSpPr/>
+      <p:grpSpPr>
+        <a:xfrm>
+          <a:off x="0" y="0"/>
+          <a:ext cx="0" cy="0"/>
+          <a:chOff x="0" y="0"/>
+          <a:chExt cx="0" cy="0"/>
+        </a:xfrm>
+      </p:grpSpPr>
       <p:sp>
         <p:nvSpPr>
           <p:cNvPr id="2" name="TextBox 1"/>
@@ -12072,7 +13587,7 @@
           <a:noFill/>
         </p:spPr>
         <p:txBody>
-          <a:bodyPr wrap="square" anchor="t" lIns="0" rIns="0" tIns="0" bIns="0">
+          <a:bodyPr wrap="square" lIns="0" tIns="0" rIns="0" bIns="0" anchor="t">
             <a:spAutoFit/>
           </a:bodyPr>
           <a:lstStyle/>
@@ -12114,7 +13629,7 @@
           <a:noFill/>
         </p:spPr>
         <p:txBody>
-          <a:bodyPr wrap="square" anchor="t" lIns="0" rIns="0" tIns="0" bIns="0">
+          <a:bodyPr wrap="square" lIns="0" tIns="0" rIns="0" bIns="0" anchor="t">
             <a:spAutoFit/>
           </a:bodyPr>
           <a:lstStyle/>
@@ -12208,6 +13723,7 @@
           <a:lstStyle/>
           <a:p>
             <a:pPr algn="ctr"/>
+            <a:endParaRPr/>
           </a:p>
         </p:txBody>
       </p:sp>
@@ -12252,6 +13768,7 @@
           <a:lstStyle/>
           <a:p>
             <a:pPr algn="ctr"/>
+            <a:endParaRPr/>
           </a:p>
         </p:txBody>
       </p:sp>
@@ -12272,7 +13789,7 @@
           <a:noFill/>
         </p:spPr>
         <p:txBody>
-          <a:bodyPr wrap="square" anchor="t" lIns="0" rIns="0" tIns="0" bIns="0">
+          <a:bodyPr wrap="square" lIns="0" tIns="0" rIns="0" bIns="0" anchor="t">
             <a:spAutoFit/>
           </a:bodyPr>
           <a:lstStyle/>
@@ -12378,7 +13895,7 @@
           </a:fontRef>
         </p:style>
         <p:txBody>
-          <a:bodyPr rtlCol="0" anchor="ctr" wrap="square" lIns="76200" rIns="76200" tIns="38100" bIns="38100"/>
+          <a:bodyPr wrap="square" lIns="76200" tIns="38100" rIns="76200" bIns="38100" rtlCol="0" anchor="ctr"/>
           <a:lstStyle/>
           <a:p>
             <a:pPr algn="ctr">
@@ -12445,6 +13962,7 @@
           <a:lstStyle/>
           <a:p>
             <a:pPr algn="ctr"/>
+            <a:endParaRPr/>
           </a:p>
         </p:txBody>
       </p:sp>
@@ -12489,7 +14007,7 @@
           </a:fontRef>
         </p:style>
         <p:txBody>
-          <a:bodyPr rtlCol="0" anchor="ctr" wrap="square" lIns="76200" rIns="76200" tIns="38100" bIns="38100"/>
+          <a:bodyPr wrap="square" lIns="76200" tIns="38100" rIns="76200" bIns="38100" rtlCol="0" anchor="ctr"/>
           <a:lstStyle/>
           <a:p>
             <a:pPr algn="ctr">
@@ -12556,6 +14074,7 @@
           <a:lstStyle/>
           <a:p>
             <a:pPr algn="ctr"/>
+            <a:endParaRPr/>
           </a:p>
         </p:txBody>
       </p:sp>
@@ -12600,7 +14119,7 @@
           </a:fontRef>
         </p:style>
         <p:txBody>
-          <a:bodyPr rtlCol="0" anchor="ctr" wrap="square" lIns="76200" rIns="76200" tIns="38100" bIns="38100"/>
+          <a:bodyPr wrap="square" lIns="76200" tIns="38100" rIns="76200" bIns="38100" rtlCol="0" anchor="ctr"/>
           <a:lstStyle/>
           <a:p>
             <a:pPr algn="ctr">
@@ -12667,6 +14186,7 @@
           <a:lstStyle/>
           <a:p>
             <a:pPr algn="ctr"/>
+            <a:endParaRPr/>
           </a:p>
         </p:txBody>
       </p:sp>
@@ -12711,7 +14231,7 @@
           </a:fontRef>
         </p:style>
         <p:txBody>
-          <a:bodyPr rtlCol="0" anchor="ctr" wrap="square" lIns="76200" rIns="76200" tIns="38100" bIns="38100"/>
+          <a:bodyPr wrap="square" lIns="76200" tIns="38100" rIns="76200" bIns="38100" rtlCol="0" anchor="ctr"/>
           <a:lstStyle/>
           <a:p>
             <a:pPr algn="ctr">
@@ -12778,6 +14298,7 @@
           <a:lstStyle/>
           <a:p>
             <a:pPr algn="ctr"/>
+            <a:endParaRPr/>
           </a:p>
         </p:txBody>
       </p:sp>
@@ -12822,7 +14343,7 @@
           </a:fontRef>
         </p:style>
         <p:txBody>
-          <a:bodyPr rtlCol="0" anchor="ctr" wrap="square" lIns="76200" rIns="76200" tIns="38100" bIns="38100"/>
+          <a:bodyPr wrap="square" lIns="76200" tIns="38100" rIns="76200" bIns="38100" rtlCol="0" anchor="ctr"/>
           <a:lstStyle/>
           <a:p>
             <a:pPr algn="ctr">
@@ -12890,6 +14411,7 @@
           <a:lstStyle/>
           <a:p>
             <a:pPr algn="ctr"/>
+            <a:endParaRPr/>
           </a:p>
         </p:txBody>
       </p:sp>
@@ -12934,6 +14456,7 @@
           <a:lstStyle/>
           <a:p>
             <a:pPr algn="ctr"/>
+            <a:endParaRPr/>
           </a:p>
         </p:txBody>
       </p:sp>
@@ -12954,7 +14477,7 @@
           <a:noFill/>
         </p:spPr>
         <p:txBody>
-          <a:bodyPr wrap="square" anchor="t" lIns="0" rIns="0" tIns="0" bIns="0">
+          <a:bodyPr wrap="square" lIns="0" tIns="0" rIns="0" bIns="0" anchor="t">
             <a:spAutoFit/>
           </a:bodyPr>
           <a:lstStyle/>
@@ -12996,7 +14519,7 @@
           <a:noFill/>
         </p:spPr>
         <p:txBody>
-          <a:bodyPr wrap="square" anchor="t" lIns="0" rIns="0" tIns="0" bIns="0">
+          <a:bodyPr wrap="square" lIns="0" tIns="0" rIns="0" bIns="0" anchor="t">
             <a:spAutoFit/>
           </a:bodyPr>
           <a:lstStyle/>
@@ -13140,6 +14663,7 @@
           <a:lstStyle/>
           <a:p>
             <a:pPr algn="ctr"/>
+            <a:endParaRPr/>
           </a:p>
         </p:txBody>
       </p:sp>
@@ -13184,6 +14708,7 @@
           <a:lstStyle/>
           <a:p>
             <a:pPr algn="ctr"/>
+            <a:endParaRPr/>
           </a:p>
         </p:txBody>
       </p:sp>
@@ -13204,7 +14729,7 @@
           <a:noFill/>
         </p:spPr>
         <p:txBody>
-          <a:bodyPr wrap="square" anchor="t" lIns="0" rIns="0" tIns="0" bIns="0">
+          <a:bodyPr wrap="square" lIns="0" tIns="0" rIns="0" bIns="0" anchor="t">
             <a:spAutoFit/>
           </a:bodyPr>
           <a:lstStyle/>
@@ -13246,7 +14771,7 @@
           <a:noFill/>
         </p:spPr>
         <p:txBody>
-          <a:bodyPr wrap="square" anchor="t" lIns="0" rIns="0" tIns="0" bIns="0">
+          <a:bodyPr wrap="square" lIns="0" tIns="0" rIns="0" bIns="0" anchor="t">
             <a:spAutoFit/>
           </a:bodyPr>
           <a:lstStyle/>
@@ -13362,7 +14887,7 @@
           <a:noFill/>
         </p:spPr>
         <p:txBody>
-          <a:bodyPr wrap="square" anchor="t" lIns="0" rIns="0" tIns="0" bIns="0">
+          <a:bodyPr wrap="square" lIns="0" tIns="0" rIns="0" bIns="0" anchor="t">
             <a:spAutoFit/>
           </a:bodyPr>
           <a:lstStyle/>
@@ -13428,6 +14953,7 @@
           <a:lstStyle/>
           <a:p>
             <a:pPr algn="ctr"/>
+            <a:endParaRPr/>
           </a:p>
         </p:txBody>
       </p:sp>
@@ -13448,7 +14974,7 @@
           <a:noFill/>
         </p:spPr>
         <p:txBody>
-          <a:bodyPr wrap="square" anchor="t" lIns="0" rIns="0" tIns="0" bIns="0">
+          <a:bodyPr wrap="square" lIns="0" tIns="0" rIns="0" bIns="0" anchor="t">
             <a:spAutoFit/>
           </a:bodyPr>
           <a:lstStyle/>
@@ -13499,7 +15025,7 @@
           <a:noFill/>
         </p:spPr>
         <p:txBody>
-          <a:bodyPr wrap="square" anchor="t" lIns="0" rIns="0" tIns="0" bIns="0">
+          <a:bodyPr wrap="square" lIns="0" tIns="0" rIns="0" bIns="0" anchor="t">
             <a:spAutoFit/>
           </a:bodyPr>
           <a:lstStyle/>
@@ -13533,7 +15059,7 @@
 </file>
 
 <file path=ppt/slides/slide8.xml><?xml version="1.0" encoding="utf-8"?>
-<p:sld xmlns:a="http://schemas.openxmlformats.org/drawingml/2006/main" xmlns:p="http://schemas.openxmlformats.org/presentationml/2006/main" xmlns:r="http://schemas.openxmlformats.org/officeDocument/2006/relationships">
+<p:sld xmlns:a="http://schemas.openxmlformats.org/drawingml/2006/main" xmlns:r="http://schemas.openxmlformats.org/officeDocument/2006/relationships" xmlns:p="http://schemas.openxmlformats.org/presentationml/2006/main">
   <p:cSld>
     <p:bg>
       <p:bgPr>
@@ -13549,7 +15075,14 @@
         <p:cNvGrpSpPr/>
         <p:nvPr/>
       </p:nvGrpSpPr>
-      <p:grpSpPr/>
+      <p:grpSpPr>
+        <a:xfrm>
+          <a:off x="0" y="0"/>
+          <a:ext cx="0" cy="0"/>
+          <a:chOff x="0" y="0"/>
+          <a:chExt cx="0" cy="0"/>
+        </a:xfrm>
+      </p:grpSpPr>
       <p:sp>
         <p:nvSpPr>
           <p:cNvPr id="2" name="TextBox 1"/>
@@ -13567,7 +15100,7 @@
           <a:noFill/>
         </p:spPr>
         <p:txBody>
-          <a:bodyPr wrap="square" anchor="t" lIns="0" rIns="0" tIns="0" bIns="0">
+          <a:bodyPr wrap="square" lIns="0" tIns="0" rIns="0" bIns="0" anchor="t">
             <a:spAutoFit/>
           </a:bodyPr>
           <a:lstStyle/>
@@ -13609,7 +15142,7 @@
           <a:noFill/>
         </p:spPr>
         <p:txBody>
-          <a:bodyPr wrap="square" anchor="t" lIns="0" rIns="0" tIns="0" bIns="0">
+          <a:bodyPr wrap="square" lIns="0" tIns="0" rIns="0" bIns="0" anchor="t">
             <a:spAutoFit/>
           </a:bodyPr>
           <a:lstStyle/>
@@ -13703,6 +15236,7 @@
           <a:lstStyle/>
           <a:p>
             <a:pPr algn="ctr"/>
+            <a:endParaRPr/>
           </a:p>
         </p:txBody>
       </p:sp>
@@ -13747,6 +15281,7 @@
           <a:lstStyle/>
           <a:p>
             <a:pPr algn="ctr"/>
+            <a:endParaRPr/>
           </a:p>
         </p:txBody>
       </p:sp>
@@ -13767,7 +15302,7 @@
           <a:noFill/>
         </p:spPr>
         <p:txBody>
-          <a:bodyPr wrap="square" anchor="t" lIns="0" rIns="0" tIns="0" bIns="0">
+          <a:bodyPr wrap="square" lIns="0" tIns="0" rIns="0" bIns="0" anchor="t">
             <a:spAutoFit/>
           </a:bodyPr>
           <a:lstStyle/>
@@ -13809,7 +15344,7 @@
           <a:noFill/>
         </p:spPr>
         <p:txBody>
-          <a:bodyPr wrap="square" anchor="t" lIns="0" rIns="0" tIns="0" bIns="0">
+          <a:bodyPr wrap="square" lIns="0" tIns="0" rIns="0" bIns="0" anchor="t">
             <a:spAutoFit/>
           </a:bodyPr>
           <a:lstStyle/>
@@ -13882,6 +15417,7 @@
           <a:lstStyle/>
           <a:p>
             <a:pPr algn="ctr"/>
+            <a:endParaRPr/>
           </a:p>
         </p:txBody>
       </p:sp>
@@ -13926,6 +15462,7 @@
           <a:lstStyle/>
           <a:p>
             <a:pPr algn="ctr"/>
+            <a:endParaRPr/>
           </a:p>
         </p:txBody>
       </p:sp>
@@ -13946,7 +15483,7 @@
           <a:noFill/>
         </p:spPr>
         <p:txBody>
-          <a:bodyPr wrap="square" anchor="t" lIns="0" rIns="0" tIns="0" bIns="0">
+          <a:bodyPr wrap="square" lIns="0" tIns="0" rIns="0" bIns="0" anchor="t">
             <a:spAutoFit/>
           </a:bodyPr>
           <a:lstStyle/>
@@ -13997,7 +15534,7 @@
           <a:noFill/>
         </p:spPr>
         <p:txBody>
-          <a:bodyPr wrap="square" anchor="t" lIns="0" rIns="0" tIns="0" bIns="0">
+          <a:bodyPr wrap="square" lIns="0" tIns="0" rIns="0" bIns="0" anchor="t">
             <a:spAutoFit/>
           </a:bodyPr>
           <a:lstStyle/>
@@ -14070,6 +15607,7 @@
           <a:lstStyle/>
           <a:p>
             <a:pPr algn="ctr"/>
+            <a:endParaRPr/>
           </a:p>
         </p:txBody>
       </p:sp>
@@ -14114,6 +15652,7 @@
           <a:lstStyle/>
           <a:p>
             <a:pPr algn="ctr"/>
+            <a:endParaRPr/>
           </a:p>
         </p:txBody>
       </p:sp>
@@ -14134,7 +15673,7 @@
           <a:noFill/>
         </p:spPr>
         <p:txBody>
-          <a:bodyPr wrap="square" anchor="t" lIns="0" rIns="0" tIns="0" bIns="0">
+          <a:bodyPr wrap="square" lIns="0" tIns="0" rIns="0" bIns="0" anchor="t">
             <a:spAutoFit/>
           </a:bodyPr>
           <a:lstStyle/>
@@ -14176,7 +15715,7 @@
           <a:noFill/>
         </p:spPr>
         <p:txBody>
-          <a:bodyPr wrap="square" anchor="t" lIns="0" rIns="0" tIns="0" bIns="0">
+          <a:bodyPr wrap="square" lIns="0" tIns="0" rIns="0" bIns="0" anchor="t">
             <a:spAutoFit/>
           </a:bodyPr>
           <a:lstStyle/>
@@ -14249,6 +15788,7 @@
           <a:lstStyle/>
           <a:p>
             <a:pPr algn="ctr"/>
+            <a:endParaRPr/>
           </a:p>
         </p:txBody>
       </p:sp>
@@ -14293,6 +15833,7 @@
           <a:lstStyle/>
           <a:p>
             <a:pPr algn="ctr"/>
+            <a:endParaRPr/>
           </a:p>
         </p:txBody>
       </p:sp>
@@ -14313,7 +15854,7 @@
           <a:noFill/>
         </p:spPr>
         <p:txBody>
-          <a:bodyPr wrap="square" anchor="t" lIns="0" rIns="0" tIns="0" bIns="0">
+          <a:bodyPr wrap="square" lIns="0" tIns="0" rIns="0" bIns="0" anchor="t">
             <a:spAutoFit/>
           </a:bodyPr>
           <a:lstStyle/>
@@ -14355,7 +15896,7 @@
           <a:noFill/>
         </p:spPr>
         <p:txBody>
-          <a:bodyPr wrap="square" anchor="t" lIns="0" rIns="0" tIns="0" bIns="0">
+          <a:bodyPr wrap="square" lIns="0" tIns="0" rIns="0" bIns="0" anchor="t">
             <a:spAutoFit/>
           </a:bodyPr>
           <a:lstStyle/>
@@ -14428,6 +15969,7 @@
           <a:lstStyle/>
           <a:p>
             <a:pPr algn="ctr"/>
+            <a:endParaRPr/>
           </a:p>
         </p:txBody>
       </p:sp>
@@ -14472,6 +16014,7 @@
           <a:lstStyle/>
           <a:p>
             <a:pPr algn="ctr"/>
+            <a:endParaRPr/>
           </a:p>
         </p:txBody>
       </p:sp>
@@ -14492,7 +16035,7 @@
           <a:noFill/>
         </p:spPr>
         <p:txBody>
-          <a:bodyPr wrap="square" anchor="t" lIns="0" rIns="0" tIns="0" bIns="0">
+          <a:bodyPr wrap="square" lIns="0" tIns="0" rIns="0" bIns="0" anchor="t">
             <a:spAutoFit/>
           </a:bodyPr>
           <a:lstStyle/>
@@ -14534,7 +16077,7 @@
           <a:noFill/>
         </p:spPr>
         <p:txBody>
-          <a:bodyPr wrap="square" anchor="t" lIns="0" rIns="0" tIns="0" bIns="0">
+          <a:bodyPr wrap="square" lIns="0" tIns="0" rIns="0" bIns="0" anchor="t">
             <a:spAutoFit/>
           </a:bodyPr>
           <a:lstStyle/>
@@ -14697,6 +16240,7 @@
           <a:lstStyle/>
           <a:p>
             <a:pPr algn="ctr"/>
+            <a:endParaRPr/>
           </a:p>
         </p:txBody>
       </p:sp>
@@ -14741,6 +16285,7 @@
           <a:lstStyle/>
           <a:p>
             <a:pPr algn="ctr"/>
+            <a:endParaRPr/>
           </a:p>
         </p:txBody>
       </p:sp>
@@ -14761,7 +16306,7 @@
           <a:noFill/>
         </p:spPr>
         <p:txBody>
-          <a:bodyPr wrap="square" anchor="t" lIns="0" rIns="0" tIns="0" bIns="0">
+          <a:bodyPr wrap="square" lIns="0" tIns="0" rIns="0" bIns="0" anchor="t">
             <a:spAutoFit/>
           </a:bodyPr>
           <a:lstStyle/>
@@ -14803,7 +16348,7 @@
           <a:noFill/>
         </p:spPr>
         <p:txBody>
-          <a:bodyPr wrap="square" anchor="t" lIns="0" rIns="0" tIns="0" bIns="0">
+          <a:bodyPr wrap="square" lIns="0" tIns="0" rIns="0" bIns="0" anchor="t">
             <a:spAutoFit/>
           </a:bodyPr>
           <a:lstStyle/>
@@ -14938,7 +16483,7 @@
           <a:noFill/>
         </p:spPr>
         <p:txBody>
-          <a:bodyPr wrap="square" anchor="t" lIns="0" rIns="0" tIns="0" bIns="0">
+          <a:bodyPr wrap="square" lIns="0" tIns="0" rIns="0" bIns="0" anchor="t">
             <a:spAutoFit/>
           </a:bodyPr>
           <a:lstStyle/>
@@ -15022,6 +16567,7 @@
           <a:lstStyle/>
           <a:p>
             <a:pPr algn="ctr"/>
+            <a:endParaRPr/>
           </a:p>
         </p:txBody>
       </p:sp>
@@ -15042,7 +16588,7 @@
           <a:noFill/>
         </p:spPr>
         <p:txBody>
-          <a:bodyPr wrap="square" anchor="t" lIns="0" rIns="0" tIns="0" bIns="0">
+          <a:bodyPr wrap="square" lIns="0" tIns="0" rIns="0" bIns="0" anchor="t">
             <a:spAutoFit/>
           </a:bodyPr>
           <a:lstStyle/>
@@ -15093,7 +16639,7 @@
           <a:noFill/>
         </p:spPr>
         <p:txBody>
-          <a:bodyPr wrap="square" anchor="t" lIns="0" rIns="0" tIns="0" bIns="0">
+          <a:bodyPr wrap="square" lIns="0" tIns="0" rIns="0" bIns="0" anchor="t">
             <a:spAutoFit/>
           </a:bodyPr>
           <a:lstStyle/>
@@ -15127,7 +16673,7 @@
 </file>
 
 <file path=ppt/slides/slide9.xml><?xml version="1.0" encoding="utf-8"?>
-<p:sld xmlns:a="http://schemas.openxmlformats.org/drawingml/2006/main" xmlns:p="http://schemas.openxmlformats.org/presentationml/2006/main" xmlns:r="http://schemas.openxmlformats.org/officeDocument/2006/relationships">
+<p:sld xmlns:a="http://schemas.openxmlformats.org/drawingml/2006/main" xmlns:r="http://schemas.openxmlformats.org/officeDocument/2006/relationships" xmlns:p="http://schemas.openxmlformats.org/presentationml/2006/main">
   <p:cSld>
     <p:bg>
       <p:bgPr>
@@ -15143,7 +16689,14 @@
         <p:cNvGrpSpPr/>
         <p:nvPr/>
       </p:nvGrpSpPr>
-      <p:grpSpPr/>
+      <p:grpSpPr>
+        <a:xfrm>
+          <a:off x="0" y="0"/>
+          <a:ext cx="0" cy="0"/>
+          <a:chOff x="0" y="0"/>
+          <a:chExt cx="0" cy="0"/>
+        </a:xfrm>
+      </p:grpSpPr>
       <p:sp>
         <p:nvSpPr>
           <p:cNvPr id="2" name="TextBox 1"/>
@@ -15161,7 +16714,7 @@
           <a:noFill/>
         </p:spPr>
         <p:txBody>
-          <a:bodyPr wrap="square" anchor="t" lIns="0" rIns="0" tIns="0" bIns="0">
+          <a:bodyPr wrap="square" lIns="0" tIns="0" rIns="0" bIns="0" anchor="t">
             <a:spAutoFit/>
           </a:bodyPr>
           <a:lstStyle/>
@@ -15203,7 +16756,7 @@
           <a:noFill/>
         </p:spPr>
         <p:txBody>
-          <a:bodyPr wrap="square" anchor="t" lIns="0" rIns="0" tIns="0" bIns="0">
+          <a:bodyPr wrap="square" lIns="0" tIns="0" rIns="0" bIns="0" anchor="t">
             <a:spAutoFit/>
           </a:bodyPr>
           <a:lstStyle/>
@@ -15297,6 +16850,7 @@
           <a:lstStyle/>
           <a:p>
             <a:pPr algn="ctr"/>
+            <a:endParaRPr/>
           </a:p>
         </p:txBody>
       </p:sp>
@@ -15341,6 +16895,7 @@
           <a:lstStyle/>
           <a:p>
             <a:pPr algn="ctr"/>
+            <a:endParaRPr/>
           </a:p>
         </p:txBody>
       </p:sp>
@@ -15361,7 +16916,7 @@
           <a:noFill/>
         </p:spPr>
         <p:txBody>
-          <a:bodyPr wrap="square" anchor="t" lIns="0" rIns="0" tIns="0" bIns="0">
+          <a:bodyPr wrap="square" lIns="0" tIns="0" rIns="0" bIns="0" anchor="t">
             <a:spAutoFit/>
           </a:bodyPr>
           <a:lstStyle/>
@@ -15406,7 +16961,7 @@
           <a:noFill/>
         </p:spPr>
         <p:txBody>
-          <a:bodyPr wrap="square" anchor="t" lIns="0" rIns="0" tIns="0" bIns="0">
+          <a:bodyPr wrap="square" lIns="0" tIns="0" rIns="0" bIns="0" anchor="t">
             <a:spAutoFit/>
           </a:bodyPr>
           <a:lstStyle/>
@@ -15479,6 +17034,7 @@
           <a:lstStyle/>
           <a:p>
             <a:pPr algn="ctr"/>
+            <a:endParaRPr/>
           </a:p>
         </p:txBody>
       </p:sp>
@@ -15523,6 +17079,7 @@
           <a:lstStyle/>
           <a:p>
             <a:pPr algn="ctr"/>
+            <a:endParaRPr/>
           </a:p>
         </p:txBody>
       </p:sp>
@@ -15543,7 +17100,7 @@
           <a:noFill/>
         </p:spPr>
         <p:txBody>
-          <a:bodyPr wrap="square" anchor="t" lIns="0" rIns="0" tIns="0" bIns="0">
+          <a:bodyPr wrap="square" lIns="0" tIns="0" rIns="0" bIns="0" anchor="t">
             <a:spAutoFit/>
           </a:bodyPr>
           <a:lstStyle/>
@@ -15588,7 +17145,7 @@
           <a:noFill/>
         </p:spPr>
         <p:txBody>
-          <a:bodyPr wrap="square" anchor="t" lIns="0" rIns="0" tIns="0" bIns="0">
+          <a:bodyPr wrap="square" lIns="0" tIns="0" rIns="0" bIns="0" anchor="t">
             <a:spAutoFit/>
           </a:bodyPr>
           <a:lstStyle/>
@@ -15661,6 +17218,7 @@
           <a:lstStyle/>
           <a:p>
             <a:pPr algn="ctr"/>
+            <a:endParaRPr/>
           </a:p>
         </p:txBody>
       </p:sp>
@@ -15705,6 +17263,7 @@
           <a:lstStyle/>
           <a:p>
             <a:pPr algn="ctr"/>
+            <a:endParaRPr/>
           </a:p>
         </p:txBody>
       </p:sp>
@@ -15725,7 +17284,7 @@
           <a:noFill/>
         </p:spPr>
         <p:txBody>
-          <a:bodyPr wrap="square" anchor="t" lIns="0" rIns="0" tIns="0" bIns="0">
+          <a:bodyPr wrap="square" lIns="0" tIns="0" rIns="0" bIns="0" anchor="t">
             <a:spAutoFit/>
           </a:bodyPr>
           <a:lstStyle/>
@@ -15770,7 +17329,7 @@
           <a:noFill/>
         </p:spPr>
         <p:txBody>
-          <a:bodyPr wrap="square" anchor="t" lIns="0" rIns="0" tIns="0" bIns="0">
+          <a:bodyPr wrap="square" lIns="0" tIns="0" rIns="0" bIns="0" anchor="t">
             <a:spAutoFit/>
           </a:bodyPr>
           <a:lstStyle/>
@@ -15843,6 +17402,7 @@
           <a:lstStyle/>
           <a:p>
             <a:pPr algn="ctr"/>
+            <a:endParaRPr/>
           </a:p>
         </p:txBody>
       </p:sp>
@@ -15887,6 +17447,7 @@
           <a:lstStyle/>
           <a:p>
             <a:pPr algn="ctr"/>
+            <a:endParaRPr/>
           </a:p>
         </p:txBody>
       </p:sp>
@@ -15907,7 +17468,7 @@
           <a:noFill/>
         </p:spPr>
         <p:txBody>
-          <a:bodyPr wrap="square" anchor="t" lIns="0" rIns="0" tIns="0" bIns="0">
+          <a:bodyPr wrap="square" lIns="0" tIns="0" rIns="0" bIns="0" anchor="t">
             <a:spAutoFit/>
           </a:bodyPr>
           <a:lstStyle/>
@@ -15952,7 +17513,7 @@
           <a:noFill/>
         </p:spPr>
         <p:txBody>
-          <a:bodyPr wrap="square" anchor="t" lIns="0" rIns="0" tIns="0" bIns="0">
+          <a:bodyPr wrap="square" lIns="0" tIns="0" rIns="0" bIns="0" anchor="t">
             <a:spAutoFit/>
           </a:bodyPr>
           <a:lstStyle/>
@@ -16025,6 +17586,7 @@
           <a:lstStyle/>
           <a:p>
             <a:pPr algn="ctr"/>
+            <a:endParaRPr/>
           </a:p>
         </p:txBody>
       </p:sp>
@@ -16069,6 +17631,7 @@
           <a:lstStyle/>
           <a:p>
             <a:pPr algn="ctr"/>
+            <a:endParaRPr/>
           </a:p>
         </p:txBody>
       </p:sp>
@@ -16089,7 +17652,7 @@
           <a:noFill/>
         </p:spPr>
         <p:txBody>
-          <a:bodyPr wrap="square" anchor="t" lIns="0" rIns="0" tIns="0" bIns="0">
+          <a:bodyPr wrap="square" lIns="0" tIns="0" rIns="0" bIns="0" anchor="t">
             <a:spAutoFit/>
           </a:bodyPr>
           <a:lstStyle/>
@@ -16134,7 +17697,7 @@
           <a:noFill/>
         </p:spPr>
         <p:txBody>
-          <a:bodyPr wrap="square" anchor="t" lIns="0" rIns="0" tIns="0" bIns="0">
+          <a:bodyPr wrap="square" lIns="0" tIns="0" rIns="0" bIns="0" anchor="t">
             <a:spAutoFit/>
           </a:bodyPr>
           <a:lstStyle/>
@@ -16205,6 +17768,7 @@
           <a:lstStyle/>
           <a:p>
             <a:pPr algn="ctr"/>
+            <a:endParaRPr/>
           </a:p>
         </p:txBody>
       </p:sp>
@@ -16225,7 +17789,7 @@
           <a:noFill/>
         </p:spPr>
         <p:txBody>
-          <a:bodyPr wrap="square" anchor="t" lIns="0" rIns="0" tIns="0" bIns="0">
+          <a:bodyPr wrap="square" lIns="0" tIns="0" rIns="0" bIns="0" anchor="t">
             <a:spAutoFit/>
           </a:bodyPr>
           <a:lstStyle/>
@@ -16331,6 +17895,7 @@
           <a:lstStyle/>
           <a:p>
             <a:pPr algn="ctr"/>
+            <a:endParaRPr/>
           </a:p>
         </p:txBody>
       </p:sp>
@@ -16351,7 +17916,7 @@
           <a:noFill/>
         </p:spPr>
         <p:txBody>
-          <a:bodyPr wrap="square" anchor="t" lIns="0" rIns="0" tIns="0" bIns="0">
+          <a:bodyPr wrap="square" lIns="0" tIns="0" rIns="0" bIns="0" anchor="t">
             <a:spAutoFit/>
           </a:bodyPr>
           <a:lstStyle/>
@@ -16402,7 +17967,7 @@
           <a:noFill/>
         </p:spPr>
         <p:txBody>
-          <a:bodyPr wrap="square" anchor="t" lIns="0" rIns="0" tIns="0" bIns="0">
+          <a:bodyPr wrap="square" lIns="0" tIns="0" rIns="0" bIns="0" anchor="t">
             <a:spAutoFit/>
           </a:bodyPr>
           <a:lstStyle/>

</xml_diff>